<commit_message>
docs: show all abstract reflection memories
</commit_message>
<xml_diff>
--- a/docs/记忆能让Agent越跑越好吗-V3.pptx
+++ b/docs/记忆能让Agent越跑越好吗-V3.pptx
@@ -12724,7 +12724,7 @@
                 <a:ea typeface="Microsoft YaHei" pitchFamily="34" charset="-122"/>
                 <a:cs typeface="Microsoft YaHei" pitchFamily="34" charset="-120"/>
               </a:rPr>
-              <a:t>规则看起来合理，但集中在拆分和格式，无法指出自己整类漏掉的内容。</a:t>
+              <a:t>4 轮运行后，consolidation 形成一份包含 15 条规则的 canonical Memory。</a:t>
             </a:r>
             <a:endParaRPr lang="en-US" sz="1400" dirty="0"/>
           </a:p>
@@ -12738,12 +12738,12 @@
         </p:nvSpPr>
         <p:spPr>
           <a:xfrm>
-            <a:off x="566928" y="1691640"/>
-            <a:ext cx="6492240" cy="3611880"/>
+            <a:off x="566928" y="1572768"/>
+            <a:ext cx="3529584" cy="3730752"/>
           </a:xfrm>
           <a:prstGeom prst="roundRect">
             <a:avLst>
-              <a:gd name="adj" fmla="val 2025"/>
+              <a:gd name="adj" fmla="val 2073"/>
             </a:avLst>
           </a:prstGeom>
           <a:solidFill>
@@ -12765,8 +12765,8 @@
         </p:nvSpPr>
         <p:spPr>
           <a:xfrm>
-            <a:off x="749808" y="1819656"/>
-            <a:ext cx="6126480" cy="256032"/>
+            <a:off x="768096" y="1709928"/>
+            <a:ext cx="3127248" cy="256032"/>
           </a:xfrm>
           <a:prstGeom prst="rect">
             <a:avLst/>
@@ -12784,13 +12784,13 @@
             <a:r>
               <a:rPr lang="en-US" sz="1150" b="1" dirty="0">
                 <a:solidFill>
-                  <a:srgbClr val="FF6A3D"/>
+                  <a:srgbClr val="42B4FF"/>
                 </a:solidFill>
                 <a:latin typeface="Amazon Ember Display" pitchFamily="34" charset="0"/>
                 <a:ea typeface="Amazon Ember Display" pitchFamily="34" charset="-122"/>
                 <a:cs typeface="Amazon Ember Display" pitchFamily="34" charset="-120"/>
               </a:rPr>
-              <a:t>真实 Memory（节选）</a:t>
+              <a:t>规则 1–5</a:t>
             </a:r>
             <a:endParaRPr lang="en-US" sz="1150" dirty="0"/>
           </a:p>
@@ -12798,41 +12798,14 @@
       </p:sp>
       <p:sp>
         <p:nvSpPr>
-          <p:cNvPr id="10" name="Shape 7"/>
-          <p:cNvSpPr/>
-          <p:nvPr/>
-        </p:nvSpPr>
-        <p:spPr>
-          <a:xfrm>
-            <a:off x="749808" y="2148840"/>
-            <a:ext cx="6126480" cy="2999232"/>
-          </a:xfrm>
-          <a:prstGeom prst="roundRect">
-            <a:avLst>
-              <a:gd name="adj" fmla="val 2439"/>
-            </a:avLst>
-          </a:prstGeom>
-          <a:solidFill>
-            <a:srgbClr val="0B1220"/>
-          </a:solidFill>
-          <a:ln w="10160">
-            <a:solidFill>
-              <a:srgbClr val="2E3B57"/>
-            </a:solidFill>
-            <a:prstDash val="solid"/>
-          </a:ln>
-        </p:spPr>
-      </p:sp>
-      <p:sp>
-        <p:nvSpPr>
-          <p:cNvPr id="11" name="Text 8"/>
-          <p:cNvSpPr/>
-          <p:nvPr/>
-        </p:nvSpPr>
-        <p:spPr>
-          <a:xfrm>
-            <a:off x="859536" y="2221992"/>
-            <a:ext cx="5907024" cy="2862072"/>
+          <p:cNvPr id="10" name="Text 7"/>
+          <p:cNvSpPr/>
+          <p:nvPr/>
+        </p:nvSpPr>
+        <p:spPr>
+          <a:xfrm>
+            <a:off x="768096" y="2057400"/>
+            <a:ext cx="3127248" cy="3118104"/>
           </a:xfrm>
           <a:prstGeom prst="rect">
             <a:avLst/>
@@ -12848,248 +12821,30 @@
               <a:buNone/>
             </a:pPr>
             <a:r>
-              <a:rPr lang="en-US" sz="1150" dirty="0">
-                <a:solidFill>
-                  <a:srgbClr val="CFD9E4"/>
-                </a:solidFill>
-                <a:latin typeface="Amazon Ember Mono" pitchFamily="34" charset="0"/>
-                <a:ea typeface="Amazon Ember Mono" pitchFamily="34" charset="-122"/>
-                <a:cs typeface="Amazon Ember Mono" pitchFamily="34" charset="-120"/>
-              </a:rPr>
-              <a:t>5. 多部件拆分规则：</a:t>
-            </a:r>
-            <a:endParaRPr lang="en-US" sz="1150" dirty="0"/>
-          </a:p>
-          <a:p>
-            <a:pPr indent="0" marL="0">
-              <a:buNone/>
-            </a:pPr>
-            <a:r>
-              <a:rPr lang="en-US" sz="1150" dirty="0">
-                <a:solidFill>
-                  <a:srgbClr val="CFD9E4"/>
-                </a:solidFill>
-                <a:latin typeface="Amazon Ember Mono" pitchFamily="34" charset="0"/>
-                <a:ea typeface="Amazon Ember Mono" pitchFamily="34" charset="-122"/>
-                <a:cs typeface="Amazon Ember Mono" pitchFamily="34" charset="-120"/>
-              </a:rPr>
-              <a:t>   一条原文描述多个部件时逐条拆分。</a:t>
-            </a:r>
-            <a:endParaRPr lang="en-US" sz="1150" dirty="0"/>
-          </a:p>
-          <a:p>
-            <a:pPr indent="0" marL="0">
-              <a:buNone/>
-            </a:pPr>
-            <a:endParaRPr lang="en-US" sz="1150" dirty="0"/>
-          </a:p>
-          <a:p>
-            <a:pPr indent="0" marL="0">
-              <a:buNone/>
-            </a:pPr>
-            <a:r>
-              <a:rPr lang="en-US" sz="1150" dirty="0">
-                <a:solidFill>
-                  <a:srgbClr val="CFD9E4"/>
-                </a:solidFill>
-                <a:latin typeface="Amazon Ember Mono" pitchFamily="34" charset="0"/>
-                <a:ea typeface="Amazon Ember Mono" pitchFamily="34" charset="-122"/>
-                <a:cs typeface="Amazon Ember Mono" pitchFamily="34" charset="-120"/>
-              </a:rPr>
-              <a:t>6. 复合指标拆分规则：</a:t>
-            </a:r>
-            <a:endParaRPr lang="en-US" sz="1150" dirty="0"/>
-          </a:p>
-          <a:p>
-            <a:pPr indent="0" marL="0">
-              <a:buNone/>
-            </a:pPr>
-            <a:r>
-              <a:rPr lang="en-US" sz="1150" dirty="0">
-                <a:solidFill>
-                  <a:srgbClr val="CFD9E4"/>
-                </a:solidFill>
-                <a:latin typeface="Amazon Ember Mono" pitchFamily="34" charset="0"/>
-                <a:ea typeface="Amazon Ember Mono" pitchFamily="34" charset="-122"/>
-                <a:cs typeface="Amazon Ember Mono" pitchFamily="34" charset="-120"/>
-              </a:rPr>
-              <a:t>   同一原文含多个指标时按指标名称拆分。</a:t>
-            </a:r>
-            <a:endParaRPr lang="en-US" sz="1150" dirty="0"/>
-          </a:p>
-          <a:p>
-            <a:pPr indent="0" marL="0">
-              <a:buNone/>
-            </a:pPr>
-            <a:endParaRPr lang="en-US" sz="1150" dirty="0"/>
-          </a:p>
-          <a:p>
-            <a:pPr indent="0" marL="0">
-              <a:buNone/>
-            </a:pPr>
-            <a:r>
-              <a:rPr lang="en-US" sz="1150" dirty="0">
-                <a:solidFill>
-                  <a:srgbClr val="CFD9E4"/>
-                </a:solidFill>
-                <a:latin typeface="Amazon Ember Mono" pitchFamily="34" charset="0"/>
-                <a:ea typeface="Amazon Ember Mono" pitchFamily="34" charset="-122"/>
-                <a:cs typeface="Amazon Ember Mono" pitchFamily="34" charset="-120"/>
-              </a:rPr>
-              <a:t>9. 阀门/仪表清单抽取规则：</a:t>
-            </a:r>
-            <a:endParaRPr lang="en-US" sz="1150" dirty="0"/>
-          </a:p>
-          <a:p>
-            <a:pPr indent="0" marL="0">
-              <a:buNone/>
-            </a:pPr>
-            <a:r>
-              <a:rPr lang="en-US" sz="1150" dirty="0">
-                <a:solidFill>
-                  <a:srgbClr val="CFD9E4"/>
-                </a:solidFill>
-                <a:latin typeface="Amazon Ember Mono" pitchFamily="34" charset="0"/>
-                <a:ea typeface="Amazon Ember Mono" pitchFamily="34" charset="-122"/>
-                <a:cs typeface="Amazon Ember Mono" pitchFamily="34" charset="-120"/>
-              </a:rPr>
-              <a:t>   规格与数量分别生成独立记录。</a:t>
-            </a:r>
-            <a:endParaRPr lang="en-US" sz="1150" dirty="0"/>
-          </a:p>
-        </p:txBody>
-      </p:sp>
-      <p:sp>
-        <p:nvSpPr>
-          <p:cNvPr id="12" name="Shape 9"/>
-          <p:cNvSpPr/>
-          <p:nvPr/>
-        </p:nvSpPr>
-        <p:spPr>
-          <a:xfrm>
-            <a:off x="7333488" y="1691640"/>
-            <a:ext cx="4297680" cy="1664208"/>
-          </a:xfrm>
-          <a:prstGeom prst="roundRect">
-            <a:avLst>
-              <a:gd name="adj" fmla="val 4396"/>
-            </a:avLst>
-          </a:prstGeom>
-          <a:solidFill>
-            <a:srgbClr val="35181C"/>
-          </a:solidFill>
-          <a:ln w="10160">
-            <a:solidFill>
-              <a:srgbClr val="2E3B57"/>
-            </a:solidFill>
-            <a:prstDash val="solid"/>
-          </a:ln>
-        </p:spPr>
-      </p:sp>
-      <p:sp>
-        <p:nvSpPr>
-          <p:cNvPr id="13" name="Text 10"/>
-          <p:cNvSpPr/>
-          <p:nvPr/>
-        </p:nvSpPr>
-        <p:spPr>
-          <a:xfrm>
-            <a:off x="7534656" y="1828800"/>
-            <a:ext cx="3895344" cy="256032"/>
-          </a:xfrm>
-          <a:prstGeom prst="rect">
-            <a:avLst/>
-          </a:prstGeom>
-          <a:noFill/>
-          <a:ln/>
-        </p:spPr>
-        <p:txBody>
-          <a:bodyPr wrap="square" lIns="0" tIns="0" rIns="0" bIns="0" rtlCol="0" anchor="ctr"/>
-          <a:lstStyle/>
-          <a:p>
-            <a:pPr indent="0" marL="0">
-              <a:buNone/>
-            </a:pPr>
-            <a:r>
-              <a:rPr lang="en-US" sz="1150" b="1" dirty="0">
-                <a:solidFill>
-                  <a:srgbClr val="FF6A3D"/>
-                </a:solidFill>
-                <a:latin typeface="Amazon Ember Display" pitchFamily="34" charset="0"/>
-                <a:ea typeface="Amazon Ember Display" pitchFamily="34" charset="-122"/>
-                <a:cs typeface="Amazon Ember Display" pitchFamily="34" charset="-120"/>
-              </a:rPr>
-              <a:t>观察</a:t>
-            </a:r>
-            <a:endParaRPr lang="en-US" sz="1150" dirty="0"/>
-          </a:p>
-        </p:txBody>
-      </p:sp>
-      <p:sp>
-        <p:nvSpPr>
-          <p:cNvPr id="14" name="Text 11"/>
-          <p:cNvSpPr/>
-          <p:nvPr/>
-        </p:nvSpPr>
-        <p:spPr>
-          <a:xfrm>
-            <a:off x="7534656" y="2176272"/>
-            <a:ext cx="3895344" cy="384048"/>
-          </a:xfrm>
-          <a:prstGeom prst="rect">
-            <a:avLst/>
-          </a:prstGeom>
-          <a:noFill/>
-          <a:ln/>
-        </p:spPr>
-        <p:txBody>
-          <a:bodyPr wrap="square" lIns="0" tIns="0" rIns="0" bIns="0" rtlCol="0" anchor="ctr"/>
-          <a:lstStyle/>
-          <a:p>
-            <a:pPr indent="0" marL="0">
-              <a:buNone/>
-            </a:pPr>
-            <a:r>
-              <a:rPr lang="en-US" sz="1700" b="1" dirty="0">
-                <a:solidFill>
-                  <a:srgbClr val="FFFFFF"/>
+              <a:rPr lang="en-US" sz="1050" dirty="0">
+                <a:solidFill>
+                  <a:srgbClr val="CFD9E4"/>
                 </a:solidFill>
                 <a:latin typeface="Microsoft YaHei" pitchFamily="34" charset="0"/>
                 <a:ea typeface="Microsoft YaHei" pitchFamily="34" charset="-122"/>
                 <a:cs typeface="Microsoft YaHei" pitchFamily="34" charset="-120"/>
               </a:rPr>
-              <a:t>规则越来越多</a:t>
-            </a:r>
-            <a:endParaRPr lang="en-US" sz="1700" dirty="0"/>
-          </a:p>
-        </p:txBody>
-      </p:sp>
-      <p:sp>
-        <p:nvSpPr>
-          <p:cNvPr id="15" name="Text 12"/>
-          <p:cNvSpPr/>
-          <p:nvPr/>
-        </p:nvSpPr>
-        <p:spPr>
-          <a:xfrm>
-            <a:off x="7534656" y="2633472"/>
-            <a:ext cx="3895344" cy="594360"/>
-          </a:xfrm>
-          <a:prstGeom prst="rect">
-            <a:avLst/>
-          </a:prstGeom>
-          <a:noFill/>
-          <a:ln/>
-        </p:spPr>
-        <p:txBody>
-          <a:bodyPr wrap="square" lIns="0" tIns="0" rIns="0" bIns="0" rtlCol="0" anchor="t"/>
-          <a:lstStyle/>
-          <a:p>
-            <a:pPr indent="0" marL="0">
-              <a:buNone/>
-            </a:pPr>
-            <a:r>
-              <a:rPr lang="en-US" sz="1400" dirty="0">
+              <a:t>1. 设备主体识别：标题/首段的“容量+介质+设备类型”作为主体，全文统一。</a:t>
+            </a:r>
+            <a:endParaRPr lang="en-US" sz="1050" dirty="0"/>
+          </a:p>
+          <a:p>
+            <a:pPr indent="0" marL="0">
+              <a:buNone/>
+            </a:pPr>
+            <a:endParaRPr lang="en-US" sz="1050" dirty="0"/>
+          </a:p>
+          <a:p>
+            <a:pPr indent="0" marL="0">
+              <a:buNone/>
+            </a:pPr>
+            <a:r>
+              <a:rPr lang="en-US" sz="1050" dirty="0">
                 <a:solidFill>
                   <a:srgbClr val="CFD9E4"/>
                 </a:solidFill>
@@ -13097,26 +12852,95 @@
                 <a:ea typeface="Microsoft YaHei" pitchFamily="34" charset="-122"/>
                 <a:cs typeface="Microsoft YaHei" pitchFamily="34" charset="-120"/>
               </a:rPr>
-              <a:t>但没有观察到稳定的覆盖改善。</a:t>
-            </a:r>
-            <a:endParaRPr lang="en-US" sz="1400" dirty="0"/>
-          </a:p>
-        </p:txBody>
-      </p:sp>
-      <p:sp>
-        <p:nvSpPr>
-          <p:cNvPr id="16" name="Shape 13"/>
-          <p:cNvSpPr/>
-          <p:nvPr/>
-        </p:nvSpPr>
-        <p:spPr>
-          <a:xfrm>
-            <a:off x="7333488" y="3566160"/>
-            <a:ext cx="4297680" cy="1737360"/>
+              <a:t>2. 整体性能归属：介质、容积、压力、温度、绝热等归“储罐整体”。</a:t>
+            </a:r>
+            <a:endParaRPr lang="en-US" sz="1050" dirty="0"/>
+          </a:p>
+          <a:p>
+            <a:pPr indent="0" marL="0">
+              <a:buNone/>
+            </a:pPr>
+            <a:endParaRPr lang="en-US" sz="1050" dirty="0"/>
+          </a:p>
+          <a:p>
+            <a:pPr indent="0" marL="0">
+              <a:buNone/>
+            </a:pPr>
+            <a:r>
+              <a:rPr lang="en-US" sz="1050" dirty="0">
+                <a:solidFill>
+                  <a:srgbClr val="CFD9E4"/>
+                </a:solidFill>
+                <a:latin typeface="Microsoft YaHei" pitchFamily="34" charset="0"/>
+                <a:ea typeface="Microsoft YaHei" pitchFamily="34" charset="-122"/>
+                <a:cs typeface="Microsoft YaHei" pitchFamily="34" charset="-120"/>
+              </a:rPr>
+              <a:t>3. 运输/交货独立：封存压力、气体、露点、封堵状态独立成条。</a:t>
+            </a:r>
+            <a:endParaRPr lang="en-US" sz="1050" dirty="0"/>
+          </a:p>
+          <a:p>
+            <a:pPr indent="0" marL="0">
+              <a:buNone/>
+            </a:pPr>
+            <a:endParaRPr lang="en-US" sz="1050" dirty="0"/>
+          </a:p>
+          <a:p>
+            <a:pPr indent="0" marL="0">
+              <a:buNone/>
+            </a:pPr>
+            <a:r>
+              <a:rPr lang="en-US" sz="1050" dirty="0">
+                <a:solidFill>
+                  <a:srgbClr val="CFD9E4"/>
+                </a:solidFill>
+                <a:latin typeface="Microsoft YaHei" pitchFamily="34" charset="0"/>
+                <a:ea typeface="Microsoft YaHei" pitchFamily="34" charset="-122"/>
+                <a:cs typeface="Microsoft YaHei" pitchFamily="34" charset="-120"/>
+              </a:rPr>
+              <a:t>4. 子系统/附件独立：增压器、安全装置、仪表、阀门、管口单独成部件。</a:t>
+            </a:r>
+            <a:endParaRPr lang="en-US" sz="1050" dirty="0"/>
+          </a:p>
+          <a:p>
+            <a:pPr indent="0" marL="0">
+              <a:buNone/>
+            </a:pPr>
+            <a:endParaRPr lang="en-US" sz="1050" dirty="0"/>
+          </a:p>
+          <a:p>
+            <a:pPr indent="0" marL="0">
+              <a:buNone/>
+            </a:pPr>
+            <a:r>
+              <a:rPr lang="en-US" sz="1050" dirty="0">
+                <a:solidFill>
+                  <a:srgbClr val="CFD9E4"/>
+                </a:solidFill>
+                <a:latin typeface="Microsoft YaHei" pitchFamily="34" charset="0"/>
+                <a:ea typeface="Microsoft YaHei" pitchFamily="34" charset="-122"/>
+                <a:cs typeface="Microsoft YaHei" pitchFamily="34" charset="-120"/>
+              </a:rPr>
+              <a:t>5. 多部件拆分：同句多个部件按部件拆分，保留完整原文。</a:t>
+            </a:r>
+            <a:endParaRPr lang="en-US" sz="1050" dirty="0"/>
+          </a:p>
+        </p:txBody>
+      </p:sp>
+      <p:sp>
+        <p:nvSpPr>
+          <p:cNvPr id="11" name="Shape 8"/>
+          <p:cNvSpPr/>
+          <p:nvPr/>
+        </p:nvSpPr>
+        <p:spPr>
+          <a:xfrm>
+            <a:off x="4334256" y="1572768"/>
+            <a:ext cx="3529584" cy="3730752"/>
           </a:xfrm>
           <a:prstGeom prst="roundRect">
             <a:avLst>
-              <a:gd name="adj" fmla="val 4211"/>
+              <a:gd name="adj" fmla="val 2073"/>
             </a:avLst>
           </a:prstGeom>
           <a:solidFill>
@@ -13132,14 +12956,14 @@
       </p:sp>
       <p:sp>
         <p:nvSpPr>
-          <p:cNvPr id="17" name="Text 14"/>
-          <p:cNvSpPr/>
-          <p:nvPr/>
-        </p:nvSpPr>
-        <p:spPr>
-          <a:xfrm>
-            <a:off x="7534656" y="3703320"/>
-            <a:ext cx="3895344" cy="256032"/>
+          <p:cNvPr id="12" name="Text 9"/>
+          <p:cNvSpPr/>
+          <p:nvPr/>
+        </p:nvSpPr>
+        <p:spPr>
+          <a:xfrm>
+            <a:off x="4535424" y="1709928"/>
+            <a:ext cx="3127248" cy="256032"/>
           </a:xfrm>
           <a:prstGeom prst="rect">
             <a:avLst/>
@@ -13163,7 +12987,7 @@
                 <a:ea typeface="Amazon Ember Display" pitchFamily="34" charset="-122"/>
                 <a:cs typeface="Amazon Ember Display" pitchFamily="34" charset="-120"/>
               </a:rPr>
-              <a:t>副作用</a:t>
+              <a:t>规则 6–10</a:t>
             </a:r>
             <a:endParaRPr lang="en-US" sz="1150" dirty="0"/>
           </a:p>
@@ -13171,69 +12995,53 @@
       </p:sp>
       <p:sp>
         <p:nvSpPr>
-          <p:cNvPr id="18" name="Text 15"/>
-          <p:cNvSpPr/>
-          <p:nvPr/>
-        </p:nvSpPr>
-        <p:spPr>
-          <a:xfrm>
-            <a:off x="7534656" y="4050792"/>
-            <a:ext cx="3895344" cy="384048"/>
-          </a:xfrm>
-          <a:prstGeom prst="rect">
-            <a:avLst/>
-          </a:prstGeom>
-          <a:noFill/>
-          <a:ln/>
-        </p:spPr>
-        <p:txBody>
-          <a:bodyPr wrap="square" lIns="0" tIns="0" rIns="0" bIns="0" rtlCol="0" anchor="ctr"/>
-          <a:lstStyle/>
-          <a:p>
-            <a:pPr indent="0" marL="0">
-              <a:buNone/>
-            </a:pPr>
-            <a:r>
-              <a:rPr lang="en-US" sz="1700" b="1" dirty="0">
-                <a:solidFill>
-                  <a:srgbClr val="FFFFFF"/>
+          <p:cNvPr id="13" name="Text 10"/>
+          <p:cNvSpPr/>
+          <p:nvPr/>
+        </p:nvSpPr>
+        <p:spPr>
+          <a:xfrm>
+            <a:off x="4535424" y="2057400"/>
+            <a:ext cx="3127248" cy="3118104"/>
+          </a:xfrm>
+          <a:prstGeom prst="rect">
+            <a:avLst/>
+          </a:prstGeom>
+          <a:noFill/>
+          <a:ln/>
+        </p:spPr>
+        <p:txBody>
+          <a:bodyPr wrap="square" lIns="0" tIns="0" rIns="0" bIns="0" rtlCol="0" anchor="t"/>
+          <a:lstStyle/>
+          <a:p>
+            <a:pPr indent="0" marL="0">
+              <a:buNone/>
+            </a:pPr>
+            <a:r>
+              <a:rPr lang="en-US" sz="1050" dirty="0">
+                <a:solidFill>
+                  <a:srgbClr val="CFD9E4"/>
                 </a:solidFill>
                 <a:latin typeface="Microsoft YaHei" pitchFamily="34" charset="0"/>
                 <a:ea typeface="Microsoft YaHei" pitchFamily="34" charset="-122"/>
                 <a:cs typeface="Microsoft YaHei" pitchFamily="34" charset="-120"/>
               </a:rPr>
-              <a:t>容易过度拆分</a:t>
-            </a:r>
-            <a:endParaRPr lang="en-US" sz="1700" dirty="0"/>
-          </a:p>
-        </p:txBody>
-      </p:sp>
-      <p:sp>
-        <p:nvSpPr>
-          <p:cNvPr id="19" name="Text 16"/>
-          <p:cNvSpPr/>
-          <p:nvPr/>
-        </p:nvSpPr>
-        <p:spPr>
-          <a:xfrm>
-            <a:off x="7534656" y="4507992"/>
-            <a:ext cx="3895344" cy="667512"/>
-          </a:xfrm>
-          <a:prstGeom prst="rect">
-            <a:avLst/>
-          </a:prstGeom>
-          <a:noFill/>
-          <a:ln/>
-        </p:spPr>
-        <p:txBody>
-          <a:bodyPr wrap="square" lIns="0" tIns="0" rIns="0" bIns="0" rtlCol="0" anchor="t"/>
-          <a:lstStyle/>
-          <a:p>
-            <a:pPr indent="0" marL="0">
-              <a:buNone/>
-            </a:pPr>
-            <a:r>
-              <a:rPr lang="en-US" sz="1350" dirty="0">
+              <a:t>6. 复合指标拆分：通径、压力、规格、数量、备注按指标分别成条。</a:t>
+            </a:r>
+            <a:endParaRPr lang="en-US" sz="1050" dirty="0"/>
+          </a:p>
+          <a:p>
+            <a:pPr indent="0" marL="0">
+              <a:buNone/>
+            </a:pPr>
+            <a:endParaRPr lang="en-US" sz="1050" dirty="0"/>
+          </a:p>
+          <a:p>
+            <a:pPr indent="0" marL="0">
+              <a:buNone/>
+            </a:pPr>
+            <a:r>
+              <a:rPr lang="en-US" sz="1050" dirty="0">
                 <a:solidFill>
                   <a:srgbClr val="CFD9E4"/>
                 </a:solidFill>
@@ -13241,26 +13049,292 @@
                 <a:ea typeface="Microsoft YaHei" pitchFamily="34" charset="-122"/>
                 <a:cs typeface="Microsoft YaHei" pitchFamily="34" charset="-120"/>
               </a:rPr>
-              <a:t>抽取条数增加，但同一段原文被切成更多细条，粒度可能偏离任务需求。</a:t>
-            </a:r>
-            <a:endParaRPr lang="en-US" sz="1350" dirty="0"/>
-          </a:p>
-        </p:txBody>
-      </p:sp>
-      <p:sp>
-        <p:nvSpPr>
-          <p:cNvPr id="20" name="Shape 17"/>
-          <p:cNvSpPr/>
-          <p:nvPr/>
-        </p:nvSpPr>
-        <p:spPr>
-          <a:xfrm>
-            <a:off x="566928" y="5532120"/>
-            <a:ext cx="11064240" cy="777240"/>
+              <a:t>7. 指标名称规范：同义属性统一；检测拆成标准、比例、技术等级、合格级别。</a:t>
+            </a:r>
+            <a:endParaRPr lang="en-US" sz="1050" dirty="0"/>
+          </a:p>
+          <a:p>
+            <a:pPr indent="0" marL="0">
+              <a:buNone/>
+            </a:pPr>
+            <a:endParaRPr lang="en-US" sz="1050" dirty="0"/>
+          </a:p>
+          <a:p>
+            <a:pPr indent="0" marL="0">
+              <a:buNone/>
+            </a:pPr>
+            <a:r>
+              <a:rPr lang="en-US" sz="1050" dirty="0">
+                <a:solidFill>
+                  <a:srgbClr val="CFD9E4"/>
+                </a:solidFill>
+                <a:latin typeface="Microsoft YaHei" pitchFamily="34" charset="0"/>
+                <a:ea typeface="Microsoft YaHei" pitchFamily="34" charset="-122"/>
+                <a:cs typeface="Microsoft YaHei" pitchFamily="34" charset="-120"/>
+              </a:rPr>
+              <a:t>8. 管口/接口规格：保留原格式、不换算；DN 与压力等级分别抽取。</a:t>
+            </a:r>
+            <a:endParaRPr lang="en-US" sz="1050" dirty="0"/>
+          </a:p>
+          <a:p>
+            <a:pPr indent="0" marL="0">
+              <a:buNone/>
+            </a:pPr>
+            <a:endParaRPr lang="en-US" sz="1050" dirty="0"/>
+          </a:p>
+          <a:p>
+            <a:pPr indent="0" marL="0">
+              <a:buNone/>
+            </a:pPr>
+            <a:r>
+              <a:rPr lang="en-US" sz="1050" dirty="0">
+                <a:solidFill>
+                  <a:srgbClr val="CFD9E4"/>
+                </a:solidFill>
+                <a:latin typeface="Microsoft YaHei" pitchFamily="34" charset="0"/>
+                <a:ea typeface="Microsoft YaHei" pitchFamily="34" charset="-122"/>
+                <a:cs typeface="Microsoft YaHei" pitchFamily="34" charset="-120"/>
+              </a:rPr>
+              <a:t>9. 阀门/仪表清单：规格与数量分条，附加说明另生成备注。</a:t>
+            </a:r>
+            <a:endParaRPr lang="en-US" sz="1050" dirty="0"/>
+          </a:p>
+          <a:p>
+            <a:pPr indent="0" marL="0">
+              <a:buNone/>
+            </a:pPr>
+            <a:endParaRPr lang="en-US" sz="1050" dirty="0"/>
+          </a:p>
+          <a:p>
+            <a:pPr indent="0" marL="0">
+              <a:buNone/>
+            </a:pPr>
+            <a:r>
+              <a:rPr lang="en-US" sz="1050" dirty="0">
+                <a:solidFill>
+                  <a:srgbClr val="CFD9E4"/>
+                </a:solidFill>
+                <a:latin typeface="Microsoft YaHei" pitchFamily="34" charset="0"/>
+                <a:ea typeface="Microsoft YaHei" pitchFamily="34" charset="-122"/>
+                <a:cs typeface="Microsoft YaHei" pitchFamily="34" charset="-120"/>
+              </a:rPr>
+              <a:t>10. 材料分层：内罐、外罐、管道、阀门材料分别成条。</a:t>
+            </a:r>
+            <a:endParaRPr lang="en-US" sz="1050" dirty="0"/>
+          </a:p>
+        </p:txBody>
+      </p:sp>
+      <p:sp>
+        <p:nvSpPr>
+          <p:cNvPr id="14" name="Shape 11"/>
+          <p:cNvSpPr/>
+          <p:nvPr/>
+        </p:nvSpPr>
+        <p:spPr>
+          <a:xfrm>
+            <a:off x="8101584" y="1572768"/>
+            <a:ext cx="3529584" cy="3730752"/>
           </a:xfrm>
           <a:prstGeom prst="roundRect">
             <a:avLst>
-              <a:gd name="adj" fmla="val 9412"/>
+              <a:gd name="adj" fmla="val 2073"/>
+            </a:avLst>
+          </a:prstGeom>
+          <a:solidFill>
+            <a:srgbClr val="12331F"/>
+          </a:solidFill>
+          <a:ln w="10160">
+            <a:solidFill>
+              <a:srgbClr val="2E3B57"/>
+            </a:solidFill>
+            <a:prstDash val="solid"/>
+          </a:ln>
+        </p:spPr>
+      </p:sp>
+      <p:sp>
+        <p:nvSpPr>
+          <p:cNvPr id="15" name="Text 12"/>
+          <p:cNvSpPr/>
+          <p:nvPr/>
+        </p:nvSpPr>
+        <p:spPr>
+          <a:xfrm>
+            <a:off x="8302752" y="1709928"/>
+            <a:ext cx="3127248" cy="256032"/>
+          </a:xfrm>
+          <a:prstGeom prst="rect">
+            <a:avLst/>
+          </a:prstGeom>
+          <a:noFill/>
+          <a:ln/>
+        </p:spPr>
+        <p:txBody>
+          <a:bodyPr wrap="square" lIns="0" tIns="0" rIns="0" bIns="0" rtlCol="0" anchor="ctr"/>
+          <a:lstStyle/>
+          <a:p>
+            <a:pPr indent="0" marL="0">
+              <a:buNone/>
+            </a:pPr>
+            <a:r>
+              <a:rPr lang="en-US" sz="1150" b="1" dirty="0">
+                <a:solidFill>
+                  <a:srgbClr val="00E500"/>
+                </a:solidFill>
+                <a:latin typeface="Amazon Ember Display" pitchFamily="34" charset="0"/>
+                <a:ea typeface="Amazon Ember Display" pitchFamily="34" charset="-122"/>
+                <a:cs typeface="Amazon Ember Display" pitchFamily="34" charset="-120"/>
+              </a:rPr>
+              <a:t>规则 11–15</a:t>
+            </a:r>
+            <a:endParaRPr lang="en-US" sz="1150" dirty="0"/>
+          </a:p>
+        </p:txBody>
+      </p:sp>
+      <p:sp>
+        <p:nvSpPr>
+          <p:cNvPr id="16" name="Text 13"/>
+          <p:cNvSpPr/>
+          <p:nvPr/>
+        </p:nvSpPr>
+        <p:spPr>
+          <a:xfrm>
+            <a:off x="8302752" y="2057400"/>
+            <a:ext cx="3127248" cy="3118104"/>
+          </a:xfrm>
+          <a:prstGeom prst="rect">
+            <a:avLst/>
+          </a:prstGeom>
+          <a:noFill/>
+          <a:ln/>
+        </p:spPr>
+        <p:txBody>
+          <a:bodyPr wrap="square" lIns="0" tIns="0" rIns="0" bIns="0" rtlCol="0" anchor="t"/>
+          <a:lstStyle/>
+          <a:p>
+            <a:pPr indent="0" marL="0">
+              <a:buNone/>
+            </a:pPr>
+            <a:r>
+              <a:rPr lang="en-US" sz="1050" dirty="0">
+                <a:solidFill>
+                  <a:srgbClr val="CFD9E4"/>
+                </a:solidFill>
+                <a:latin typeface="Microsoft YaHei" pitchFamily="34" charset="0"/>
+                <a:ea typeface="Microsoft YaHei" pitchFamily="34" charset="-122"/>
+                <a:cs typeface="Microsoft YaHei" pitchFamily="34" charset="-120"/>
+              </a:rPr>
+              <a:t>11. 检测标准完整：标准编号、比例、技术等级、合格级别齐全；RT/PT 分条。</a:t>
+            </a:r>
+            <a:endParaRPr lang="en-US" sz="1050" dirty="0"/>
+          </a:p>
+          <a:p>
+            <a:pPr indent="0" marL="0">
+              <a:buNone/>
+            </a:pPr>
+            <a:endParaRPr lang="en-US" sz="1050" dirty="0"/>
+          </a:p>
+          <a:p>
+            <a:pPr indent="0" marL="0">
+              <a:buNone/>
+            </a:pPr>
+            <a:r>
+              <a:rPr lang="en-US" sz="1050" dirty="0">
+                <a:solidFill>
+                  <a:srgbClr val="CFD9E4"/>
+                </a:solidFill>
+                <a:latin typeface="Microsoft YaHei" pitchFamily="34" charset="0"/>
+                <a:ea typeface="Microsoft YaHei" pitchFamily="34" charset="-122"/>
+                <a:cs typeface="Microsoft YaHei" pitchFamily="34" charset="-120"/>
+              </a:rPr>
+              <a:t>12. 工艺/结构要求：防涡、液封、双阀、清洁度、焊接结构独立抽取。</a:t>
+            </a:r>
+            <a:endParaRPr lang="en-US" sz="1050" dirty="0"/>
+          </a:p>
+          <a:p>
+            <a:pPr indent="0" marL="0">
+              <a:buNone/>
+            </a:pPr>
+            <a:endParaRPr lang="en-US" sz="1050" dirty="0"/>
+          </a:p>
+          <a:p>
+            <a:pPr indent="0" marL="0">
+              <a:buNone/>
+            </a:pPr>
+            <a:r>
+              <a:rPr lang="en-US" sz="1050" dirty="0">
+                <a:solidFill>
+                  <a:srgbClr val="CFD9E4"/>
+                </a:solidFill>
+                <a:latin typeface="Microsoft YaHei" pitchFamily="34" charset="0"/>
+                <a:ea typeface="Microsoft YaHei" pitchFamily="34" charset="-122"/>
+                <a:cs typeface="Microsoft YaHei" pitchFamily="34" charset="-120"/>
+              </a:rPr>
+              <a:t>13. 限值符号保留：≤、≥、不少于等原样保留，范围上下限完整。</a:t>
+            </a:r>
+            <a:endParaRPr lang="en-US" sz="1050" dirty="0"/>
+          </a:p>
+          <a:p>
+            <a:pPr indent="0" marL="0">
+              <a:buNone/>
+            </a:pPr>
+            <a:endParaRPr lang="en-US" sz="1050" dirty="0"/>
+          </a:p>
+          <a:p>
+            <a:pPr indent="0" marL="0">
+              <a:buNone/>
+            </a:pPr>
+            <a:r>
+              <a:rPr lang="en-US" sz="1050" dirty="0">
+                <a:solidFill>
+                  <a:srgbClr val="CFD9E4"/>
+                </a:solidFill>
+                <a:latin typeface="Microsoft YaHei" pitchFamily="34" charset="0"/>
+                <a:ea typeface="Microsoft YaHei" pitchFamily="34" charset="-122"/>
+                <a:cs typeface="Microsoft YaHei" pitchFamily="34" charset="-120"/>
+              </a:rPr>
+              <a:t>14. 功能/描述要求：无数值文本完整保留，不替换为空值或泛化词。</a:t>
+            </a:r>
+            <a:endParaRPr lang="en-US" sz="1050" dirty="0"/>
+          </a:p>
+          <a:p>
+            <a:pPr indent="0" marL="0">
+              <a:buNone/>
+            </a:pPr>
+            <a:endParaRPr lang="en-US" sz="1050" dirty="0"/>
+          </a:p>
+          <a:p>
+            <a:pPr indent="0" marL="0">
+              <a:buNone/>
+            </a:pPr>
+            <a:r>
+              <a:rPr lang="en-US" sz="1050" dirty="0">
+                <a:solidFill>
+                  <a:srgbClr val="CFD9E4"/>
+                </a:solidFill>
+                <a:latin typeface="Microsoft YaHei" pitchFamily="34" charset="0"/>
+                <a:ea typeface="Microsoft YaHei" pitchFamily="34" charset="-122"/>
+                <a:cs typeface="Microsoft YaHei" pitchFamily="34" charset="-120"/>
+              </a:rPr>
+              <a:t>15. 原文溯源：保留编号和标点；OCR 错误可修特征，但原文不改。</a:t>
+            </a:r>
+            <a:endParaRPr lang="en-US" sz="1050" dirty="0"/>
+          </a:p>
+        </p:txBody>
+      </p:sp>
+      <p:sp>
+        <p:nvSpPr>
+          <p:cNvPr id="17" name="Shape 14"/>
+          <p:cNvSpPr/>
+          <p:nvPr/>
+        </p:nvSpPr>
+        <p:spPr>
+          <a:xfrm>
+            <a:off x="566928" y="5504688"/>
+            <a:ext cx="11064240" cy="658368"/>
+          </a:xfrm>
+          <a:prstGeom prst="roundRect">
+            <a:avLst>
+              <a:gd name="adj" fmla="val 11111"/>
             </a:avLst>
           </a:prstGeom>
           <a:solidFill>
@@ -13276,14 +13350,14 @@
       </p:sp>
       <p:sp>
         <p:nvSpPr>
-          <p:cNvPr id="21" name="Text 18"/>
-          <p:cNvSpPr/>
-          <p:nvPr/>
-        </p:nvSpPr>
-        <p:spPr>
-          <a:xfrm>
-            <a:off x="822960" y="5532120"/>
-            <a:ext cx="10552176" cy="777240"/>
+          <p:cNvPr id="18" name="Text 15"/>
+          <p:cNvSpPr/>
+          <p:nvPr/>
+        </p:nvSpPr>
+        <p:spPr>
+          <a:xfrm>
+            <a:off x="795528" y="5504688"/>
+            <a:ext cx="10607040" cy="658368"/>
           </a:xfrm>
           <a:prstGeom prst="rect">
             <a:avLst/>
@@ -13299,7 +13373,7 @@
               <a:buNone/>
             </a:pPr>
             <a:r>
-              <a:rPr lang="en-US" sz="1650" b="1" dirty="0">
+              <a:rPr lang="en-US" sz="1550" b="1" dirty="0">
                 <a:solidFill>
                   <a:srgbClr val="FF6A3D"/>
                 </a:solidFill>
@@ -13307,9 +13381,9 @@
                 <a:ea typeface="Amazon Ember Display" pitchFamily="34" charset="-122"/>
                 <a:cs typeface="Amazon Ember Display" pitchFamily="34" charset="-120"/>
               </a:rPr>
-              <a:t>结论：只看输出的抽象自省，学习信号不足。</a:t>
-            </a:r>
-            <a:endParaRPr lang="en-US" sz="1650" dirty="0"/>
+              <a:t>4 轮抽取：90 → 93 → 95 → 102 条　|　15 条规则　|　53 个唯一原文　|　1.92 条/原文</a:t>
+            </a:r>
+            <a:endParaRPr lang="en-US" sz="1550" dirty="0"/>
           </a:p>
         </p:txBody>
       </p:sp>

</xml_diff>

<commit_message>
docs: clarify execution roles in memory deck
</commit_message>
<xml_diff>
--- a/docs/记忆能让Agent越跑越好吗-V3.pptx
+++ b/docs/记忆能让Agent越跑越好吗-V3.pptx
@@ -2562,7 +2562,7 @@
                 <a:ea typeface="Amazon Ember Display" pitchFamily="34" charset="-122"/>
                 <a:cs typeface="Amazon Ember Display" pitchFamily="34" charset="-120"/>
               </a:rPr>
-              <a:t>实际生成的 Memory</a:t>
+              <a:t>AgentCore Memory System 实际生成的 Records</a:t>
             </a:r>
             <a:endParaRPr lang="en-US" sz="2700" dirty="0"/>
           </a:p>
@@ -2601,7 +2601,7 @@
                 <a:ea typeface="Microsoft YaHei" pitchFamily="34" charset="-122"/>
                 <a:cs typeface="Microsoft YaHei" pitchFamily="34" charset="-120"/>
               </a:rPr>
-              <a:t>下面是 AgentCore 托管策略真实产出的 episode reflection 与 actor-level reflection。</a:t>
+              <a:t>以下内容均由内置 EPISODIC strategy 异步生成，不是 Harness Agent 手工写入的规则。</a:t>
             </a:r>
             <a:endParaRPr lang="en-US" sz="1400" dirty="0"/>
           </a:p>
@@ -2667,7 +2667,7 @@
                 <a:ea typeface="Amazon Ember Display" pitchFamily="34" charset="-122"/>
                 <a:cs typeface="Amazon Ember Display" pitchFamily="34" charset="-120"/>
               </a:rPr>
-              <a:t>EPISODE REFLECTION</a:t>
+              <a:t>MEMORY SYSTEM · EPISODE RECORD</a:t>
             </a:r>
             <a:endParaRPr lang="en-US" sz="1150" dirty="0"/>
           </a:p>
@@ -2857,7 +2857,7 @@
                 <a:ea typeface="Amazon Ember Display" pitchFamily="34" charset="-122"/>
                 <a:cs typeface="Amazon Ember Display" pitchFamily="34" charset="-120"/>
               </a:rPr>
-              <a:t>ACTOR REFLECTION 1</a:t>
+              <a:t>MEMORY SYSTEM · ACTOR REFLECTION 1</a:t>
             </a:r>
             <a:endParaRPr lang="en-US" sz="1150" dirty="0"/>
           </a:p>
@@ -3081,7 +3081,7 @@
                 <a:ea typeface="Amazon Ember Display" pitchFamily="34" charset="-122"/>
                 <a:cs typeface="Amazon Ember Display" pitchFamily="34" charset="-120"/>
               </a:rPr>
-              <a:t>ACTOR REFLECTION 2</a:t>
+              <a:t>MEMORY SYSTEM · ACTOR REFLECTION 2</a:t>
             </a:r>
             <a:endParaRPr lang="en-US" sz="1150" dirty="0"/>
           </a:p>
@@ -3445,7 +3445,7 @@
                 <a:ea typeface="Amazon Ember Display" pitchFamily="34" charset="-122"/>
                 <a:cs typeface="Amazon Ember Display" pitchFamily="34" charset="-120"/>
               </a:rPr>
-              <a:t>留出文档实验：目标端只改变 Memory 开关</a:t>
+              <a:t>Harness Agent 留出实验：目标端只改变 Memory 开关</a:t>
             </a:r>
             <a:endParaRPr lang="en-US" sz="2700" dirty="0"/>
           </a:p>
@@ -3484,7 +3484,7 @@
                 <a:ea typeface="Microsoft YaHei" pitchFamily="34" charset="-122"/>
                 <a:cs typeface="Microsoft YaHei" pitchFamily="34" charset="-120"/>
               </a:rPr>
-              <a:t>源文档为 13 页液氮罐技术要求；目标文档为全新 session 的一页电机图纸。</a:t>
+              <a:t>目标抽取由 Harness Agent 完成；Memory System 只在 enabled 组负责自动检索并注入 records。</a:t>
             </a:r>
             <a:endParaRPr lang="en-US" sz="1400" dirty="0"/>
           </a:p>
@@ -3550,7 +3550,7 @@
                 <a:ea typeface="Amazon Ember Display" pitchFamily="34" charset="-122"/>
                 <a:cs typeface="Amazon Ember Display" pitchFamily="34" charset="-120"/>
               </a:rPr>
-              <a:t>目标抽取 Prompt（真实节选）</a:t>
+              <a:t>HARNESS AGENT · 目标抽取 Prompt</a:t>
             </a:r>
             <a:endParaRPr lang="en-US" sz="1150" dirty="0"/>
           </a:p>
@@ -3818,7 +3818,7 @@
                 <a:ea typeface="Microsoft YaHei" pitchFamily="34" charset="-122"/>
                 <a:cs typeface="Microsoft YaHei" pitchFamily="34" charset="-120"/>
               </a:rPr>
-              <a:t>两组完全相同</a:t>
+              <a:t>Harness Agent 配置相同</a:t>
             </a:r>
             <a:endParaRPr lang="en-US" sz="1700" dirty="0"/>
           </a:p>
@@ -3849,7 +3849,7 @@
               <a:buNone/>
             </a:pPr>
             <a:r>
-              <a:rPr lang="en-US" sz="1350" dirty="0">
+              <a:rPr lang="en-US" sz="1330" dirty="0">
                 <a:solidFill>
                   <a:srgbClr val="CFD9E4"/>
                 </a:solidFill>
@@ -3857,16 +3857,16 @@
                 <a:ea typeface="Microsoft YaHei" pitchFamily="34" charset="-122"/>
                 <a:cs typeface="Microsoft YaHei" pitchFamily="34" charset="-120"/>
               </a:rPr>
-              <a:t>· 同一测试文档</a:t>
-            </a:r>
-            <a:endParaRPr lang="en-US" sz="1350" dirty="0"/>
-          </a:p>
-          <a:p>
-            <a:pPr indent="0" marL="0">
-              <a:buNone/>
-            </a:pPr>
-            <a:r>
-              <a:rPr lang="en-US" sz="1350" dirty="0">
+              <a:t>· 同一测试文档与 system prompt</a:t>
+            </a:r>
+            <a:endParaRPr lang="en-US" sz="1330" dirty="0"/>
+          </a:p>
+          <a:p>
+            <a:pPr indent="0" marL="0">
+              <a:buNone/>
+            </a:pPr>
+            <a:r>
+              <a:rPr lang="en-US" sz="1330" dirty="0">
                 <a:solidFill>
                   <a:srgbClr val="CFD9E4"/>
                 </a:solidFill>
@@ -3874,16 +3874,16 @@
                 <a:ea typeface="Microsoft YaHei" pitchFamily="34" charset="-122"/>
                 <a:cs typeface="Microsoft YaHei" pitchFamily="34" charset="-120"/>
               </a:rPr>
-              <a:t>· 同一 invocation-level system prompt</a:t>
-            </a:r>
-            <a:endParaRPr lang="en-US" sz="1350" dirty="0"/>
-          </a:p>
-          <a:p>
-            <a:pPr indent="0" marL="0">
-              <a:buNone/>
-            </a:pPr>
-            <a:r>
-              <a:rPr lang="en-US" sz="1350" dirty="0">
+              <a:t>· claude-sonnet-4-6</a:t>
+            </a:r>
+            <a:endParaRPr lang="en-US" sz="1330" dirty="0"/>
+          </a:p>
+          <a:p>
+            <a:pPr indent="0" marL="0">
+              <a:buNone/>
+            </a:pPr>
+            <a:r>
+              <a:rPr lang="en-US" sz="1330" dirty="0">
                 <a:solidFill>
                   <a:srgbClr val="CFD9E4"/>
                 </a:solidFill>
@@ -3891,16 +3891,16 @@
                 <a:ea typeface="Microsoft YaHei" pitchFamily="34" charset="-122"/>
                 <a:cs typeface="Microsoft YaHei" pitchFamily="34" charset="-120"/>
               </a:rPr>
-              <a:t>· claude-sonnet-4-6</a:t>
-            </a:r>
-            <a:endParaRPr lang="en-US" sz="1350" dirty="0"/>
-          </a:p>
-          <a:p>
-            <a:pPr indent="0" marL="0">
-              <a:buNone/>
-            </a:pPr>
-            <a:r>
-              <a:rPr lang="en-US" sz="1350" dirty="0">
+              <a:t>· temperature=0 · maxTokens=32768</a:t>
+            </a:r>
+            <a:endParaRPr lang="en-US" sz="1330" dirty="0"/>
+          </a:p>
+          <a:p>
+            <a:pPr indent="0" marL="0">
+              <a:buNone/>
+            </a:pPr>
+            <a:r>
+              <a:rPr lang="en-US" sz="1330" dirty="0">
                 <a:solidFill>
                   <a:srgbClr val="CFD9E4"/>
                 </a:solidFill>
@@ -3908,16 +3908,16 @@
                 <a:ea typeface="Microsoft YaHei" pitchFamily="34" charset="-122"/>
                 <a:cs typeface="Microsoft YaHei" pitchFamily="34" charset="-120"/>
               </a:rPr>
-              <a:t>· temperature=0</a:t>
-            </a:r>
-            <a:endParaRPr lang="en-US" sz="1350" dirty="0"/>
-          </a:p>
-          <a:p>
-            <a:pPr indent="0" marL="0">
-              <a:buNone/>
-            </a:pPr>
-            <a:r>
-              <a:rPr lang="en-US" sz="1350" dirty="0">
+              <a:t>· skills=[] · tools=[]</a:t>
+            </a:r>
+            <a:endParaRPr lang="en-US" sz="1330" dirty="0"/>
+          </a:p>
+          <a:p>
+            <a:pPr indent="0" marL="0">
+              <a:buNone/>
+            </a:pPr>
+            <a:r>
+              <a:rPr lang="en-US" sz="1330" dirty="0">
                 <a:solidFill>
                   <a:srgbClr val="CFD9E4"/>
                 </a:solidFill>
@@ -3925,16 +3925,22 @@
                 <a:ea typeface="Microsoft YaHei" pitchFamily="34" charset="-122"/>
                 <a:cs typeface="Microsoft YaHei" pitchFamily="34" charset="-120"/>
               </a:rPr>
-              <a:t>· maxTokens=32768</a:t>
-            </a:r>
-            <a:endParaRPr lang="en-US" sz="1350" dirty="0"/>
-          </a:p>
-          <a:p>
-            <a:pPr indent="0" marL="0">
-              <a:buNone/>
-            </a:pPr>
-            <a:r>
-              <a:rPr lang="en-US" sz="1350" dirty="0">
+              <a:t>· 两组均使用全新 session</a:t>
+            </a:r>
+            <a:endParaRPr lang="en-US" sz="1330" dirty="0"/>
+          </a:p>
+          <a:p>
+            <a:pPr indent="0" marL="0">
+              <a:buNone/>
+            </a:pPr>
+            <a:endParaRPr lang="en-US" sz="1330" dirty="0"/>
+          </a:p>
+          <a:p>
+            <a:pPr indent="0" marL="0">
+              <a:buNone/>
+            </a:pPr>
+            <a:r>
+              <a:rPr lang="en-US" sz="1330" dirty="0">
                 <a:solidFill>
                   <a:srgbClr val="CFD9E4"/>
                 </a:solidFill>
@@ -3942,16 +3948,16 @@
                 <a:ea typeface="Microsoft YaHei" pitchFamily="34" charset="-122"/>
                 <a:cs typeface="Microsoft YaHei" pitchFamily="34" charset="-120"/>
               </a:rPr>
-              <a:t>· skills=[] · tools=[]</a:t>
-            </a:r>
-            <a:endParaRPr lang="en-US" sz="1350" dirty="0"/>
-          </a:p>
-          <a:p>
-            <a:pPr indent="0" marL="0">
-              <a:buNone/>
-            </a:pPr>
-            <a:r>
-              <a:rPr lang="en-US" sz="1350" dirty="0">
+              <a:t>Memory 组：EPISODIC retrieval enabled</a:t>
+            </a:r>
+            <a:endParaRPr lang="en-US" sz="1330" dirty="0"/>
+          </a:p>
+          <a:p>
+            <a:pPr indent="0" marL="0">
+              <a:buNone/>
+            </a:pPr>
+            <a:r>
+              <a:rPr lang="en-US" sz="1330" dirty="0">
                 <a:solidFill>
                   <a:srgbClr val="CFD9E4"/>
                 </a:solidFill>
@@ -3959,32 +3965,9 @@
                 <a:ea typeface="Microsoft YaHei" pitchFamily="34" charset="-122"/>
                 <a:cs typeface="Microsoft YaHei" pitchFamily="34" charset="-120"/>
               </a:rPr>
-              <a:t>· 两组均使用全新 session</a:t>
-            </a:r>
-            <a:endParaRPr lang="en-US" sz="1350" dirty="0"/>
-          </a:p>
-          <a:p>
-            <a:pPr indent="0" marL="0">
-              <a:buNone/>
-            </a:pPr>
-            <a:endParaRPr lang="en-US" sz="1350" dirty="0"/>
-          </a:p>
-          <a:p>
-            <a:pPr indent="0" marL="0">
-              <a:buNone/>
-            </a:pPr>
-            <a:r>
-              <a:rPr lang="en-US" sz="1350" dirty="0">
-                <a:solidFill>
-                  <a:srgbClr val="CFD9E4"/>
-                </a:solidFill>
-                <a:latin typeface="Microsoft YaHei" pitchFamily="34" charset="0"/>
-                <a:ea typeface="Microsoft YaHei" pitchFamily="34" charset="-122"/>
-                <a:cs typeface="Microsoft YaHei" pitchFamily="34" charset="-120"/>
-              </a:rPr>
-              <a:t>唯一变量：Harness Memory enabled / disabled</a:t>
-            </a:r>
-            <a:endParaRPr lang="en-US" sz="1350" dirty="0"/>
+              <a:t>No Memory 组：Memory disabled</a:t>
+            </a:r>
+            <a:endParaRPr lang="en-US" sz="1330" dirty="0"/>
           </a:p>
         </p:txBody>
       </p:sp>
@@ -4048,7 +4031,7 @@
                 <a:ea typeface="Amazon Ember Display" pitchFamily="34" charset="-122"/>
                 <a:cs typeface="Amazon Ember Display" pitchFamily="34" charset="-120"/>
               </a:rPr>
-              <a:t>目标端不使用源文档答案，只自动召回 source actor 的托管 Memory。</a:t>
+              <a:t>执行主体：Harness Agent　|　实验变量：Memory System 是否检索并注入 source actor records</a:t>
             </a:r>
             <a:endParaRPr lang="en-US" sz="1650" dirty="0"/>
           </a:p>
@@ -4260,7 +4243,7 @@
                 <a:ea typeface="Amazon Ember Display" pitchFamily="34" charset="-122"/>
                 <a:cs typeface="Amazon Ember Display" pitchFamily="34" charset="-120"/>
               </a:rPr>
-              <a:t>同一份图纸，抽取关注点发生变化</a:t>
+              <a:t>Harness Agent 输出：Memory 注入后关注点发生变化</a:t>
             </a:r>
             <a:endParaRPr lang="en-US" sz="2700" dirty="0"/>
           </a:p>
@@ -4299,7 +4282,7 @@
                 <a:ea typeface="Microsoft YaHei" pitchFamily="34" charset="-122"/>
                 <a:cs typeface="Microsoft YaHei" pitchFamily="34" charset="-120"/>
               </a:rPr>
-              <a:t>两组都覆盖标题栏与技术要求；Memory 组进一步系统展开两张 BOM。</a:t>
+              <a:t>两组输出都由 Harness Agent 生成；差别是左侧调用前接收了 Memory System 注入的 records。</a:t>
             </a:r>
             <a:endParaRPr lang="en-US" sz="1400" dirty="0"/>
           </a:p>
@@ -4365,7 +4348,7 @@
                 <a:ea typeface="Amazon Ember Display" pitchFamily="34" charset="-122"/>
                 <a:cs typeface="Amazon Ember Display" pitchFamily="34" charset="-120"/>
               </a:rPr>
-              <a:t>MEMORY · BOM 条目</a:t>
+              <a:t>HARNESS AGENT + MEMORY SYSTEM · BOM</a:t>
             </a:r>
             <a:endParaRPr lang="en-US" sz="1150" dirty="0"/>
           </a:p>
@@ -4684,7 +4667,7 @@
                 <a:ea typeface="Amazon Ember Display" pitchFamily="34" charset="-122"/>
                 <a:cs typeface="Amazon Ember Display" pitchFamily="34" charset="-120"/>
               </a:rPr>
-              <a:t>NO MEMORY · 技术要求</a:t>
+              <a:t>HARNESS AGENT · MEMORY DISABLED</a:t>
             </a:r>
             <a:endParaRPr lang="en-US" sz="1150" dirty="0"/>
           </a:p>
@@ -5359,7 +5342,7 @@
                 <a:ea typeface="Amazon Ember Display" pitchFamily="34" charset="-122"/>
                 <a:cs typeface="Amazon Ember Display" pitchFamily="34" charset="-120"/>
               </a:rPr>
-              <a:t>为什么两种自省得到不同结果</a:t>
+              <a:t>Harness Agent 的两种 Review，为何产生不同 Memory</a:t>
             </a:r>
             <a:endParaRPr lang="en-US" sz="2700" dirty="0"/>
           </a:p>
@@ -5398,7 +5381,7 @@
                 <a:ea typeface="Microsoft YaHei" pitchFamily="34" charset="-122"/>
                 <a:cs typeface="Microsoft YaHei" pitchFamily="34" charset="-120"/>
               </a:rPr>
-              <a:t>不是 Self-reflection 有用或没用，而是 Reflection 是否有可靠的检查对象。</a:t>
+              <a:t>不是 Self-reflection 有用或没用，而是 Harness Agent 的 Review 是否有可靠检查对象。</a:t>
             </a:r>
             <a:endParaRPr lang="en-US" sz="1400" dirty="0"/>
           </a:p>
@@ -5431,7 +5414,7 @@
                 <a:gridCol w="4297680"/>
                 <a:gridCol w="4389120"/>
               </a:tblGrid>
-              <a:tr h="438912">
+              <a:tr h="384048">
                 <a:tc>
                   <a:txBody>
                     <a:bodyPr/>
@@ -5637,7 +5620,7 @@
                   </a:tcPr>
                 </a:tc>
               </a:tr>
-              <a:tr h="438912">
+              <a:tr h="384048">
                 <a:tc>
                   <a:txBody>
                     <a:bodyPr/>
@@ -5843,7 +5826,7 @@
                   </a:tcPr>
                 </a:tc>
               </a:tr>
-              <a:tr h="438912">
+              <a:tr h="384048">
                 <a:tc>
                   <a:txBody>
                     <a:bodyPr/>
@@ -6049,7 +6032,213 @@
                   </a:tcPr>
                 </a:tc>
               </a:tr>
-              <a:tr h="512064">
+              <a:tr h="438912">
+                <a:tc>
+                  <a:txBody>
+                    <a:bodyPr/>
+                    <a:lstStyle/>
+                    <a:p>
+                      <a:pPr indent="0" marL="0">
+                        <a:buNone/>
+                      </a:pPr>
+                      <a:r>
+                        <a:rPr lang="en-US" sz="1220" b="1" dirty="0">
+                          <a:solidFill>
+                            <a:srgbClr val="FFFFFF"/>
+                          </a:solidFill>
+                          <a:latin typeface="Microsoft YaHei" pitchFamily="34" charset="0"/>
+                          <a:ea typeface="Microsoft YaHei" pitchFamily="34" charset="-122"/>
+                          <a:cs typeface="Microsoft YaHei" pitchFamily="34" charset="-120"/>
+                        </a:rPr>
+                        <a:t>Memory 形成主体</a:t>
+                      </a:r>
+                      <a:endParaRPr lang="en-US" sz="1220" dirty="0">
+                        <a:latin typeface="Microsoft YaHei" charset="0"/>
+                        <a:ea typeface="Microsoft YaHei" charset="0"/>
+                        <a:cs typeface="Microsoft YaHei" charset="0"/>
+                      </a:endParaRPr>
+                    </a:p>
+                  </a:txBody>
+                  <a:tcPr marL="91440" marR="91440" marT="45720" marB="45720" anchor="ctr">
+                    <a:lnL w="9525" cap="flat" cmpd="sng" algn="ctr">
+                      <a:solidFill>
+                        <a:srgbClr val="2E3B57"/>
+                      </a:solidFill>
+                      <a:prstDash val="solid"/>
+                      <a:round/>
+                      <a:headEnd type="none" w="med" len="med"/>
+                      <a:tailEnd type="none" w="med" len="med"/>
+                    </a:lnL>
+                    <a:lnR w="9525" cap="flat" cmpd="sng" algn="ctr">
+                      <a:solidFill>
+                        <a:srgbClr val="2E3B57"/>
+                      </a:solidFill>
+                      <a:prstDash val="solid"/>
+                      <a:round/>
+                      <a:headEnd type="none" w="med" len="med"/>
+                      <a:tailEnd type="none" w="med" len="med"/>
+                    </a:lnR>
+                    <a:lnT w="9525" cap="flat" cmpd="sng" algn="ctr">
+                      <a:solidFill>
+                        <a:srgbClr val="2E3B57"/>
+                      </a:solidFill>
+                      <a:prstDash val="solid"/>
+                      <a:round/>
+                      <a:headEnd type="none" w="med" len="med"/>
+                      <a:tailEnd type="none" w="med" len="med"/>
+                    </a:lnT>
+                    <a:lnB w="9525" cap="flat" cmpd="sng" algn="ctr">
+                      <a:solidFill>
+                        <a:srgbClr val="2E3B57"/>
+                      </a:solidFill>
+                      <a:prstDash val="solid"/>
+                      <a:round/>
+                      <a:headEnd type="none" w="med" len="med"/>
+                      <a:tailEnd type="none" w="med" len="med"/>
+                    </a:lnB>
+                    <a:solidFill>
+                      <a:srgbClr val="0B1220"/>
+                    </a:solidFill>
+                  </a:tcPr>
+                </a:tc>
+                <a:tc>
+                  <a:txBody>
+                    <a:bodyPr/>
+                    <a:lstStyle/>
+                    <a:p>
+                      <a:pPr indent="0" marL="0">
+                        <a:buNone/>
+                      </a:pPr>
+                      <a:r>
+                        <a:rPr lang="en-US" sz="1220" dirty="0">
+                          <a:solidFill>
+                            <a:srgbClr val="CFD9E4"/>
+                          </a:solidFill>
+                          <a:latin typeface="Microsoft YaHei" pitchFamily="34" charset="0"/>
+                          <a:ea typeface="Microsoft YaHei" pitchFamily="34" charset="-122"/>
+                          <a:cs typeface="Microsoft YaHei" pitchFamily="34" charset="-120"/>
+                        </a:rPr>
+                        <a:t>应用调用 LLM 合并规则</a:t>
+                      </a:r>
+                      <a:endParaRPr lang="en-US" sz="1220" dirty="0">
+                        <a:latin typeface="Microsoft YaHei" charset="0"/>
+                        <a:ea typeface="Microsoft YaHei" charset="0"/>
+                        <a:cs typeface="Microsoft YaHei" charset="0"/>
+                      </a:endParaRPr>
+                    </a:p>
+                  </a:txBody>
+                  <a:tcPr marL="91440" marR="91440" marT="45720" marB="45720" anchor="ctr">
+                    <a:lnL w="9525" cap="flat" cmpd="sng" algn="ctr">
+                      <a:solidFill>
+                        <a:srgbClr val="2E3B57"/>
+                      </a:solidFill>
+                      <a:prstDash val="solid"/>
+                      <a:round/>
+                      <a:headEnd type="none" w="med" len="med"/>
+                      <a:tailEnd type="none" w="med" len="med"/>
+                    </a:lnL>
+                    <a:lnR w="9525" cap="flat" cmpd="sng" algn="ctr">
+                      <a:solidFill>
+                        <a:srgbClr val="2E3B57"/>
+                      </a:solidFill>
+                      <a:prstDash val="solid"/>
+                      <a:round/>
+                      <a:headEnd type="none" w="med" len="med"/>
+                      <a:tailEnd type="none" w="med" len="med"/>
+                    </a:lnR>
+                    <a:lnT w="9525" cap="flat" cmpd="sng" algn="ctr">
+                      <a:solidFill>
+                        <a:srgbClr val="2E3B57"/>
+                      </a:solidFill>
+                      <a:prstDash val="solid"/>
+                      <a:round/>
+                      <a:headEnd type="none" w="med" len="med"/>
+                      <a:tailEnd type="none" w="med" len="med"/>
+                    </a:lnT>
+                    <a:lnB w="9525" cap="flat" cmpd="sng" algn="ctr">
+                      <a:solidFill>
+                        <a:srgbClr val="2E3B57"/>
+                      </a:solidFill>
+                      <a:prstDash val="solid"/>
+                      <a:round/>
+                      <a:headEnd type="none" w="med" len="med"/>
+                      <a:tailEnd type="none" w="med" len="med"/>
+                    </a:lnB>
+                    <a:solidFill>
+                      <a:srgbClr val="35181C"/>
+                    </a:solidFill>
+                  </a:tcPr>
+                </a:tc>
+                <a:tc>
+                  <a:txBody>
+                    <a:bodyPr/>
+                    <a:lstStyle/>
+                    <a:p>
+                      <a:pPr indent="0" marL="0">
+                        <a:buNone/>
+                      </a:pPr>
+                      <a:r>
+                        <a:rPr lang="en-US" sz="1220" dirty="0">
+                          <a:solidFill>
+                            <a:srgbClr val="CFD9E4"/>
+                          </a:solidFill>
+                          <a:latin typeface="Microsoft YaHei" pitchFamily="34" charset="0"/>
+                          <a:ea typeface="Microsoft YaHei" pitchFamily="34" charset="-122"/>
+                          <a:cs typeface="Microsoft YaHei" pitchFamily="34" charset="-120"/>
+                        </a:rPr>
+                        <a:t>Memory System · EPISODIC</a:t>
+                      </a:r>
+                      <a:endParaRPr lang="en-US" sz="1220" dirty="0">
+                        <a:latin typeface="Microsoft YaHei" charset="0"/>
+                        <a:ea typeface="Microsoft YaHei" charset="0"/>
+                        <a:cs typeface="Microsoft YaHei" charset="0"/>
+                      </a:endParaRPr>
+                    </a:p>
+                  </a:txBody>
+                  <a:tcPr marL="91440" marR="91440" marT="45720" marB="45720" anchor="ctr">
+                    <a:lnL w="9525" cap="flat" cmpd="sng" algn="ctr">
+                      <a:solidFill>
+                        <a:srgbClr val="2E3B57"/>
+                      </a:solidFill>
+                      <a:prstDash val="solid"/>
+                      <a:round/>
+                      <a:headEnd type="none" w="med" len="med"/>
+                      <a:tailEnd type="none" w="med" len="med"/>
+                    </a:lnL>
+                    <a:lnR w="9525" cap="flat" cmpd="sng" algn="ctr">
+                      <a:solidFill>
+                        <a:srgbClr val="2E3B57"/>
+                      </a:solidFill>
+                      <a:prstDash val="solid"/>
+                      <a:round/>
+                      <a:headEnd type="none" w="med" len="med"/>
+                      <a:tailEnd type="none" w="med" len="med"/>
+                    </a:lnR>
+                    <a:lnT w="9525" cap="flat" cmpd="sng" algn="ctr">
+                      <a:solidFill>
+                        <a:srgbClr val="2E3B57"/>
+                      </a:solidFill>
+                      <a:prstDash val="solid"/>
+                      <a:round/>
+                      <a:headEnd type="none" w="med" len="med"/>
+                      <a:tailEnd type="none" w="med" len="med"/>
+                    </a:lnT>
+                    <a:lnB w="9525" cap="flat" cmpd="sng" algn="ctr">
+                      <a:solidFill>
+                        <a:srgbClr val="2E3B57"/>
+                      </a:solidFill>
+                      <a:prstDash val="solid"/>
+                      <a:round/>
+                      <a:headEnd type="none" w="med" len="med"/>
+                      <a:tailEnd type="none" w="med" len="med"/>
+                    </a:lnB>
+                    <a:solidFill>
+                      <a:srgbClr val="12331F"/>
+                    </a:solidFill>
+                  </a:tcPr>
+                </a:tc>
+              </a:tr>
+              <a:tr h="438912">
                 <a:tc>
                   <a:txBody>
                     <a:bodyPr/>
@@ -6255,7 +6444,7 @@
                   </a:tcPr>
                 </a:tc>
               </a:tr>
-              <a:tr h="530352">
+              <a:tr h="475488">
                 <a:tc>
                   <a:txBody>
                     <a:bodyPr/>
@@ -6461,7 +6650,7 @@
                   </a:tcPr>
                 </a:tc>
               </a:tr>
-              <a:tr h="438912">
+              <a:tr h="384048">
                 <a:tc>
                   <a:txBody>
                     <a:bodyPr/>
@@ -6667,7 +6856,7 @@
                   </a:tcPr>
                 </a:tc>
               </a:tr>
-              <a:tr h="438912">
+              <a:tr h="384048">
                 <a:tc>
                   <a:txBody>
                     <a:bodyPr/>
@@ -7295,7 +7484,7 @@
                 <a:ea typeface="Microsoft YaHei" pitchFamily="34" charset="-122"/>
                 <a:cs typeface="Microsoft YaHei" pitchFamily="34" charset="-120"/>
               </a:rPr>
-              <a:t>Review 必须看原文</a:t>
+              <a:t>Harness Agent · Review 看原文</a:t>
             </a:r>
             <a:endParaRPr lang="en-US" sz="1450" dirty="0"/>
           </a:p>
@@ -7441,7 +7630,7 @@
                 <a:ea typeface="Microsoft YaHei" pitchFamily="34" charset="-122"/>
                 <a:cs typeface="Microsoft YaHei" pitchFamily="34" charset="-120"/>
               </a:rPr>
-              <a:t>输出结构化 Artifact</a:t>
+              <a:t>Harness Agent · 输出 Artifact</a:t>
             </a:r>
             <a:endParaRPr lang="en-US" sz="1450" dirty="0"/>
           </a:p>
@@ -7587,7 +7776,7 @@
                 <a:ea typeface="Microsoft YaHei" pitchFamily="34" charset="-122"/>
                 <a:cs typeface="Microsoft YaHei" pitchFamily="34" charset="-120"/>
               </a:rPr>
-              <a:t>建议必须可执行</a:t>
+              <a:t>Harness Agent · 产出动作</a:t>
             </a:r>
             <a:endParaRPr lang="en-US" sz="1450" dirty="0"/>
           </a:p>
@@ -7626,7 +7815,7 @@
                 <a:ea typeface="Microsoft YaHei" pitchFamily="34" charset="-122"/>
                 <a:cs typeface="Microsoft YaHei" pitchFamily="34" charset="-120"/>
               </a:rPr>
-              <a:t>产出明确 next_actions。</a:t>
+              <a:t>生成明确、可执行的 next_actions。</a:t>
             </a:r>
             <a:endParaRPr lang="en-US" sz="1170" dirty="0"/>
           </a:p>
@@ -7733,7 +7922,7 @@
                 <a:ea typeface="Microsoft YaHei" pitchFamily="34" charset="-122"/>
                 <a:cs typeface="Microsoft YaHei" pitchFamily="34" charset="-120"/>
               </a:rPr>
-              <a:t>区分两类问题</a:t>
+              <a:t>任务设计 · 区分问题</a:t>
             </a:r>
             <a:endParaRPr lang="en-US" sz="1450" dirty="0"/>
           </a:p>
@@ -7879,7 +8068,7 @@
                 <a:ea typeface="Microsoft YaHei" pitchFamily="34" charset="-122"/>
                 <a:cs typeface="Microsoft YaHei" pitchFamily="34" charset="-120"/>
               </a:rPr>
-              <a:t>保存方法，不存答案</a:t>
+              <a:t>Memory 内容 · 保存方法</a:t>
             </a:r>
             <a:endParaRPr lang="en-US" sz="1450" dirty="0"/>
           </a:p>
@@ -7918,7 +8107,7 @@
                 <a:ea typeface="Microsoft YaHei" pitchFamily="34" charset="-122"/>
                 <a:cs typeface="Microsoft YaHei" pitchFamily="34" charset="-120"/>
               </a:rPr>
-              <a:t>Memory 应描述何时适用、检查什么、避免什么。</a:t>
+              <a:t>描述何时适用、检查什么、避免什么，不保存答案。</a:t>
             </a:r>
             <a:endParaRPr lang="en-US" sz="1170" dirty="0"/>
           </a:p>
@@ -8025,7 +8214,7 @@
                 <a:ea typeface="Microsoft YaHei" pitchFamily="34" charset="-122"/>
                 <a:cs typeface="Microsoft YaHei" pitchFamily="34" charset="-120"/>
               </a:rPr>
-              <a:t>区分 Episode 与 Reflection</a:t>
+              <a:t>Memory System · 区分 Records</a:t>
             </a:r>
             <a:endParaRPr lang="en-US" sz="1450" dirty="0"/>
           </a:p>
@@ -8064,7 +8253,7 @@
                 <a:ea typeface="Microsoft YaHei" pitchFamily="34" charset="-122"/>
                 <a:cs typeface="Microsoft YaHei" pitchFamily="34" charset="-120"/>
               </a:rPr>
-              <a:t>前者记录一次任务，后者沉淀跨任务方法。</a:t>
+              <a:t>Episode 记录一次任务；Reflection 沉淀跨任务方法。</a:t>
             </a:r>
             <a:endParaRPr lang="en-US" sz="1170" dirty="0"/>
           </a:p>
@@ -8171,7 +8360,7 @@
                 <a:ea typeface="Microsoft YaHei" pitchFamily="34" charset="-122"/>
                 <a:cs typeface="Microsoft YaHei" pitchFamily="34" charset="-120"/>
               </a:rPr>
-              <a:t>控制召回</a:t>
+              <a:t>Harness 配置 · 控制召回</a:t>
             </a:r>
             <a:endParaRPr lang="en-US" sz="1450" dirty="0"/>
           </a:p>
@@ -8317,7 +8506,7 @@
                 <a:ea typeface="Microsoft YaHei" pitchFamily="34" charset="-122"/>
                 <a:cs typeface="Microsoft YaHei" pitchFamily="34" charset="-120"/>
               </a:rPr>
-              <a:t>人工校准结果</a:t>
+              <a:t>Evaluation · 人工校准</a:t>
             </a:r>
             <a:endParaRPr lang="en-US" sz="1450" dirty="0"/>
           </a:p>
@@ -14426,7 +14615,7 @@
                 <a:ea typeface="Amazon Ember Display" pitchFamily="34" charset="-122"/>
                 <a:cs typeface="Amazon Ember Display" pitchFamily="34" charset="-120"/>
               </a:rPr>
-              <a:t>新设计：两阶段结构化 Self-review</a:t>
+              <a:t>Harness Agent：两阶段结构化 Self-review</a:t>
             </a:r>
             <a:endParaRPr lang="en-US" sz="2700" dirty="0"/>
           </a:p>
@@ -14465,7 +14654,7 @@
                 <a:ea typeface="Microsoft YaHei" pitchFamily="34" charset="-122"/>
                 <a:cs typeface="Microsoft YaHei" pitchFamily="34" charset="-120"/>
               </a:rPr>
-              <a:t>把隐藏在模型内部的自审，变成 session 中可观察、可执行、可被 Memory 提炼的 Artifact。</a:t>
+              <a:t>两个阶段均由 Harness Agent 执行；产物写入同一 runtime session，等待 Memory System 后台提炼。</a:t>
             </a:r>
             <a:endParaRPr lang="en-US" sz="1400" dirty="0"/>
           </a:p>
@@ -14531,7 +14720,7 @@
                 <a:ea typeface="Amazon Ember Display" pitchFamily="34" charset="-122"/>
                 <a:cs typeface="Amazon Ember Display" pitchFamily="34" charset="-120"/>
               </a:rPr>
-              <a:t>阶段一 Prompt（真实节选）</a:t>
+              <a:t>HARNESS AGENT · 阶段一 Prompt</a:t>
             </a:r>
             <a:endParaRPr lang="en-US" sz="1150" dirty="0"/>
           </a:p>
@@ -14839,7 +15028,7 @@
                 <a:ea typeface="Amazon Ember Display" pitchFamily="34" charset="-122"/>
                 <a:cs typeface="Amazon Ember Display" pitchFamily="34" charset="-120"/>
               </a:rPr>
-              <a:t>阶段二 Prompt（真实节选）</a:t>
+              <a:t>HARNESS AGENT · 阶段二 Prompt</a:t>
             </a:r>
             <a:endParaRPr lang="en-US" sz="1150" dirty="0"/>
           </a:p>
@@ -15102,7 +15291,7 @@
                 <a:ea typeface="Amazon Ember Display" pitchFamily="34" charset="-122"/>
                 <a:cs typeface="Amazon Ember Display" pitchFamily="34" charset="-120"/>
               </a:rPr>
-              <a:t>关键变化：Review 有固定检查维度，并产出可执行的 next_actions。</a:t>
+              <a:t>执行主体：Harness Agent　|　产物：self_review + 最终 JSON　|　载体：同一 session events</a:t>
             </a:r>
             <a:endParaRPr lang="en-US" sz="1650" dirty="0"/>
           </a:p>
@@ -15314,7 +15503,7 @@
                 <a:ea typeface="Amazon Ember Display" pitchFamily="34" charset="-122"/>
                 <a:cs typeface="Amazon Ember Display" pitchFamily="34" charset="-120"/>
               </a:rPr>
-              <a:t>AgentCore 如何形成托管 Memory</a:t>
+              <a:t>Memory System：EPISODIC 提炼轨迹</a:t>
             </a:r>
             <a:endParaRPr lang="en-US" sz="2700" dirty="0"/>
           </a:p>
@@ -15353,7 +15542,7 @@
                 <a:ea typeface="Microsoft YaHei" pitchFamily="34" charset="-122"/>
                 <a:cs typeface="Microsoft YaHei" pitchFamily="34" charset="-120"/>
               </a:rPr>
-              <a:t>完整 session 被异步提炼为 episode，再跨 episode 形成 actor-level reflection。</a:t>
+              <a:t>AgentCore Memory 资源使用内置 EPISODIC strategy；后台异步处理 Harness Agent 产生的完整 session events。</a:t>
             </a:r>
             <a:endParaRPr lang="en-US" sz="1400" dirty="0"/>
           </a:p>
@@ -15419,7 +15608,7 @@
                 <a:ea typeface="Amazon Ember Display" pitchFamily="34" charset="-122"/>
                 <a:cs typeface="Amazon Ember Display" pitchFamily="34" charset="-120"/>
               </a:rPr>
-              <a:t>①</a:t>
+              <a:t>HARNESS AGENT</a:t>
             </a:r>
             <a:endParaRPr lang="en-US" sz="1150" dirty="0"/>
           </a:p>
@@ -15458,7 +15647,7 @@
                 <a:ea typeface="Microsoft YaHei" pitchFamily="34" charset="-122"/>
                 <a:cs typeface="Microsoft YaHei" pitchFamily="34" charset="-120"/>
               </a:rPr>
-              <a:t>完整 Session</a:t>
+              <a:t>Session Events</a:t>
             </a:r>
             <a:endParaRPr lang="en-US" sz="1700" dirty="0"/>
           </a:p>
@@ -15602,7 +15791,7 @@
                 <a:ea typeface="Amazon Ember Display" pitchFamily="34" charset="-122"/>
                 <a:cs typeface="Amazon Ember Display" pitchFamily="34" charset="-120"/>
               </a:rPr>
-              <a:t>②</a:t>
+              <a:t>MEMORY · EPISODIC</a:t>
             </a:r>
             <a:endParaRPr lang="en-US" sz="1150" dirty="0"/>
           </a:p>
@@ -15785,7 +15974,7 @@
                 <a:ea typeface="Amazon Ember Display" pitchFamily="34" charset="-122"/>
                 <a:cs typeface="Amazon Ember Display" pitchFamily="34" charset="-120"/>
               </a:rPr>
-              <a:t>③</a:t>
+              <a:t>MEMORY · EPISODIC</a:t>
             </a:r>
             <a:endParaRPr lang="en-US" sz="1150" dirty="0"/>
           </a:p>
@@ -15968,7 +16157,7 @@
                 <a:ea typeface="Amazon Ember Display" pitchFamily="34" charset="-122"/>
                 <a:cs typeface="Amazon Ember Display" pitchFamily="34" charset="-120"/>
               </a:rPr>
-              <a:t>④</a:t>
+              <a:t>MEMORY · EPISODIC</a:t>
             </a:r>
             <a:endParaRPr lang="en-US" sz="1150" dirty="0"/>
           </a:p>
@@ -16046,7 +16235,7 @@
                 <a:ea typeface="Microsoft YaHei" pitchFamily="34" charset="-122"/>
                 <a:cs typeface="Microsoft YaHei" pitchFamily="34" charset="-120"/>
               </a:rPr>
-              <a:t>形成跨任务可复用策略</a:t>
+              <a:t>形成 actor-level 可复用策略</a:t>
             </a:r>
             <a:endParaRPr lang="en-US" sz="1250" dirty="0"/>
           </a:p>
@@ -16361,7 +16550,7 @@
                 <a:ea typeface="Microsoft YaHei" pitchFamily="34" charset="-122"/>
                 <a:cs typeface="Microsoft YaHei" pitchFamily="34" charset="-120"/>
               </a:rPr>
-              <a:t>目标任务自动召回</a:t>
+              <a:t>Harness 自动检索并注入</a:t>
             </a:r>
             <a:endParaRPr lang="en-US" sz="1250" dirty="0"/>
           </a:p>
@@ -16427,7 +16616,7 @@
                 <a:ea typeface="Amazon Ember Display" pitchFamily="34" charset="-122"/>
                 <a:cs typeface="Amazon Ember Display" pitchFamily="34" charset="-120"/>
               </a:rPr>
-              <a:t>Memory 记住的是处理方法，而不是源文档中的具体字段值。</a:t>
+              <a:t>Episode namespace: /episodes/{actorId}/{sessionId}　|　Reflection namespace: /episodes/{actorId}</a:t>
             </a:r>
             <a:endParaRPr lang="en-US" sz="1650" dirty="0"/>
           </a:p>

</xml_diff>

<commit_message>
docs: embed speaker notes in V3 deck
</commit_message>
<xml_diff>
--- a/docs/记忆能让Agent越跑越好吗-V3.pptx
+++ b/docs/记忆能让Agent越跑越好吗-V3.pptx
@@ -518,7 +518,10 @@
           <a:p>
             <a:r>
               <a:rPr lang="en-US" dirty="0"/>
-              <a:t/>
+              <a:t>今天讨论一个具体问题：在结构化数据抽取场景中，怎样让 Harness Agent 从过去任务中学习，并在下一份文档中抽得更完整。
+这里的 Memory 不应只是保存历史答案。更有价值的是保存 Review 发现的遗漏模式、检查方法和可复用抽取策略，再由 AgentCore Memory System 在后续任务中检索并注入给 Harness Agent。
+接下来通过三项相互独立、前后递进的实验，说明什么样的学习信号能形成有用 Memory，以及 Memory 最终如何改变留出文档的抽取行为。
+过渡： 先看结构化抽取真正困难的部分。</a:t>
             </a:r>
             <a:endParaRPr lang="en-US" dirty="0"/>
           </a:p>
@@ -606,7 +609,12 @@
           <a:p>
             <a:r>
               <a:rPr lang="en-US" dirty="0"/>
-              <a:t/>
+              <a:t>阶段一的执行主体是 Harness Agent。
+Harness Agent 在内部形成草稿，但不向用户输出草稿，只输出结构化 self_review。固定检查项包括 coverage、omissions、format、granularity 和 next_actions。
+阶段二仍由同一个 Harness Agent 执行。Harness Agent 重新读取原文和 self_review，逐项落实 next_actions，再输出最终五字段 JSON。
+这个设计不要求模型暴露完整思维过程。它要求 Harness Agent 产生一个可观察、可执行的 Review artifact，并在同一 session 中留下修订前后的因果轨迹。
+应用或 Harness 负责两阶段调用顺序和输出约束；此时 AgentCore Memory System 尚不负责抽取业务数据，也不替 Harness Agent 做 Review。
+过渡： 完整 session 结束后，AgentCore Memory System 才开始提炼这条轨迹。</a:t>
             </a:r>
             <a:endParaRPr lang="en-US" dirty="0"/>
           </a:p>
@@ -694,7 +702,15 @@
           <a:p>
             <a:r>
               <a:rPr lang="en-US" dirty="0"/>
-              <a:t/>
+              <a:t>这一页的执行主体是 AgentCore Memory System，策略类型是内置 EPISODIC strategy。
+Harness Agent 已经在 session events 中留下原文、结构化 self_review、最终 JSON 和任务结束信号。AgentCore Memory System 随后异步执行三个处理阶段：
+1. Episode Extraction：分析 session 中的行为、Review 与结果；
+2. Consolidation：形成 session-level episode；
+3. Reflection：从 episode 中抽象 actor-level 可复用策略。
+Session-level episode 的作用域是当前 actor 和 session，namespace 为 /episodes/{actorId}/{sessionId}。
+Actor-level reflection 的作用域是当前 actor，namespace 为 /episodes/{actorId}，用于后续 session 的跨任务召回。
+EPISODIC 提炼是异步过程，短 session 不保证一定生成 Memory。本次 13 页源任务提供了足够完整的执行轨迹。
+过渡： 下一页展示 AgentCore Memory System 实际生成的 records，而不是概念示例。</a:t>
             </a:r>
             <a:endParaRPr lang="en-US" dirty="0"/>
           </a:p>
@@ -782,7 +798,14 @@
           <a:p>
             <a:r>
               <a:rPr lang="en-US" dirty="0"/>
-              <a:t/>
+              <a:t>AgentCore Memory System 的内置 EPISODIC strategy 最终生成了 1 条 session-level episode 和 2 条 actor-level reflections。
+Session-level episode 总结了本次任务发生了什么：Harness Agent 使用两阶段流程，先输出 self_review，再执行修订；面对 OCR 错误、章节跳号、重复表格和图片限制时，应显式处理并保留可追溯信息。
+两条 actor-level reflections 把本次经验抽象成未来可复用的方法：
+• Harness Agent 应先系统检查 coverage、omissions、format 和 granularity，再执行明确的 next_actions；
+• Harness Agent 应保留原文用于追溯，遇到冲突或无法完整结构化的内容时，不应静默丢弃信息。
+Episode 回答“这一次任务发生了什么”；actor reflection 回答“未来遇到类似任务时应该怎么做”。
+这些 records 的生成主体是 AgentCore Memory System，不是 Harness Agent 手工写入，也不是应用侧沿用实验一的自定义 canonical rules。
+过渡： 实验二到此只证明 Memory 已经形成；实验三才验证这些 records 是否会改变新文档的抽取。</a:t>
             </a:r>
             <a:endParaRPr lang="en-US" dirty="0"/>
           </a:p>
@@ -870,7 +893,12 @@
           <a:p>
             <a:r>
               <a:rPr lang="en-US" dirty="0"/>
-              <a:t/>
+              <a:t>这是第三项独立实验的章节页，也是效果验证实验。
+源任务仍是实验二的 13 页液氮罐技术要求；目标任务换成一页电机图纸“2477080009简图-8.16”，并使用全新的 runtime session。
+Harness Agent 在目标文档上执行抽取。Memory 组由 AgentCore Memory System 检索实验二形成的 EPISODIC records，并由 Harness 注入给 Harness Agent；No Memory 组完全禁用 Memory。
+本实验不再生成或比较新的自省规则，问题只有一个：在其他条件相同的情况下，Memory 注入是否改变 Harness Agent 对目标文档的覆盖重点。
+前后边界： 第 9 至第 12 页的实验二是 Memory 生成阶段；从本页到第 15 页是留出文档验证阶段。源任务的答案不会提供给目标任务，目标 Harness Agent 只接收托管 Memory 中的方法性 records。
+过渡： 为了让结果可解释，下一页先锁定控制变量。</a:t>
             </a:r>
             <a:endParaRPr lang="en-US" dirty="0"/>
           </a:p>
@@ -958,7 +986,19 @@
           <a:p>
             <a:r>
               <a:rPr lang="en-US" dirty="0"/>
-              <a:t/>
+              <a:t>两组目标抽取都由 Harness Agent 执行，并保持以下条件一致：
+• 相同的一页电机图纸；
+• 相同的 invocation-level system prompt；
+• 相同模型 claude-sonnet-4-6；
+• 相同 temperature=0；
+• 相同 maxTokens=32768；
+• 都禁用 Skill 和 tools；
+• 都使用全新 session；
+• 都执行单次抽取，并在内部自审后输出最终 JSON。
+唯一变量是 AgentCore Memory System 是否参与 Retrieval 和 context injection。
+Memory 组使用 extractor_ep_review，复用 source actor ep-review-1789102186。AgentCore Memory System 检索该 actor 的 EPISODIC records，Harness 将其注入目标 Harness Agent。
+No Memory 组使用 extractor_ep_review_nomem，Harness 的 Memory 配置为 disabled。
+过渡： 在这组严格对照下，最重要的结果不是格式差异，而是 Harness Agent 是否开始系统覆盖两张 BOM。</a:t>
             </a:r>
             <a:endParaRPr lang="en-US" dirty="0"/>
           </a:p>
@@ -1046,7 +1086,14 @@
           <a:p>
             <a:r>
               <a:rPr lang="en-US" dirty="0"/>
-              <a:t/>
+              <a:t>这是全套实验最重要的一页。
+首次运行中，Memory 组由 Harness Agent 输出 31 条记录；No Memory 组由 Harness Agent 输出 11 条记录。这里不能表述为“质量提升三倍”，因为条数不是质量分数。
+真正值得关注的是新增内容的来源。Memory 组多出的约 20 条记录主要来自图纸中的两张 BOM，Harness Agent 系统展开了其中的零部件和组件，例如机座、前端盖、转子、轴承、壳体组件、法兰盘组件和散热器组件。
+No Memory 组主要关注标题栏和技术要求，只零散抽取了少量数量信息，没有同样系统地展开两张 BOM。
+人眼核对后，这些新增条目基本能够在原文表格中找到依据，并非明显臆造。但这仍然不代表每一条都符合最终业务边界，条目是否应纳入正式结果仍需 Reviewer 或人工评审。
+因此，本页的准确结论是：
+AgentCore Memory System 注入方法性 EPISODIC records 后，Harness Agent 改变了对“什么值得结构化”的判断，并显著扩大了对两张 BOM 的覆盖。
+过渡： 把三项实验放在一起，可以得到一个比“Memory 有效或无效”更具体的结论。</a:t>
             </a:r>
             <a:endParaRPr lang="en-US" dirty="0"/>
           </a:p>
@@ -1134,7 +1181,15 @@
           <a:p>
             <a:r>
               <a:rPr lang="en-US" dirty="0"/>
-              <a:t/>
+              <a:t>实验一说明：当反思模型只看 Harness Agent 输出时，自定义 canonical memory 会学到格式、规范化和拆分规则，但无法稳定发现完全遗漏的文档区域，条数增长也可能来自过度拆分。
+实验二说明：当 Harness Agent 同时查看原文和内部草稿，并输出结构化 self_review 与可执行 next_actions 时，完整 session 能为 AgentCore Memory System 的内置 EPISODIC strategy 提供更有价值的提炼轨迹。
+实验三说明：AgentCore Memory System 在目标任务中检索并注入这些方法性 records 后，Harness Agent 的关注点发生变化；在一页电机图纸上，输出从 11 条变为 31 条，新增内容主要来自两张 BOM，且人眼看基本有原文依据。
+统一结论不是“有 Memory 就一定更好”，而是：
+• Memory 的价值取决于上游 Review 是否获得了足够的事实信号；
+• 源覆盖问题适合由原文驱动的结构化 Self-review 改善；
+• AgentCore EPISODIC Memory 适合沉淀和跨 session 复用方法；
+• 任务边界与最终质量判断仍需规范、Reviewer 或人工反馈。
+过渡： 最后把这些发现收敛成可执行的工程实践。</a:t>
             </a:r>
             <a:endParaRPr lang="en-US" dirty="0"/>
           </a:p>
@@ -1222,7 +1277,15 @@
           <a:p>
             <a:r>
               <a:rPr lang="en-US" dirty="0"/>
-              <a:t/>
+              <a:t>第一，Harness Agent 的 Review 必须同时查看原文和内部草稿，不能只看已有输出做抽象总结。
+第二，Harness Agent 应输出结构化 Review artifact，固定检查覆盖、遗漏、格式和粒度，并形成明确、可执行的 next_actions。
+第三，应用或 Harness 应明确控制两阶段调用、结束信号和实验变量，不要把编排动作误写成 Memory System 的能力。
+第四，AgentCore Memory System 使用内置 EPISODIC strategy 时，应明确区分 session-level episode 与 actor-level reflection，以及 Extraction、Consolidation、Reflection 和 Retrieval 各阶段。
+第五，AgentCore Memory System 保存和检索的重点应是方法性经验，而不是历史业务答案；Harness 将检索结果注入新的 Harness Agent session。
+第六，团队应区分源覆盖问题和任务边界问题。前者可以通过原文驱动的 Self-review 改善，后者仍需任务规范、Reviewer 或人工反馈。
+第七，评估时不能把记录条数直接当作质量分数。Reviewer 应分别检查忠实性、完整性、粒度、过度抽取和业务边界。
+最终 takeaway 是：
+Memory 的价值不是让 Harness Agent 记住上一份答案，而是让 AgentCore Memory System 复用一次高质量 Review 中形成的抽取方法。</a:t>
             </a:r>
             <a:endParaRPr lang="en-US" dirty="0"/>
           </a:p>
@@ -1310,7 +1373,11 @@
           <a:p>
             <a:r>
               <a:rPr lang="en-US" dirty="0"/>
-              <a:t/>
+              <a:t>当前模型生成合法 JSON 并不困难，真正困难的是完整性。
+工业文档的信息可能分散在正文、技术要求、BOM 表格、附注、图纸说明和 OCR 结果中。Harness Agent 往往优先关注明显的参数和数值，却可能把整张 BOM 或整个章节当成背景材料。
+因此，结果即使格式完全正确，也可能只覆盖技术要求，没有覆盖表格中的零部件和组件。
+核心挑战不是“Harness Agent 能不能输出 JSON”，而是“Harness Agent 如何发现自己漏了什么，并把这种发现带到下一次任务中”。
+过渡： 这决定了 Memory 在抽取回路中应该承担什么角色。</a:t>
             </a:r>
             <a:endParaRPr lang="en-US" dirty="0"/>
           </a:p>
@@ -1398,7 +1465,15 @@
           <a:p>
             <a:r>
               <a:rPr lang="en-US" dirty="0"/>
-              <a:t/>
+              <a:t>Harness Agent 先执行抽取和 Review；AgentCore Memory System 再保存 session events，并根据配置的策略提炼可复用记录。
+在后续任务开始前，AgentCore Memory System 检索相关记录，Harness 将这些记录作为上下文注入新的 Harness Agent session。
+有价值的 Memory 应描述方法，例如：
+• Harness Agent 应检查哪些文档区域；
+• Harness Agent 应如何处理遗漏、冲突和重复；
+• Harness Agent 输出前应执行哪些明确动作；
+• Harness Agent 应如何选择抽取粒度。
+Memory 不应直接复制上一份文档的业务答案，因为历史答案既占上下文，也可能误导新任务。
+过渡： 为了判断哪种方法有效，我们把探索拆成三项边界清晰的实验。</a:t>
             </a:r>
             <a:endParaRPr lang="en-US" dirty="0"/>
           </a:p>
@@ -1486,7 +1561,12 @@
           <a:p>
             <a:r>
               <a:rPr lang="en-US" dirty="0"/>
-              <a:t/>
+              <a:t>三项实验回答三个不同问题。
+实验一研究“只看输出能学到什么”。应用侧把 Harness Agent 的已有输出交给反思模型，再通过自定义 consolidation 维护 canonical memory，观察规则和抽取结果如何变化。
+实验二研究“怎样产生可被托管 Memory 提炼的轨迹”。Harness Agent 同时查看原文和内部草稿，执行两阶段结构化 Self-review；AgentCore Memory System 使用内置 EPISODIC strategy 提炼完整 session。
+实验三研究“已有 Memory 是否改变下一份文档的抽取”。Harness Agent 在留出文档上执行 Memory 开关对照；AgentCore Memory System 只在 Memory 组检索并注入 records。
+三项实验依次对应：抽象规则学习、源任务 Memory 生成、目标任务效果验证。
+过渡： 先进入实验一，只允许反思模型看到已经抽出的输出。</a:t>
             </a:r>
             <a:endParaRPr lang="en-US" dirty="0"/>
           </a:p>
@@ -1574,7 +1654,12 @@
           <a:p>
             <a:r>
               <a:rPr lang="en-US" dirty="0"/>
-              <a:t/>
+              <a:t>这是第一项独立实验的章节页。
+实验一的输入边界是：反思模型只能看到 Harness Agent 已经抽出的结果，看不到原文，也看不到被完全遗漏的章节或表格。
+应用侧负责调用反思模型生成规则，再调用 consolidation prompt 合并、去重并维护 canonical memory。这里形成的是自定义规则记忆，不是 AgentCore Memory System 内置 EPISODIC strategy 生成的 episode 或 reflection。
+本实验的目标是判断：仅依赖输出侧自省，规则是否会逐轮收敛，以及抽取数量增加究竟代表覆盖提升还是拆分变细。
+前后边界： 前四页是问题定义和实验地图；从本页到第 8 页只讨论实验一。第 9 页开始切换到新的源任务流程，不沿用实验一的输入条件。
+过渡： 下一页先展示实验一真实使用的 reflection 与 consolidation prompt。</a:t>
             </a:r>
             <a:endParaRPr lang="en-US" dirty="0"/>
           </a:p>
@@ -1662,7 +1747,11 @@
           <a:p>
             <a:r>
               <a:rPr lang="en-US" dirty="0"/>
-              <a:t/>
+              <a:t>第一步，应用侧把某轮 Harness Agent 输出交给反思模型。Reflection prompt 要求模型总结不超过十条、可用于未来任务的规则。
+第二步，应用侧把已有规则和新规则一起交给 consolidation 模型。Consolidation prompt 负责合并同义项、删除重复项，并把规则集控制在十五条以内。
+这个流程每轮都能产生新的规则，而且规则会持续合并，因此形式上像一个自进化闭环。
+但反思模型的观察范围只包含“已经抽出来的内容”。如果 Harness Agent 完全漏掉了一张 BOM，这张表不会出现在输出里，反思模型也无法从缺失信息中推导出遗漏。
+过渡： 因此要同时看规则内容、抽取条数和原文覆盖，而不能只看 Memory 数量。</a:t>
             </a:r>
             <a:endParaRPr lang="en-US" dirty="0"/>
           </a:p>
@@ -1750,7 +1839,26 @@
           <a:p>
             <a:r>
               <a:rPr lang="en-US" dirty="0"/>
-              <a:t/>
+              <a:t>四轮 consolidation 最终形成了完整的 15 条 canonical memory：
+1. 先识别指标所属主体，避免把部件指标错误归到整机；
+2. 整体性能指标与部件性能指标分别记录；
+3. 运输、交付和包装要求独立成条；
+4. 子系统、附件和独立部件的要求分别记录；
+5. 同一句涉及多个部件时，按部件拆分记录；
+6. 同一句包含多个指标时，按指标拆分记录；
+7. 指标名称应规范化，避免把完整句子直接作为名称；
+8. 接管、接口和连接要求按接口对象分别记录；
+9. 阀门、仪表和附件清单中的对象分别记录；
+10. 不同部位、不同层次的材料要求分别记录；
+11. 无损检测方法、比例、级别和标准应完整保留；
+12. 制造工艺和结构要求应与性能指标区分；
+13. 上下限、范围及大于小于符号必须忠实保留；
+14. 功能性和描述性要求不能因为缺少数值而忽略；
+15. 每条结果保留对应原文，支持追溯和复核。
+这些规则并非都没有价值。限值符号保留、描述性要求保留和原文追溯都是合理的质量要求。
+但规则集中有多条持续强调“分别成条”和“独立拆分”。四轮抽取条数从 90、93、95 增加到 102，最终 102 条只来自约 53 个唯一原文片段，平均每段原文被拆成 1.92 条。
+因此，90→102 主要反映拆分粒度变细，不能直接证明覆盖了更多文档区域。
+过渡： 实验一的结果需要用两类错误来解释。</a:t>
             </a:r>
             <a:endParaRPr lang="en-US" dirty="0"/>
           </a:p>
@@ -1838,7 +1946,11 @@
           <a:p>
             <a:r>
               <a:rPr lang="en-US" dirty="0"/>
-              <a:t/>
+              <a:t>第一类是源覆盖问题：信息明确存在于原文，但 Harness Agent 没有输出，例如漏掉 BOM、漏掉章节、重复记录或字段为空。
+第二类是任务边界问题：Harness Agent 不知道某类内容是否属于目标，或者不知道一段原文应该拆成几条。这需要任务规范、Reviewer 或人工反馈。
+实验一说明，只看输出的抽象自省可以改善格式、规范化和局部拆分规则，但无法稳定发现完全未进入输出的区域。规则增加和条数增加也可能只是过度拆分。
+因此，正确结论不是“Self-reflection 没用”，而是“只看输出时，反思模型获得的学习信号不足”。
+过渡： 实验二改变输入条件，让 Harness Agent 的 Review 同时看到原文和内部草稿。</a:t>
             </a:r>
             <a:endParaRPr lang="en-US" dirty="0"/>
           </a:p>
@@ -1926,7 +2038,12 @@
           <a:p>
             <a:r>
               <a:rPr lang="en-US" dirty="0"/>
-              <a:t/>
+              <a:t>这是第二项独立实验的章节页。
+实验二不再沿用实验一“只看输出”的抽象自省。Harness Agent 在同一个源任务 session 中读取 13 页液氮罐技术要求，先形成内部草稿，再输出结构化 self_review，最后根据 next_actions 修订并输出最终 JSON。
+Harness Agent 负责抽取、自审和修订；AgentCore Memory System 负责保存 session events，并使用内置 EPISODIC strategy 异步执行 Extraction、Consolidation 和 Reflection。
+本实验的目标不是直接比较最终条数，而是构造一条包含“原文、Review、修订结果”的高质量轨迹，观察托管 Memory 能否从中提炼出 episode 和 actor-level reflections。
+前后边界： 第 5 至第 8 页的实验一到此结束；第 9 至第 12 页只讨论源任务如何产生托管 Memory。第 13 页才开始在另一份留出文档上验证效果。
+过渡： 下一页先看 Harness Agent 如何执行两阶段 Self-review。</a:t>
             </a:r>
             <a:endParaRPr lang="en-US" dirty="0"/>
           </a:p>

</xml_diff>

<commit_message>
docs: clarify role ownership across memory deck
</commit_message>
<xml_diff>
--- a/docs/记忆能让Agent越跑越好吗-V3.pptx
+++ b/docs/记忆能让Agent越跑越好吗-V3.pptx
@@ -518,10 +518,13 @@
           <a:p>
             <a:r>
               <a:rPr lang="en-US" dirty="0"/>
-              <a:t>今天讨论一个具体问题：在结构化数据抽取场景中，怎样让 Harness Agent 从过去任务中学习，并在下一份文档中抽得更完整。
-这里的 Memory 不应只是保存历史答案。更有价值的是保存 Review 发现的遗漏模式、检查方法和可复用抽取策略，再由 AgentCore Memory System 在后续任务中检索并注入给 Harness Agent。
-接下来通过三项相互独立、前后递进的实验，说明什么样的学习信号能形成有用 Memory，以及 Memory 最终如何改变留出文档的抽取行为。
-过渡： 先看结构化抽取真正困难的部分。</a:t>
+              <a:t>今天讨论一个具体问题：在结构化数据抽取场景中，Application/Orchestrator 应如何组织抽取与学习回路，使 Harness Agent 能复用过去任务中形成的方法，并在下一份文档中抽得更完整。
+这里的 Memory 不应只是保存历史业务答案。更有价值的做法是：Harness Agent 在源任务中形成可观察的 Review 轨迹，AgentCore Memory System 再使用内置 EPISODIC strategy 从 session events 中提炼 session-level episode 和 actor-level reflection。后续任务开始时，AgentCore Memory System 执行 Retrieval，Harness 集成层把返回的 records 放入新的 Harness Agent session 上下文。
+本次汇报包含三项边界独立、前后递进的实验：
+• 实验一由应用侧 Reflection LLM 和 Consolidation LLM 执行输出侧抽象自省；
+• 实验二由 Harness Agent 产生结构化 Self-review 轨迹，再由 AgentCore Memory System 提炼 EPISODIC records；
+• 实验三由 Application/Orchestrator 控制 Memory 开关，比较同一目标文档上的 Harness Agent 输出。
+过渡： 在讨论 Memory 之前，先明确 Harness Agent 在结构化抽取中最容易失败的地方。</a:t>
             </a:r>
             <a:endParaRPr lang="en-US" dirty="0"/>
           </a:p>
@@ -609,12 +612,13 @@
           <a:p>
             <a:r>
               <a:rPr lang="en-US" dirty="0"/>
-              <a:t>阶段一的执行主体是 Harness Agent。
-Harness Agent 在内部形成草稿，但不向用户输出草稿，只输出结构化 self_review。固定检查项包括 coverage、omissions、format、granularity 和 next_actions。
-阶段二仍由同一个 Harness Agent 执行。Harness Agent 重新读取原文和 self_review，逐项落实 next_actions，再输出最终五字段 JSON。
-这个设计不要求模型暴露完整思维过程。它要求 Harness Agent 产生一个可观察、可执行的 Review artifact，并在同一 session 中留下修订前后的因果轨迹。
-应用或 Harness 负责两阶段调用顺序和输出约束；此时 AgentCore Memory System 尚不负责抽取业务数据，也不替 Harness Agent 做 Review。
-过渡： 完整 session 结束后，AgentCore Memory System 才开始提炼这条轨迹。</a:t>
+              <a:t>第一阶段由 Application/Orchestrator 发起，由 Harness Agent 执行。
+Application/Orchestrator 向 Harness Agent 提供源文档和第一阶段指令。Harness Agent 在内部形成抽取草稿，但不把草稿作为最终答案返回；Harness Agent 对照原文检查 coverage、omissions、format 和 granularity，并输出结构化 self_review 与 next_actions。
+第二阶段仍由 Application/Orchestrator 发起，并由同一 source session 中的 Harness Agent 执行。
+Application/Orchestrator 把原文、结构化 self_review 和第二阶段输出约束提交给 Harness Agent。Harness Agent 逐项落实 next_actions，修订内部草稿，并输出最终五字段 JSON。
+这套设计不要求 Harness Agent 暴露完整思维过程；它要求 Harness Agent 留下一个可观察、可执行的 Review artifact。Application/Orchestrator 负责保证两个阶段的顺序和输入连续性。
+在两个阶段运行期间，AgentCore Memory System 的 event storage 保存 session events；AgentCore Memory System 此时不负责业务抽取，也不负责生成 self_review。托管 Extraction、Consolidation 和 Reflection 在完整轨迹形成后异步执行。
+过渡： source session 结束后，处理主体从 Harness Agent 切换为 AgentCore Memory System。</a:t>
             </a:r>
             <a:endParaRPr lang="en-US" dirty="0"/>
           </a:p>
@@ -703,14 +707,14 @@
             <a:r>
               <a:rPr lang="en-US" dirty="0"/>
               <a:t>这一页的执行主体是 AgentCore Memory System，策略类型是内置 EPISODIC strategy。
-Harness Agent 已经在 session events 中留下原文、结构化 self_review、最终 JSON 和任务结束信号。AgentCore Memory System 随后异步执行三个处理阶段：
-1. Episode Extraction：分析 session 中的行为、Review 与结果；
-2. Consolidation：形成 session-level episode；
-3. Reflection：从 episode 中抽象 actor-level 可复用策略。
-Session-level episode 的作用域是当前 actor 和 session，namespace 为 /episodes/{actorId}/{sessionId}。
-Actor-level reflection 的作用域是当前 actor，namespace 为 /episodes/{actorId}，用于后续 session 的跨任务召回。
-EPISODIC 提炼是异步过程，短 session 不保证一定生成 Memory。本次 13 页源任务提供了足够完整的执行轨迹。
-过渡： 下一页展示 AgentCore Memory System 实际生成的 records，而不是概念示例。</a:t>
+处理过程包含四个明确阶段：
+1. Event storage： AgentCore Memory System 按 actor 和 session 保存 Application/Orchestrator 与 Harness Agent 交互形成的 raw events，包括源文档输入、结构化 self_review、修订动作和最终 JSON。
+2. Extraction： AgentCore Memory System 从 source session events 中识别值得保留的任务过程、Review 发现、修订动作和结果。
+3. Consolidation： AgentCore Memory System 把当前 source session 的关键信息整理为 session-level episode，作用域为当前 actor/session，namespace 为 /episodes/{actorId}/{sessionId}。
+4. Reflection： AgentCore Memory System 从 episode 中抽象跨 session 可复用的方法，形成 actor-level reflection records，作用域为当前 actor，namespace 为 /episodes/{actorId}。
+这里的 Consolidation 和 Reflection 都属于 AgentCore Memory System 的托管 EPISODIC 处理，不是实验一中的应用侧 Consolidation LLM 与应用侧 Reflection LLM。
+EPISODIC 处理是异步的，短 session 不保证一定生成 records。本次 13 页源任务留下了原文、Review、修订和结果之间的完整轨迹，因此 AgentCore Memory System 最终形成了可检索记录。
+过渡： 下一页展示 AgentCore Memory System 实际形成的 record 数量、类型和作用域。</a:t>
             </a:r>
             <a:endParaRPr lang="en-US" dirty="0"/>
           </a:p>
@@ -798,14 +802,16 @@
           <a:p>
             <a:r>
               <a:rPr lang="en-US" dirty="0"/>
-              <a:t>AgentCore Memory System 的内置 EPISODIC strategy 最终生成了 1 条 session-level episode 和 2 条 actor-level reflections。
-Session-level episode 总结了本次任务发生了什么：Harness Agent 使用两阶段流程，先输出 self_review，再执行修订；面对 OCR 错误、章节跳号、重复表格和图片限制时，应显式处理并保留可追溯信息。
-两条 actor-level reflections 把本次经验抽象成未来可复用的方法：
-• Harness Agent 应先系统检查 coverage、omissions、format 和 granularity，再执行明确的 next_actions；
-• Harness Agent 应保留原文用于追溯，遇到冲突或无法完整结构化的内容时，不应静默丢弃信息。
-Episode 回答“这一次任务发生了什么”；actor reflection 回答“未来遇到类似任务时应该怎么做”。
-这些 records 的生成主体是 AgentCore Memory System，不是 Harness Agent 手工写入，也不是应用侧沿用实验一的自定义 canonical rules。
-过渡： 实验二到此只证明 Memory 已经形成；实验三才验证这些 records 是否会改变新文档的抽取。</a:t>
+              <a:t>AgentCore Memory System 使用内置 EPISODIC strategy，最终从 source session 中生成了：
+• 1 条 session-level episode，作用域是 actor ep-review-1789102186 的当前 source session；
+• 2 条 actor-level reflections，作用域是 actor ep-review-1789102186，可供该 actor 的后续新 session 检索。
+session-level episode 由 AgentCore Memory System 的 Consolidation 阶段形成，主要总结本次任务发生了什么：Harness Agent 使用两阶段流程，先输出结构化 self_review，再执行修订；Harness Agent 面对 OCR 错误、章节跳号、重复表格和图片限制时，应显式处理并保留可追溯信息。
+两条 actor-level reflections 由 AgentCore Memory System 的 Reflection 阶段形成，主要抽象未来可复用的方法：
+• Harness Agent 应系统检查 coverage、omissions、format 和 granularity，再执行明确的 next_actions；
+• Harness Agent 应保留原文用于 Reviewer/Human 追溯；遇到冲突或无法完整结构化的内容时，Harness Agent 不应静默丢弃信息。
+这些 records 的生成主体是 AgentCore Memory System。Harness Agent 提供的是 source session 行为轨迹，Application/Orchestrator 提供的是运行编排，Reviewer/Human 没有参与 record 撰写。
+实验二到此只证明托管 records 已形成，还没有证明这些 records 能提高新文档的抽取质量。
+过渡： 实验三把这组 records 带到一份留出文档，并通过 Memory 开关隔离其影响。</a:t>
             </a:r>
             <a:endParaRPr lang="en-US" dirty="0"/>
           </a:p>
@@ -893,12 +899,19 @@
           <a:p>
             <a:r>
               <a:rPr lang="en-US" dirty="0"/>
-              <a:t>这是第三项独立实验的章节页，也是效果验证实验。
-源任务仍是实验二的 13 页液氮罐技术要求；目标任务换成一页电机图纸“2477080009简图-8.16”，并使用全新的 runtime session。
-Harness Agent 在目标文档上执行抽取。Memory 组由 AgentCore Memory System 检索实验二形成的 EPISODIC records，并由 Harness 注入给 Harness Agent；No Memory 组完全禁用 Memory。
-本实验不再生成或比较新的自省规则，问题只有一个：在其他条件相同的情况下，Memory 注入是否改变 Harness Agent 对目标文档的覆盖重点。
-前后边界： 第 9 至第 12 页的实验二是 Memory 生成阶段；从本页到第 15 页是留出文档验证阶段。源任务的答案不会提供给目标任务，目标 Harness Agent 只接收托管 Memory 中的方法性 records。
-过渡： 为了让结果可解释，下一页先锁定控制变量。</a:t>
+              <a:t>实验三由 Application/Orchestrator 负责分组、配置和运行控制。
+源任务仍是实验二中的 13 页液氮罐技术要求；目标任务换成一页电机图纸“2477080009简图-8.16”。Application/Orchestrator 为 Memory 组和 No Memory 组分别创建全新的 target session。
+Memory 组的责任链是：
+1. Application/Orchestrator 使用 extractor_ep_review 和 source actor ep-review-1789102186 发起 target session；
+2. AgentCore Memory System 在 Retrieval 阶段按 actor 检索实验二形成的 EPISODIC records；
+3. Harness 集成层把 Retrieval 返回的方法性 records 放入目标 Harness Agent 的上下文；
+4. 目标 Harness Agent 阅读目标文档和注入的 Memory 上下文，执行抽取、内部自审并输出最终 JSON。
+No Memory 组的责任链是：
+1. Application/Orchestrator 使用 extractor_ep_review_nomem 发起另一条全新 target session；
+2. Application/Orchestrator 禁用 Harness Memory 配置，因此 AgentCore Memory System 不参与 Retrieval，目标 Harness Agent 不接收历史 records；
+3. 目标 Harness Agent 只依据目标文档和相同抽取指令完成抽取、内部自审并输出最终 JSON。
+Reviewer/Human 在两组输出完成后进行人工对比。本实验不让 Reviewer/Human 的评分参与前面的 Memory 形成过程。
+过渡： 为了把差异归因于 Memory 上下文，下一页逐项说明 Application/Orchestrator 锁定了哪些控制变量。</a:t>
             </a:r>
             <a:endParaRPr lang="en-US" dirty="0"/>
           </a:p>
@@ -986,19 +999,20 @@
           <a:p>
             <a:r>
               <a:rPr lang="en-US" dirty="0"/>
-              <a:t>两组目标抽取都由 Harness Agent 执行，并保持以下条件一致：
-• 相同的一页电机图纸；
-• 相同的 invocation-level system prompt；
-• 相同模型 claude-sonnet-4-6；
-• 相同 temperature=0；
-• 相同 maxTokens=32768；
-• 都禁用 Skill 和 tools；
-• 都使用全新 session；
-• 都执行单次抽取，并在内部自审后输出最终 JSON。
-唯一变量是 AgentCore Memory System 是否参与 Retrieval 和 context injection。
-Memory 组使用 extractor_ep_review，复用 source actor ep-review-1789102186。AgentCore Memory System 检索该 actor 的 EPISODIC records，Harness 将其注入目标 Harness Agent。
-No Memory 组使用 extractor_ep_review_nomem，Harness 的 Memory 配置为 disabled。
-过渡： 在这组严格对照下，最重要的结果不是格式差异，而是 Harness Agent 是否开始系统覆盖两张 BOM。</a:t>
+              <a:t>两组目标抽取都由 Harness Agent 执行；Application/Orchestrator 保持以下条件一致：
+• Application/Orchestrator 向两组提供相同的一页电机图纸；
+• Application/Orchestrator 向两组提供相同的 invocation-level system prompt；
+• Application/Orchestrator 为两组配置相同模型 claude-sonnet-4-6；
+• Application/Orchestrator 为两组配置相同的 temperature=0；
+• Application/Orchestrator 为两组配置相同的 maxTokens=32768；
+• Application/Orchestrator 为两组禁用 Skill 和 tools；
+• Application/Orchestrator 为两组分别创建全新 target session；
+• 两组 Harness Agent 都执行单次抽取，并在内部自审后输出最终 JSON。
+唯一变量是托管 Memory 链路：
+• Memory 组中，AgentCore Memory System 执行 EPISODIC Retrieval，Harness 集成层把返回 records 放入 Harness Agent 上下文；
+• No Memory 组中，Application/Orchestrator 禁用 Memory，因此 AgentCore Memory System 不执行目标端 Retrieval，Harness Agent 不接收历史 records。
+Application/Orchestrator 记录两组最终输出；Reviewer/Human 再对照目标原文检查新增记录是否有依据。记录条数本身不是自动质量评分。
+过渡： 在这组控制条件下，最重要的观察是 Harness Agent 是否开始系统覆盖两张 BOM。</a:t>
             </a:r>
             <a:endParaRPr lang="en-US" dirty="0"/>
           </a:p>
@@ -1087,13 +1101,18 @@
             <a:r>
               <a:rPr lang="en-US" dirty="0"/>
               <a:t>这是全套实验最重要的一页。
-首次运行中，Memory 组由 Harness Agent 输出 31 条记录；No Memory 组由 Harness Agent 输出 11 条记录。这里不能表述为“质量提升三倍”，因为条数不是质量分数。
-真正值得关注的是新增内容的来源。Memory 组多出的约 20 条记录主要来自图纸中的两张 BOM，Harness Agent 系统展开了其中的零部件和组件，例如机座、前端盖、转子、轴承、壳体组件、法兰盘组件和散热器组件。
-No Memory 组主要关注标题栏和技术要求，只零散抽取了少量数量信息，没有同样系统地展开两张 BOM。
-人眼核对后，这些新增条目基本能够在原文表格中找到依据，并非明显臆造。但这仍然不代表每一条都符合最终业务边界，条目是否应纳入正式结果仍需 Reviewer 或人工评审。
-因此，本页的准确结论是：
-AgentCore Memory System 注入方法性 EPISODIC records 后，Harness Agent 改变了对“什么值得结构化”的判断，并显著扩大了对两张 BOM 的覆盖。
-过渡： 把三项实验放在一起，可以得到一个比“Memory 有效或无效”更具体的结论。</a:t>
+首次运行中：
+• Memory 组的目标 Harness Agent 输出 31 条记录；
+• No Memory 组的目标 Harness Agent 输出 11 条记录。
+这两个数字由 Application/Orchestrator 从两组最终 JSON 中统计。它们表示记录数量，不表示质量分数，因此不能表述为“质量提升三倍”。
+真正关键的差异来自内容覆盖：
+• Memory 组中，AgentCore Memory System 先执行 Retrieval，Harness 集成层把方法性 EPISODIC records 放入目标 Harness Agent 上下文；目标 Harness Agent 随后系统展开了图纸中的两张 BOM；
+• No Memory 组中，目标 Harness Agent 主要关注标题栏和技术要求，只零散抽取少量数量信息，没有同样系统地展开两张 BOM。
+Memory 组新增的约 20 条记录主要包括机座、前端盖、转子、轴承、壳体组件、法兰盘组件和散热器组件等零部件与组件。
+Reviewer/Human 对照目标图纸后认为，这些新增条目基本能够在两张 BOM 中找到原文依据，并非明显臆造。但 Reviewer/Human 仍需判断每个零部件是否属于最终业务边界，以及拆分粒度是否符合实际使用要求。
+因此，本页能够支持的准确结论是：
+在这份留出文档上，AgentCore Memory System 检索方法性 EPISODIC records，并由 Harness 集成层将其提供给目标 Harness Agent 后，目标 Harness Agent 改变了对“什么值得结构化”的判断，输出从 11 条变为 31 条，新增内容主要来自两张 BOM。
+过渡： 最后一部分把三项实验的主体、证据和结论边界合并起来。</a:t>
             </a:r>
             <a:endParaRPr lang="en-US" dirty="0"/>
           </a:p>
@@ -1181,15 +1200,18 @@
           <a:p>
             <a:r>
               <a:rPr lang="en-US" dirty="0"/>
-              <a:t>实验一说明：当反思模型只看 Harness Agent 输出时，自定义 canonical memory 会学到格式、规范化和拆分规则，但无法稳定发现完全遗漏的文档区域，条数增长也可能来自过度拆分。
-实验二说明：当 Harness Agent 同时查看原文和内部草稿，并输出结构化 self_review 与可执行 next_actions 时，完整 session 能为 AgentCore Memory System 的内置 EPISODIC strategy 提供更有价值的提炼轨迹。
-实验三说明：AgentCore Memory System 在目标任务中检索并注入这些方法性 records 后，Harness Agent 的关注点发生变化；在一页电机图纸上，输出从 11 条变为 31 条，新增内容主要来自两张 BOM，且人眼看基本有原文依据。
-统一结论不是“有 Memory 就一定更好”，而是：
-• Memory 的价值取决于上游 Review 是否获得了足够的事实信号；
-• 源覆盖问题适合由原文驱动的结构化 Self-review 改善；
-• AgentCore EPISODIC Memory 适合沉淀和跨 session 复用方法；
-• 任务边界与最终质量判断仍需规范、Reviewer 或人工反馈。
-过渡： 最后把这些发现收敛成可执行的工程实践。</a:t>
+              <a:t>实验一的主体与结论：
+Harness Agent 先输出抽取结果；应用侧 Reflection LLM 只阅读已有输出并归纳候选规则；应用侧 Consolidation LLM 合并 canonical rules；Application/Orchestrator 把规则提供给下一轮 Harness Agent。这套回路学到了格式、规范化和拆分方法，但因为应用侧 Reflection LLM 看不到原文，所以无法稳定发现整块遗漏，90→102 也主要体现拆分变细。
+实验二的主体与结论：
+Application/Orchestrator 组织两阶段调用；Harness Agent 同时查看原文和内部草稿，输出结构化 self_review，再根据 next_actions 修订；AgentCore Memory System 保存 source session events，并使用内置 EPISODIC strategy 执行 Extraction、Consolidation 和 Reflection。这条源任务轨迹最终形成 1 条 session-level episode 和 2 条 actor-level reflections。
+实验三的主体与结论：
+Application/Orchestrator 控制目标端变量；AgentCore Memory System 只在 Memory 组执行 Retrieval；Harness 集成层只在 Memory 组把 records 放入目标 Harness Agent 上下文；两组 Harness Agent 分别输出最终 JSON。结果是 31 条对 11 条，新增内容主要来自两张 BOM；Reviewer/Human 核对后认为新增内容基本有原文依据。
+三项实验共同支持的结论是：
+• Harness Agent 的源覆盖能力取决于 Review 是否能同时看到原文和内部草稿；
+• AgentCore Memory System 的价值取决于 source session 是否包含足够清晰的 Review 与修订轨迹；
+• AgentCore Memory System 的 EPISODIC records 可以跨 session 复用方法，但不能替 Reviewer/Human 定义任务边界；
+• 在本次单个留出文档实验中，Memory 上下文改变了目标 Harness Agent 的覆盖重点，但仍需要更多文档与人工评审验证泛化性。
+过渡： 最后一页把这些角色分工收敛成可执行的工程实践。</a:t>
             </a:r>
             <a:endParaRPr lang="en-US" dirty="0"/>
           </a:p>
@@ -1277,15 +1299,16 @@
           <a:p>
             <a:r>
               <a:rPr lang="en-US" dirty="0"/>
-              <a:t>第一，Harness Agent 的 Review 必须同时查看原文和内部草稿，不能只看已有输出做抽象总结。
-第二，Harness Agent 应输出结构化 Review artifact，固定检查覆盖、遗漏、格式和粒度，并形成明确、可执行的 next_actions。
-第三，应用或 Harness 应明确控制两阶段调用、结束信号和实验变量，不要把编排动作误写成 Memory System 的能力。
-第四，AgentCore Memory System 使用内置 EPISODIC strategy 时，应明确区分 session-level episode 与 actor-level reflection，以及 Extraction、Consolidation、Reflection 和 Retrieval 各阶段。
-第五，AgentCore Memory System 保存和检索的重点应是方法性经验，而不是历史业务答案；Harness 将检索结果注入新的 Harness Agent session。
-第六，团队应区分源覆盖问题和任务边界问题。前者可以通过原文驱动的 Self-review 改善，后者仍需任务规范、Reviewer 或人工反馈。
-第七，评估时不能把记录条数直接当作质量分数。Reviewer 应分别检查忠实性、完整性、粒度、过度抽取和业务边界。
+              <a:t>第一，Application/Orchestrator 应把源任务 Review 设计成明确的两阶段调用，并保证原文、结构化 self_review 和 next_actions 在同一 source session 中形成连续轨迹。
+第二，Harness Agent 的 Review 必须同时查看原文和内部草稿；Harness Agent 应固定检查 coverage、omissions、format 和 granularity，再根据明确的 next_actions 修订最终 JSON。
+第三，应用侧 Reflection LLM 与应用侧 Consolidation LLM 适合维护自定义规则，但团队必须明确：这两种应用侧调用不是 AgentCore Memory System 内置 EPISODIC strategy 的 Reflection 与 Consolidation。
+第四，AgentCore Memory System 使用内置 EPISODIC strategy 时，团队应分别观察 event storage、Extraction、Consolidation、Reflection 和 Retrieval，并明确 session-level episode 与 actor-level reflection 的作用域。
+第五，后续任务开始时，AgentCore Memory System 负责按 actor 执行 Retrieval；Harness 集成层负责把返回 records 放入新的 Harness Agent session 上下文；新的 Harness Agent 仍应依据当前文档原文完成抽取，不能复制历史业务答案。
+第六，Application/Orchestrator 应在对照实验中分别控制 source actor、target session、prompt、模型参数、tools、Skill 和 Memory 开关，避免把编排差异误判为 Memory 效果。
+第七，Reviewer/Human 应分别检查忠实性、完整性、粒度、过度抽取和业务边界，不能把规则数量或输出记录数量直接当作质量分数。
 最终 takeaway 是：
-Memory 的价值不是让 Harness Agent 记住上一份答案，而是让 AgentCore Memory System 复用一次高质量 Review 中形成的抽取方法。</a:t>
+Harness Agent 负责产生高质量 Review 轨迹，AgentCore Memory System 负责把轨迹提炼并跨 session 检索，Harness 集成层负责把检索 records 提供给新的 Harness Agent，Reviewer/Human 负责判断这些方法是否真正改善了业务结果。
+过渡（收束）： 本次最有价值的证据不是“Memory 里多了几条记录”，而是同一目标任务中，接收方法性 EPISODIC records 的 Harness Agent 系统覆盖了两张 BOM，并输出 31 条；未接收 Memory 的 Harness Agent 输出 11 条。</a:t>
             </a:r>
             <a:endParaRPr lang="en-US" dirty="0"/>
           </a:p>
@@ -1373,11 +1396,14 @@
           <a:p>
             <a:r>
               <a:rPr lang="en-US" dirty="0"/>
-              <a:t>当前模型生成合法 JSON 并不困难，真正困难的是完整性。
-工业文档的信息可能分散在正文、技术要求、BOM 表格、附注、图纸说明和 OCR 结果中。Harness Agent 往往优先关注明显的参数和数值，却可能把整张 BOM 或整个章节当成背景材料。
-因此，结果即使格式完全正确，也可能只覆盖技术要求，没有覆盖表格中的零部件和组件。
-核心挑战不是“Harness Agent 能不能输出 JSON”，而是“Harness Agent 如何发现自己漏了什么，并把这种发现带到下一次任务中”。
-过渡： 这决定了 Memory 在抽取回路中应该承担什么角色。</a:t>
+              <a:t>Harness Agent 使用的模型生成合法 JSON 并不困难，真正困难的是完整性。
+工业文档的信息可能分散在正文、技术要求、BOM 表格、附注、图纸说明和 OCR 结果中。Harness Agent 往往优先识别明显的参数和数值，却可能把整张 BOM、某个章节或图片区域当成背景材料。
+因此，Harness Agent 输出的 JSON 即使格式完全正确，也可能只覆盖技术要求，没有覆盖表格中的零部件和组件。
+这里需要区分两个责任：
+• Harness Agent 负责在给定任务定义下识别、审查并结构化原文信息；
+• Reviewer/Human 负责判断哪些内容属于业务目标，以及某段原文应该合并还是拆分。
+核心挑战不是“Harness Agent 能不能输出 JSON”，而是“Harness Agent 如何发现自己漏了什么，Application/Orchestrator 又如何把这种发现变成后续任务可复用的学习信号”。
+过渡： 这决定了抽取回路中每个组件应该承担什么责任。</a:t>
             </a:r>
             <a:endParaRPr lang="en-US" dirty="0"/>
           </a:p>
@@ -1465,15 +1491,15 @@
           <a:p>
             <a:r>
               <a:rPr lang="en-US" dirty="0"/>
-              <a:t>Harness Agent 先执行抽取和 Review；AgentCore Memory System 再保存 session events，并根据配置的策略提炼可复用记录。
-在后续任务开始前，AgentCore Memory System 检索相关记录，Harness 将这些记录作为上下文注入新的 Harness Agent session。
-有价值的 Memory 应描述方法，例如：
-• Harness Agent 应检查哪些文档区域；
-• Harness Agent 应如何处理遗漏、冲突和重复；
-• Harness Agent 输出前应执行哪些明确动作；
-• Harness Agent 应如何选择抽取粒度。
-Memory 不应直接复制上一份文档的业务答案，因为历史答案既占上下文，也可能误导新任务。
-过渡： 为了判断哪种方法有效，我们把探索拆成三项边界清晰的实验。</a:t>
+              <a:t>这一页的五个步骤应按以下端到端责任链理解：
+1. 当前文档与抽取草稿： Application/Orchestrator 把当前文档、抽取指令和运行配置提交给 Harness Agent；Harness Agent 阅读原文并形成内部抽取草稿。
+2. Review： Harness Agent 对照原文检查草稿的覆盖、遗漏、格式、粒度和冲突，并形成结构化 self_review 与可执行的 next_actions。
+3. 可复用经验： Harness Agent 根据 next_actions 修订并输出最终 JSON；同时，AgentCore Memory System 的 event storage 保存该 actor/session 中的原文输入、Review artifact、修订动作和最终输出等 events。
+4. Memory： 源 session 结束后，AgentCore Memory System 使用内置 EPISODIC strategy 异步执行 Extraction、Consolidation 和 Reflection，分别形成 session-level episode 与 actor-level reflection records。
+5. 下一份文档： Application/Orchestrator 使用同一 actor 创建新的 session 并提交下一份文档；AgentCore Memory System 执行 Retrieval，Harness 集成层把检索到的方法性 records 放入目标 Harness Agent 的上下文；Harness Agent 再根据新文档原文完成抽取、自审和最终输出。
+最后，Reviewer/Human 对目标输出进行忠实性、完整性、粒度和业务边界评判。Reviewer/Human 的判断不能由记录条数替代。
+因此，AgentCore Memory System 保存和检索的重点应是“容易漏什么、应该检查什么、下一次应该执行什么动作”等方法性经验，而不是上一份文档的业务答案。
+过渡： 为了验证这条责任链，我们把探索拆成三项主体、输入和产物都不同的实验。</a:t>
             </a:r>
             <a:endParaRPr lang="en-US" dirty="0"/>
           </a:p>
@@ -1561,12 +1587,28 @@
           <a:p>
             <a:r>
               <a:rPr lang="en-US" dirty="0"/>
-              <a:t>三项实验回答三个不同问题。
-实验一研究“只看输出能学到什么”。应用侧把 Harness Agent 的已有输出交给反思模型，再通过自定义 consolidation 维护 canonical memory，观察规则和抽取结果如何变化。
-实验二研究“怎样产生可被托管 Memory 提炼的轨迹”。Harness Agent 同时查看原文和内部草稿，执行两阶段结构化 Self-review；AgentCore Memory System 使用内置 EPISODIC strategy 提炼完整 session。
-实验三研究“已有 Memory 是否改变下一份文档的抽取”。Harness Agent 在留出文档上执行 Memory 开关对照；AgentCore Memory System 只在 Memory 组检索并注入 records。
-三项实验依次对应：抽象规则学习、源任务 Memory 生成、目标任务效果验证。
-过渡： 先进入实验一，只允许反思模型看到已经抽出的输出。</a:t>
+              <a:t>三项实验的端到端流程如下。
+实验一：输出侧抽象自省。
+1. Application/Orchestrator 调用 Harness Agent 执行一轮文档抽取；
+2. Application/Orchestrator 只把该轮已有抽取输出交给应用侧 Reflection LLM，不提供原文；
+3. 应用侧 Reflection LLM 从已有输出中归纳候选规则；
+4. Application/Orchestrator 把旧规则和新候选规则交给应用侧 Consolidation LLM；
+5. 应用侧 Consolidation LLM 合并、去重并输出 canonical rules；
+6. Application/Orchestrator 把 canonical rules 作为下一轮抽取的附加指导，再次调用 Harness Agent。
+实验一形成的是应用侧自定义规则记忆，不是 AgentCore Memory System 内置 EPISODIC records。
+实验二：源任务产生托管 EPISODIC Memory。
+1. Application/Orchestrator 把 13 页液氮罐文档提交给 Harness Agent；
+2. Harness Agent 在同一 source session 中先输出结构化 self_review，再根据 next_actions 修订并输出最终 JSON；
+3. AgentCore Memory System 的 event storage 保存该 source session 的 events；
+4. AgentCore Memory System 使用内置 EPISODIC strategy 执行 Extraction、Consolidation 和 Reflection，生成 1 条 session-level episode 和 2 条 actor-level reflections。
+实验三：留出文档 Memory 开关对照。
+1. Application/Orchestrator 为 Memory 组和 No Memory 组分别创建全新 target session，并保持目标文档、prompt、模型参数及工具配置一致；
+2. Memory 组中，AgentCore Memory System 执行 Retrieval，Harness 集成层把检索 records 放入目标 Harness Agent 上下文；
+3. No Memory 组中，Application/Orchestrator 禁用 Harness Memory 配置，因此 Harness Agent 不接收任何历史 records；
+4. 两组 Harness Agent 分别完成抽取、自审和最终 JSON 输出；
+5. Reviewer/Human 对两组结果进行原文核对和业务边界判断。
+三项实验依次回答：应用侧抽象规则能学到什么、托管 Memory 如何形成、托管 Memory 是否改变新任务中的抽取行为。
+过渡： 先进入实验一，明确“只看输出的抽象自省”究竟由谁执行。</a:t>
             </a:r>
             <a:endParaRPr lang="en-US" dirty="0"/>
           </a:p>
@@ -1654,12 +1696,16 @@
           <a:p>
             <a:r>
               <a:rPr lang="en-US" dirty="0"/>
-              <a:t>这是第一项独立实验的章节页。
-实验一的输入边界是：反思模型只能看到 Harness Agent 已经抽出的结果，看不到原文，也看不到被完全遗漏的章节或表格。
-应用侧负责调用反思模型生成规则，再调用 consolidation prompt 合并、去重并维护 canonical memory。这里形成的是自定义规则记忆，不是 AgentCore Memory System 内置 EPISODIC strategy 生成的 episode 或 reflection。
-本实验的目标是判断：仅依赖输出侧自省，规则是否会逐轮收敛，以及抽取数量增加究竟代表覆盖提升还是拆分变细。
-前后边界： 前四页是问题定义和实验地图；从本页到第 8 页只讨论实验一。第 9 页开始切换到新的源任务流程，不沿用实验一的输入条件。
-过渡： 下一页先展示实验一真实使用的 reflection 与 consolidation prompt。</a:t>
+              <a:t>本页所说的“抽象自省”不是 Harness Agent 在同一次抽取中对照原文做 Self-review，也不是 AgentCore Memory System 的 Reflection 阶段。
+实验一中的主体分工是：
+• Harness Agent 只负责先完成文档抽取并输出结构化结果；
+• Application/Orchestrator 只收集 Harness Agent 已经输出的结果；
+• 应用侧 Reflection LLM 只阅读这些已有输出，并生成候选抽取规则；
+• 应用侧 Consolidation LLM 把候选规则与已有规则合并为 canonical rules；
+• Application/Orchestrator 保存 canonical rules，并在下一轮调用中把这些规则提供给 Harness Agent。
+应用侧 Reflection LLM 看不到原文，因此它也看不到 Harness Agent 完全遗漏的章节、表格或图片区域。本实验测试的是“输出侧规则归纳能力”，而不是“原文覆盖检查能力”。
+实验边界： 第 5 至第 8 页只讨论应用侧自定义 Reflection/Consolidation 回路；这一回路没有使用 AgentCore Memory System 内置 EPISODIC strategy。
+过渡： 下一页展示的两个 Prompt，分别属于应用侧 Reflection LLM 和应用侧 Consolidation LLM。</a:t>
             </a:r>
             <a:endParaRPr lang="en-US" dirty="0"/>
           </a:p>
@@ -1747,11 +1793,13 @@
           <a:p>
             <a:r>
               <a:rPr lang="en-US" dirty="0"/>
-              <a:t>第一步，应用侧把某轮 Harness Agent 输出交给反思模型。Reflection prompt 要求模型总结不超过十条、可用于未来任务的规则。
-第二步，应用侧把已有规则和新规则一起交给 consolidation 模型。Consolidation prompt 负责合并同义项、删除重复项，并把规则集控制在十五条以内。
-这个流程每轮都能产生新的规则，而且规则会持续合并，因此形式上像一个自进化闭环。
-但反思模型的观察范围只包含“已经抽出来的内容”。如果 Harness Agent 完全漏掉了一张 BOM，这张表不会出现在输出里，反思模型也无法从缺失信息中推导出遗漏。
-过渡： 因此要同时看规则内容、抽取条数和原文覆盖，而不能只看 Memory 数量。</a:t>
+              <a:t>左侧 Reflection Prompt 的执行主体是应用侧 Reflection LLM。
+Application/Orchestrator 把某一轮 Harness Agent 的抽取输出作为 Reflection Prompt 的输入。应用侧 Reflection LLM 根据“每条必须可操作、只讲规则、不讲具体数值、不超过十条”等要求，生成本轮候选规则。
+右侧 Consolidation Prompt 的执行主体是另一次应用侧 Consolidation LLM 调用。
+Application/Orchestrator 把已有 canonical rules 和本轮候选规则一起提交给应用侧 Consolidation LLM。应用侧 Consolidation LLM 负责合并同义项、删除重复项，并把最终规则集控制在十五条以内。Application/Orchestrator 再保存新的 canonical rules，并将其提供给下一轮 Harness Agent 抽取。
+这个应用侧闭环每轮都能形成新的规则，但它有一个结构性限制：应用侧 Reflection LLM 只能观察 Harness Agent 已经输出的内容。如果 Harness Agent 完全漏掉一张 BOM，该 BOM 不会进入 Reflection Prompt，应用侧 Reflection LLM 就没有事实依据发现这块遗漏。
+这里的 Reflection 和 Consolidation 都是应用侧 LLM 调用，不是 AgentCore Memory System 内置 EPISODIC strategy 中的 Reflection 或 Consolidation 阶段。
+过渡： 接下来检查应用侧 Consolidation LLM 最终保留了什么，以及这些规则实际改变了什么。</a:t>
             </a:r>
             <a:endParaRPr lang="en-US" dirty="0"/>
           </a:p>
@@ -1839,26 +1887,27 @@
           <a:p>
             <a:r>
               <a:rPr lang="en-US" dirty="0"/>
-              <a:t>四轮 consolidation 最终形成了完整的 15 条 canonical memory：
-1. 先识别指标所属主体，避免把部件指标错误归到整机；
-2. 整体性能指标与部件性能指标分别记录；
-3. 运输、交付和包装要求独立成条；
-4. 子系统、附件和独立部件的要求分别记录；
-5. 同一句涉及多个部件时，按部件拆分记录；
-6. 同一句包含多个指标时，按指标拆分记录；
-7. 指标名称应规范化，避免把完整句子直接作为名称；
-8. 接管、接口和连接要求按接口对象分别记录；
-9. 阀门、仪表和附件清单中的对象分别记录；
-10. 不同部位、不同层次的材料要求分别记录；
-11. 无损检测方法、比例、级别和标准应完整保留；
-12. 制造工艺和结构要求应与性能指标区分；
-13. 上下限、范围及大于小于符号必须忠实保留；
-14. 功能性和描述性要求不能因为缺少数值而忽略；
-15. 每条结果保留对应原文，支持追溯和复核。
-这些规则并非都没有价值。限值符号保留、描述性要求保留和原文追溯都是合理的质量要求。
-但规则集中有多条持续强调“分别成条”和“独立拆分”。四轮抽取条数从 90、93、95 增加到 102，最终 102 条只来自约 53 个唯一原文片段，平均每段原文被拆成 1.92 条。
-因此，90→102 主要反映拆分粒度变细，不能直接证明覆盖了更多文档区域。
-过渡： 实验一的结果需要用两类错误来解释。</a:t>
+              <a:t>四轮运行后，应用侧 Consolidation LLM 最终输出了 15 条 canonical rules；Application/Orchestrator 把这 15 条规则作为自定义规则记忆维护，并提供给后续 Harness Agent 调用。
+这 15 条规则主要覆盖以下方法：
+1. Harness Agent 应先识别指标所属主体；
+2. Harness Agent 应区分整体性能与部件性能；
+3. Harness Agent 应把运输、交付和包装要求独立记录；
+4. Harness Agent 应把子系统、附件和独立部件分别记录；
+5. Harness Agent 遇到多部件语句时应按部件拆分；
+6. Harness Agent 遇到复合指标时应按指标拆分；
+7. Harness Agent 应规范化指标名称；
+8. Harness Agent 应按接口对象记录接管和连接要求；
+9. Harness Agent 应分别记录阀门、仪表和附件清单对象；
+10. Harness Agent 应区分不同部位和层次的材料要求；
+11. Harness Agent 应完整保留无损检测方法、比例、级别和标准；
+12. Harness Agent 应区分制造工艺、结构要求和性能指标；
+13. Harness Agent 应忠实保留上下限、范围及比较符号；
+14. Harness Agent 不应因缺少数值而忽略功能性和描述性要求；
+15. Harness Agent 应保留对应原文，支持 Reviewer/Human 追溯。
+这些规则并非没有价值。限值符号保留、描述性要求保留和原文追溯都是合理的质量要求。
+但多条规则持续要求 Harness Agent “分别成条”或“独立拆分”。Application/Orchestrator 记录到四轮输出条数从 90、93、95 增加到 102；最终 102 条只对应约 53 个唯一原文片段，平均每段原文被拆成 1.92 条。
+因此，Reviewer/Human 不能把 90→102 直接解释为覆盖提升。现有数据更支持“应用侧规则让 Harness Agent 的拆分粒度变细”。
+过渡： 实验一的局限，需要通过“源覆盖问题”和“任务边界问题”来解释。</a:t>
             </a:r>
             <a:endParaRPr lang="en-US" dirty="0"/>
           </a:p>
@@ -1946,11 +1995,16 @@
           <a:p>
             <a:r>
               <a:rPr lang="en-US" dirty="0"/>
-              <a:t>第一类是源覆盖问题：信息明确存在于原文，但 Harness Agent 没有输出，例如漏掉 BOM、漏掉章节、重复记录或字段为空。
-第二类是任务边界问题：Harness Agent 不知道某类内容是否属于目标，或者不知道一段原文应该拆成几条。这需要任务规范、Reviewer 或人工反馈。
-实验一说明，只看输出的抽象自省可以改善格式、规范化和局部拆分规则，但无法稳定发现完全未进入输出的区域。规则增加和条数增加也可能只是过度拆分。
-因此，正确结论不是“Self-reflection 没用”，而是“只看输出时，反思模型获得的学习信号不足”。
-过渡： 实验二改变输入条件，让 Harness Agent 的 Review 同时看到原文和内部草稿。</a:t>
+              <a:t>实验一暴露了两类不同错误。
+第一类是源覆盖问题。 原文中明确存在信息，但 Harness Agent 没有输出，例如整张 BOM、某个章节或某类附注被完全遗漏。要发现这类问题，执行 Review 的主体必须同时看到原文和内部草稿。应用侧 Reflection LLM 在实验一中只看已有输出，因此无法稳定发现完全未进入输出的区域。
+第二类是任务边界问题。 例如某类内容是否属于目标、某段原文应该合并还是拆分、BOM 零部件是否都应进入正式结果。这类判断需要任务规范，最终应由 Reviewer/Human 或明确的业务 rubric 给出事实信号。
+实验一能够支持的结论是：
+• 应用侧 Reflection LLM 可以从已有输出中归纳格式、命名、追溯和局部拆分规则；
+• 应用侧 Consolidation LLM 可以把候选规则压缩成稳定的 canonical rules；
+• 但当应用侧 Reflection LLM 看不到原文时，这套回路无法稳定发现整块遗漏；
+• Application/Orchestrator 观察到的规则数或记录数增长，不能替代 Reviewer/Human 对原文覆盖的检查。
+因此，正确结论不是“Reflection 没用”，而是“输出侧 Reflection 的事实输入不足以解决源覆盖问题”。
+过渡： 实验二改变 Review 的输入条件：由 Harness Agent 同时查看原文和内部草稿，并留下可被 AgentCore Memory System 提炼的完整轨迹。</a:t>
             </a:r>
             <a:endParaRPr lang="en-US" dirty="0"/>
           </a:p>
@@ -2038,12 +2092,17 @@
           <a:p>
             <a:r>
               <a:rPr lang="en-US" dirty="0"/>
-              <a:t>这是第二项独立实验的章节页。
-实验二不再沿用实验一“只看输出”的抽象自省。Harness Agent 在同一个源任务 session 中读取 13 页液氮罐技术要求，先形成内部草稿，再输出结构化 self_review，最后根据 next_actions 修订并输出最终 JSON。
-Harness Agent 负责抽取、自审和修订；AgentCore Memory System 负责保存 session events，并使用内置 EPISODIC strategy 异步执行 Extraction、Consolidation 和 Reflection。
-本实验的目标不是直接比较最终条数，而是构造一条包含“原文、Review、修订结果”的高质量轨迹，观察托管 Memory 能否从中提炼出 episode 和 actor-level reflections。
-前后边界： 第 5 至第 8 页的实验一到此结束；第 9 至第 12 页只讨论源任务如何产生托管 Memory。第 13 页才开始在另一份留出文档上验证效果。
-过渡： 下一页先看 Harness Agent 如何执行两阶段 Self-review。</a:t>
+              <a:t>实验二不再使用实验一的输出侧抽象自省回路。
+实验二的端到端流程是：
+1. Application/Orchestrator 选择 13 页液氮罐技术要求作为 source document，并为 actor ep-review-1789102186 创建 source session；
+2. Application/Orchestrator 在第一阶段调用 Harness Agent，要求 Harness Agent 阅读原文、形成内部草稿，并只输出结构化 self_review；
+3. Application/Orchestrator 在第二阶段把原文和 self_review.next_actions 继续提供给同一 source session 中的 Harness Agent；
+4. Harness Agent 根据 next_actions 修订内部草稿并输出最终 JSON；
+5. AgentCore Memory System 的 event storage 保存 source session 中的输入、self_review、修订请求和最终输出等 events；
+6. source session 形成完整轨迹后，AgentCore Memory System 使用内置 EPISODIC strategy 异步执行 Extraction、Consolidation 和 Reflection。
+Harness Agent 负责业务抽取、自审和修订；Application/Orchestrator 负责两阶段调用顺序、输出约束和 session 控制；AgentCore Memory System 不替 Harness Agent 抽取业务字段，也不替 Reviewer/Human 判断业务边界。
+实验边界： 第 9 至第 12 页只讨论 source session 如何形成托管 EPISODIC records；目标文档的效果验证从第 13 页开始。
+过渡： 下一页聚焦两阶段流程中 Application/Orchestrator 与 Harness Agent 各自执行的动作。</a:t>
             </a:r>
             <a:endParaRPr lang="en-US" dirty="0"/>
           </a:p>
@@ -2590,7 +2649,7 @@
                 <a:ea typeface="Microsoft YaHei" pitchFamily="34" charset="-122"/>
                 <a:cs typeface="Microsoft YaHei" pitchFamily="34" charset="-120"/>
               </a:rPr>
-              <a:t>怎样让 Agent 从一次抽取中学习，并在下一份文档中抽得更完整？</a:t>
+              <a:t>怎样让 Harness Agent 从一次抽取中学习，并在下一份文档中抽得更完整？</a:t>
             </a:r>
             <a:endParaRPr lang="en-US" sz="1800" dirty="0"/>
           </a:p>
@@ -2656,7 +2715,7 @@
                 <a:ea typeface="Amazon Ember Display" pitchFamily="34" charset="-122"/>
                 <a:cs typeface="Amazon Ember Display" pitchFamily="34" charset="-120"/>
               </a:rPr>
-              <a:t>核心：把 Review 中发现的遗漏模式与处理策略，转化为可复用的 Memory。</a:t>
+              <a:t>核心：Harness Agent 产出 Review 轨迹；AgentCore Memory System 把轨迹提炼为可复用 Records。</a:t>
             </a:r>
             <a:endParaRPr lang="en-US" sz="2000" dirty="0"/>
           </a:p>
@@ -2695,7 +2754,7 @@
                 <a:ea typeface="Microsoft YaHei" pitchFamily="34" charset="-122"/>
                 <a:cs typeface="Microsoft YaHei" pitchFamily="34" charset="-120"/>
               </a:rPr>
-              <a:t>基于真实工业文档抽取实验 · AgentCore Harness + EPISODIC Memory</a:t>
+              <a:t>基于真实工业文档实验 · Application 编排 + Harness Agent 抽取 + AgentCore Memory EPISODIC</a:t>
             </a:r>
             <a:endParaRPr lang="en-US" sz="1200" dirty="0"/>
           </a:p>
@@ -2946,7 +3005,7 @@
                 <a:ea typeface="Amazon Ember Display" pitchFamily="34" charset="-122"/>
                 <a:cs typeface="Amazon Ember Display" pitchFamily="34" charset="-120"/>
               </a:rPr>
-              <a:t>Harness Agent：两阶段结构化 Self-review</a:t>
+              <a:t>Harness Agent：两阶段 Self-review</a:t>
             </a:r>
             <a:endParaRPr lang="en-US" sz="2700" dirty="0"/>
           </a:p>
@@ -2985,7 +3044,7 @@
                 <a:ea typeface="Microsoft YaHei" pitchFamily="34" charset="-122"/>
                 <a:cs typeface="Microsoft YaHei" pitchFamily="34" charset="-120"/>
               </a:rPr>
-              <a:t>两个阶段均由 Harness Agent 执行；产物写入同一 runtime session，等待 Memory System 后台提炼。</a:t>
+              <a:t>Application 连续调用同一 Harness Agent；Harness Agent 执行自审与修订；Memory System 保存同一 session 的 events。</a:t>
             </a:r>
             <a:endParaRPr lang="en-US" sz="1400" dirty="0"/>
           </a:p>
@@ -3051,7 +3110,7 @@
                 <a:ea typeface="Amazon Ember Display" pitchFamily="34" charset="-122"/>
                 <a:cs typeface="Amazon Ember Display" pitchFamily="34" charset="-120"/>
               </a:rPr>
-              <a:t>HARNESS AGENT · 阶段一 Prompt</a:t>
+              <a:t>APPLICATION 调用 → HARNESS AGENT 阶段一</a:t>
             </a:r>
             <a:endParaRPr lang="en-US" sz="1150" dirty="0"/>
           </a:p>
@@ -3359,7 +3418,7 @@
                 <a:ea typeface="Amazon Ember Display" pitchFamily="34" charset="-122"/>
                 <a:cs typeface="Amazon Ember Display" pitchFamily="34" charset="-120"/>
               </a:rPr>
-              <a:t>HARNESS AGENT · 阶段二 Prompt</a:t>
+              <a:t>APPLICATION 调用 → HARNESS AGENT 阶段二</a:t>
             </a:r>
             <a:endParaRPr lang="en-US" sz="1150" dirty="0"/>
           </a:p>
@@ -3622,7 +3681,7 @@
                 <a:ea typeface="Amazon Ember Display" pitchFamily="34" charset="-122"/>
                 <a:cs typeface="Amazon Ember Display" pitchFamily="34" charset="-120"/>
               </a:rPr>
-              <a:t>执行主体：Harness Agent　|　产物：self_review + 最终 JSON　|　载体：同一 session events</a:t>
+              <a:t>Application：顺序调用　|　Harness Agent：self_review + 最终 JSON　|　Memory System：保存 session events</a:t>
             </a:r>
             <a:endParaRPr lang="en-US" sz="1650" dirty="0"/>
           </a:p>
@@ -3834,7 +3893,7 @@
                 <a:ea typeface="Amazon Ember Display" pitchFamily="34" charset="-122"/>
                 <a:cs typeface="Amazon Ember Display" pitchFamily="34" charset="-120"/>
               </a:rPr>
-              <a:t>Memory System：EPISODIC 提炼轨迹</a:t>
+              <a:t>Memory System：EPISODIC 处理链</a:t>
             </a:r>
             <a:endParaRPr lang="en-US" sz="2700" dirty="0"/>
           </a:p>
@@ -3873,7 +3932,7 @@
                 <a:ea typeface="Microsoft YaHei" pitchFamily="34" charset="-122"/>
                 <a:cs typeface="Microsoft YaHei" pitchFamily="34" charset="-120"/>
               </a:rPr>
-              <a:t>AgentCore Memory 资源使用内置 EPISODIC strategy；后台异步处理 Harness Agent 产生的完整 session events。</a:t>
+              <a:t>Memory System 异步处理 Harness Agent 的 session events；新 session 中，AgentCore Harness 调用 Retrieval 并注入 Records。</a:t>
             </a:r>
             <a:endParaRPr lang="en-US" sz="1400" dirty="0"/>
           </a:p>
@@ -3888,11 +3947,11 @@
         <p:spPr>
           <a:xfrm>
             <a:off x="566928" y="1828800"/>
-            <a:ext cx="2286000" cy="1234440"/>
+            <a:ext cx="2286000" cy="1417320"/>
           </a:xfrm>
           <a:prstGeom prst="roundRect">
             <a:avLst>
-              <a:gd name="adj" fmla="val 5926"/>
+              <a:gd name="adj" fmla="val 5161"/>
             </a:avLst>
           </a:prstGeom>
           <a:solidFill>
@@ -3939,7 +3998,7 @@
                 <a:ea typeface="Amazon Ember Display" pitchFamily="34" charset="-122"/>
                 <a:cs typeface="Amazon Ember Display" pitchFamily="34" charset="-120"/>
               </a:rPr>
-              <a:t>HARNESS AGENT</a:t>
+              <a:t>MEMORY · EVENT STORAGE</a:t>
             </a:r>
             <a:endParaRPr lang="en-US" sz="1150" dirty="0"/>
           </a:p>
@@ -3970,7 +4029,7 @@
               <a:buNone/>
             </a:pPr>
             <a:r>
-              <a:rPr lang="en-US" sz="1700" b="1" dirty="0">
+              <a:rPr lang="en-US" sz="1400" b="1" dirty="0">
                 <a:solidFill>
                   <a:srgbClr val="FFFFFF"/>
                 </a:solidFill>
@@ -3978,9 +4037,9 @@
                 <a:ea typeface="Microsoft YaHei" pitchFamily="34" charset="-122"/>
                 <a:cs typeface="Microsoft YaHei" pitchFamily="34" charset="-120"/>
               </a:rPr>
-              <a:t>Session Events</a:t>
-            </a:r>
-            <a:endParaRPr lang="en-US" sz="1700" dirty="0"/>
+              <a:t>保存 Session Events</a:t>
+            </a:r>
+            <a:endParaRPr lang="en-US" sz="1400" dirty="0"/>
           </a:p>
         </p:txBody>
       </p:sp>
@@ -3993,7 +4052,7 @@
         <p:spPr>
           <a:xfrm>
             <a:off x="768096" y="2770632"/>
-            <a:ext cx="1883664" cy="164592"/>
+            <a:ext cx="1883664" cy="347472"/>
           </a:xfrm>
           <a:prstGeom prst="rect">
             <a:avLst/>
@@ -4009,7 +4068,7 @@
               <a:buNone/>
             </a:pPr>
             <a:r>
-              <a:rPr lang="en-US" sz="1250" dirty="0">
+              <a:rPr lang="en-US" sz="1050" dirty="0">
                 <a:solidFill>
                   <a:srgbClr val="CFD9E4"/>
                 </a:solidFill>
@@ -4017,9 +4076,9 @@
                 <a:ea typeface="Microsoft YaHei" pitchFamily="34" charset="-122"/>
                 <a:cs typeface="Microsoft YaHei" pitchFamily="34" charset="-120"/>
               </a:rPr>
-              <a:t>原文 + self_review + 最终 JSON</a:t>
-            </a:r>
-            <a:endParaRPr lang="en-US" sz="1250" dirty="0"/>
+              <a:t>Harness Agent 产物：原文 + self_review + 最终 JSON</a:t>
+            </a:r>
+            <a:endParaRPr lang="en-US" sz="1050" dirty="0"/>
           </a:p>
         </p:txBody>
       </p:sp>
@@ -4031,7 +4090,7 @@
         </p:nvSpPr>
         <p:spPr>
           <a:xfrm>
-            <a:off x="2898648" y="2176272"/>
+            <a:off x="2898648" y="2267712"/>
             <a:ext cx="384048" cy="548640"/>
           </a:xfrm>
           <a:prstGeom prst="rect">
@@ -4071,11 +4130,11 @@
         <p:spPr>
           <a:xfrm>
             <a:off x="3310128" y="1828800"/>
-            <a:ext cx="2286000" cy="1234440"/>
+            <a:ext cx="2286000" cy="1417320"/>
           </a:xfrm>
           <a:prstGeom prst="roundRect">
             <a:avLst>
-              <a:gd name="adj" fmla="val 5926"/>
+              <a:gd name="adj" fmla="val 5161"/>
             </a:avLst>
           </a:prstGeom>
           <a:solidFill>
@@ -4122,7 +4181,7 @@
                 <a:ea typeface="Amazon Ember Display" pitchFamily="34" charset="-122"/>
                 <a:cs typeface="Amazon Ember Display" pitchFamily="34" charset="-120"/>
               </a:rPr>
-              <a:t>MEMORY · EPISODIC</a:t>
+              <a:t>MEMORY · EXTRACTION</a:t>
             </a:r>
             <a:endParaRPr lang="en-US" sz="1150" dirty="0"/>
           </a:p>
@@ -4153,7 +4212,7 @@
               <a:buNone/>
             </a:pPr>
             <a:r>
-              <a:rPr lang="en-US" sz="1700" b="1" dirty="0">
+              <a:rPr lang="en-US" sz="1400" b="1" dirty="0">
                 <a:solidFill>
                   <a:srgbClr val="FFFFFF"/>
                 </a:solidFill>
@@ -4161,9 +4220,9 @@
                 <a:ea typeface="Microsoft YaHei" pitchFamily="34" charset="-122"/>
                 <a:cs typeface="Microsoft YaHei" pitchFamily="34" charset="-120"/>
               </a:rPr>
-              <a:t>Episode Extraction</a:t>
-            </a:r>
-            <a:endParaRPr lang="en-US" sz="1700" dirty="0"/>
+              <a:t>分析每个 Turn</a:t>
+            </a:r>
+            <a:endParaRPr lang="en-US" sz="1400" dirty="0"/>
           </a:p>
         </p:txBody>
       </p:sp>
@@ -4176,7 +4235,7 @@
         <p:spPr>
           <a:xfrm>
             <a:off x="3511296" y="2770632"/>
-            <a:ext cx="1883664" cy="164592"/>
+            <a:ext cx="1883664" cy="347472"/>
           </a:xfrm>
           <a:prstGeom prst="rect">
             <a:avLst/>
@@ -4192,7 +4251,7 @@
               <a:buNone/>
             </a:pPr>
             <a:r>
-              <a:rPr lang="en-US" sz="1250" dirty="0">
+              <a:rPr lang="en-US" sz="1050" dirty="0">
                 <a:solidFill>
                   <a:srgbClr val="CFD9E4"/>
                 </a:solidFill>
@@ -4200,9 +4259,9 @@
                 <a:ea typeface="Microsoft YaHei" pitchFamily="34" charset="-122"/>
                 <a:cs typeface="Microsoft YaHei" pitchFamily="34" charset="-120"/>
               </a:rPr>
-              <a:t>逐 turn 分析行为与结果</a:t>
-            </a:r>
-            <a:endParaRPr lang="en-US" sz="1250" dirty="0"/>
+              <a:t>Memory System 识别行为、结果与任务信号</a:t>
+            </a:r>
+            <a:endParaRPr lang="en-US" sz="1050" dirty="0"/>
           </a:p>
         </p:txBody>
       </p:sp>
@@ -4214,7 +4273,7 @@
         </p:nvSpPr>
         <p:spPr>
           <a:xfrm>
-            <a:off x="5641848" y="2176272"/>
+            <a:off x="5641848" y="2267712"/>
             <a:ext cx="384048" cy="548640"/>
           </a:xfrm>
           <a:prstGeom prst="rect">
@@ -4254,11 +4313,11 @@
         <p:spPr>
           <a:xfrm>
             <a:off x="6053328" y="1828800"/>
-            <a:ext cx="2286000" cy="1234440"/>
+            <a:ext cx="2286000" cy="1417320"/>
           </a:xfrm>
           <a:prstGeom prst="roundRect">
             <a:avLst>
-              <a:gd name="adj" fmla="val 5926"/>
+              <a:gd name="adj" fmla="val 5161"/>
             </a:avLst>
           </a:prstGeom>
           <a:solidFill>
@@ -4305,7 +4364,7 @@
                 <a:ea typeface="Amazon Ember Display" pitchFamily="34" charset="-122"/>
                 <a:cs typeface="Amazon Ember Display" pitchFamily="34" charset="-120"/>
               </a:rPr>
-              <a:t>MEMORY · EPISODIC</a:t>
+              <a:t>MEMORY · CONSOLIDATION</a:t>
             </a:r>
             <a:endParaRPr lang="en-US" sz="1150" dirty="0"/>
           </a:p>
@@ -4336,7 +4395,7 @@
               <a:buNone/>
             </a:pPr>
             <a:r>
-              <a:rPr lang="en-US" sz="1700" b="1" dirty="0">
+              <a:rPr lang="en-US" sz="1400" b="1" dirty="0">
                 <a:solidFill>
                   <a:srgbClr val="FFFFFF"/>
                 </a:solidFill>
@@ -4344,9 +4403,9 @@
                 <a:ea typeface="Microsoft YaHei" pitchFamily="34" charset="-122"/>
                 <a:cs typeface="Microsoft YaHei" pitchFamily="34" charset="-120"/>
               </a:rPr>
-              <a:t>Consolidation</a:t>
-            </a:r>
-            <a:endParaRPr lang="en-US" sz="1700" dirty="0"/>
+              <a:t>生成 Episode</a:t>
+            </a:r>
+            <a:endParaRPr lang="en-US" sz="1400" dirty="0"/>
           </a:p>
         </p:txBody>
       </p:sp>
@@ -4359,7 +4418,7 @@
         <p:spPr>
           <a:xfrm>
             <a:off x="6254496" y="2770632"/>
-            <a:ext cx="1883664" cy="164592"/>
+            <a:ext cx="1883664" cy="347472"/>
           </a:xfrm>
           <a:prstGeom prst="rect">
             <a:avLst/>
@@ -4375,7 +4434,7 @@
               <a:buNone/>
             </a:pPr>
             <a:r>
-              <a:rPr lang="en-US" sz="1250" dirty="0">
+              <a:rPr lang="en-US" sz="1050" dirty="0">
                 <a:solidFill>
                   <a:srgbClr val="CFD9E4"/>
                 </a:solidFill>
@@ -4383,9 +4442,9 @@
                 <a:ea typeface="Microsoft YaHei" pitchFamily="34" charset="-122"/>
                 <a:cs typeface="Microsoft YaHei" pitchFamily="34" charset="-120"/>
               </a:rPr>
-              <a:t>形成 session-level episode</a:t>
-            </a:r>
-            <a:endParaRPr lang="en-US" sz="1250" dirty="0"/>
+              <a:t>Memory System 形成 session-level episode</a:t>
+            </a:r>
+            <a:endParaRPr lang="en-US" sz="1050" dirty="0"/>
           </a:p>
         </p:txBody>
       </p:sp>
@@ -4397,7 +4456,7 @@
         </p:nvSpPr>
         <p:spPr>
           <a:xfrm>
-            <a:off x="8385048" y="2176272"/>
+            <a:off x="8385048" y="2267712"/>
             <a:ext cx="384048" cy="548640"/>
           </a:xfrm>
           <a:prstGeom prst="rect">
@@ -4437,11 +4496,11 @@
         <p:spPr>
           <a:xfrm>
             <a:off x="8796528" y="1828800"/>
-            <a:ext cx="2834640" cy="1234440"/>
+            <a:ext cx="2834640" cy="1417320"/>
           </a:xfrm>
           <a:prstGeom prst="roundRect">
             <a:avLst>
-              <a:gd name="adj" fmla="val 5926"/>
+              <a:gd name="adj" fmla="val 5161"/>
             </a:avLst>
           </a:prstGeom>
           <a:solidFill>
@@ -4488,7 +4547,7 @@
                 <a:ea typeface="Amazon Ember Display" pitchFamily="34" charset="-122"/>
                 <a:cs typeface="Amazon Ember Display" pitchFamily="34" charset="-120"/>
               </a:rPr>
-              <a:t>MEMORY · EPISODIC</a:t>
+              <a:t>MEMORY · REFLECTION</a:t>
             </a:r>
             <a:endParaRPr lang="en-US" sz="1150" dirty="0"/>
           </a:p>
@@ -4519,7 +4578,7 @@
               <a:buNone/>
             </a:pPr>
             <a:r>
-              <a:rPr lang="en-US" sz="1700" b="1" dirty="0">
+              <a:rPr lang="en-US" sz="1400" b="1" dirty="0">
                 <a:solidFill>
                   <a:srgbClr val="FFFFFF"/>
                 </a:solidFill>
@@ -4527,9 +4586,9 @@
                 <a:ea typeface="Microsoft YaHei" pitchFamily="34" charset="-122"/>
                 <a:cs typeface="Microsoft YaHei" pitchFamily="34" charset="-120"/>
               </a:rPr>
-              <a:t>Reflection</a:t>
-            </a:r>
-            <a:endParaRPr lang="en-US" sz="1700" dirty="0"/>
+              <a:t>生成跨任务方法</a:t>
+            </a:r>
+            <a:endParaRPr lang="en-US" sz="1400" dirty="0"/>
           </a:p>
         </p:txBody>
       </p:sp>
@@ -4542,7 +4601,7 @@
         <p:spPr>
           <a:xfrm>
             <a:off x="8997696" y="2770632"/>
-            <a:ext cx="2432304" cy="164592"/>
+            <a:ext cx="2432304" cy="347472"/>
           </a:xfrm>
           <a:prstGeom prst="rect">
             <a:avLst/>
@@ -4558,7 +4617,7 @@
               <a:buNone/>
             </a:pPr>
             <a:r>
-              <a:rPr lang="en-US" sz="1250" dirty="0">
+              <a:rPr lang="en-US" sz="1050" dirty="0">
                 <a:solidFill>
                   <a:srgbClr val="CFD9E4"/>
                 </a:solidFill>
@@ -4566,9 +4625,9 @@
                 <a:ea typeface="Microsoft YaHei" pitchFamily="34" charset="-122"/>
                 <a:cs typeface="Microsoft YaHei" pitchFamily="34" charset="-120"/>
               </a:rPr>
-              <a:t>形成 actor-level 可复用策略</a:t>
-            </a:r>
-            <a:endParaRPr lang="en-US" sz="1250" dirty="0"/>
+              <a:t>Memory System 形成 actor-level reflections</a:t>
+            </a:r>
+            <a:endParaRPr lang="en-US" sz="1050" dirty="0"/>
           </a:p>
         </p:txBody>
       </p:sp>
@@ -4671,7 +4730,7 @@
                 <a:ea typeface="Microsoft YaHei" pitchFamily="34" charset="-122"/>
                 <a:cs typeface="Microsoft YaHei" pitchFamily="34" charset="-120"/>
               </a:rPr>
-              <a:t>session-level episode</a:t>
+              <a:t>Memory System · session-level episode</a:t>
             </a:r>
             <a:endParaRPr lang="en-US" sz="1250" dirty="0"/>
           </a:p>
@@ -4776,7 +4835,7 @@
                 <a:ea typeface="Microsoft YaHei" pitchFamily="34" charset="-122"/>
                 <a:cs typeface="Microsoft YaHei" pitchFamily="34" charset="-120"/>
               </a:rPr>
-              <a:t>actor-level reflections</a:t>
+              <a:t>Memory System · actor-level reflections</a:t>
             </a:r>
             <a:endParaRPr lang="en-US" sz="1250" dirty="0"/>
           </a:p>
@@ -4881,7 +4940,7 @@
                 <a:ea typeface="Microsoft YaHei" pitchFamily="34" charset="-122"/>
                 <a:cs typeface="Microsoft YaHei" pitchFamily="34" charset="-120"/>
               </a:rPr>
-              <a:t>Harness 自动检索并注入</a:t>
+              <a:t>AgentCore Harness · Retrieval 调用 + 注入</a:t>
             </a:r>
             <a:endParaRPr lang="en-US" sz="1250" dirty="0"/>
           </a:p>
@@ -4947,7 +5006,7 @@
                 <a:ea typeface="Amazon Ember Display" pitchFamily="34" charset="-122"/>
                 <a:cs typeface="Amazon Ember Display" pitchFamily="34" charset="-120"/>
               </a:rPr>
-              <a:t>Episode namespace: /episodes/{actorId}/{sessionId}　|　Reflection namespace: /episodes/{actorId}</a:t>
+              <a:t>Memory System：检索 actor Records　|　AgentCore Harness：注入上下文　|　接收方：新 Harness Agent</a:t>
             </a:r>
             <a:endParaRPr lang="en-US" sz="1650" dirty="0"/>
           </a:p>
@@ -5159,7 +5218,7 @@
                 <a:ea typeface="Amazon Ember Display" pitchFamily="34" charset="-122"/>
                 <a:cs typeface="Amazon Ember Display" pitchFamily="34" charset="-120"/>
               </a:rPr>
-              <a:t>AgentCore Memory System 实际生成的 Records</a:t>
+              <a:t>Memory System · EPISODIC 实际生成的 Records</a:t>
             </a:r>
             <a:endParaRPr lang="en-US" sz="2700" dirty="0"/>
           </a:p>
@@ -5198,7 +5257,7 @@
                 <a:ea typeface="Microsoft YaHei" pitchFamily="34" charset="-122"/>
                 <a:cs typeface="Microsoft YaHei" pitchFamily="34" charset="-120"/>
               </a:rPr>
-              <a:t>以下内容均由内置 EPISODIC strategy 异步生成，不是 Harness Agent 手工写入的规则。</a:t>
+              <a:t>Memory System 在 Consolidation 阶段生成 session-level episode，在 Reflection 阶段生成 actor-level reflections。</a:t>
             </a:r>
             <a:endParaRPr lang="en-US" sz="1400" dirty="0"/>
           </a:p>
@@ -6073,7 +6132,7 @@
               <a:buNone/>
             </a:pPr>
             <a:r>
-              <a:rPr lang="en-US" sz="3400" b="1" dirty="0">
+              <a:rPr lang="en-US" sz="2700" b="1" dirty="0">
                 <a:solidFill>
                   <a:srgbClr val="FFFFFF"/>
                 </a:solidFill>
@@ -6081,9 +6140,9 @@
                 <a:ea typeface="Amazon Ember Display" pitchFamily="34" charset="-122"/>
                 <a:cs typeface="Amazon Ember Display" pitchFamily="34" charset="-120"/>
               </a:rPr>
-              <a:t>留出文档：只改变 Memory 开关</a:t>
-            </a:r>
-            <a:endParaRPr lang="en-US" sz="3400" dirty="0"/>
+              <a:t>Application 启动留出实验：只改变 Retrieval 开关</a:t>
+            </a:r>
+            <a:endParaRPr lang="en-US" sz="2700" dirty="0"/>
           </a:p>
         </p:txBody>
       </p:sp>
@@ -6120,7 +6179,7 @@
                 <a:ea typeface="Microsoft YaHei" pitchFamily="34" charset="-122"/>
                 <a:cs typeface="Microsoft YaHei" pitchFamily="34" charset="-120"/>
               </a:rPr>
-              <a:t>源任务已经结束；现在换一份全新电机图纸，验证跨 session 召回是否改变抽取行为。</a:t>
+              <a:t>Application 为同一电机图纸创建两组 fresh sessions；Harness Agent 使用相同配置执行抽取。</a:t>
             </a:r>
             <a:endParaRPr lang="en-US" sz="1800" dirty="0"/>
           </a:p>
@@ -6186,7 +6245,7 @@
                 <a:ea typeface="Microsoft YaHei" pitchFamily="34" charset="-122"/>
                 <a:cs typeface="Microsoft YaHei" pitchFamily="34" charset="-120"/>
               </a:rPr>
-              <a:t>实验边界：两组目标调用配置相同；唯一变量是 Memory System 是否检索并注入 records。</a:t>
+              <a:t>实验边界：enabled 组由 Memory System 执行 Retrieval、AgentCore Harness 注入 Records；disabled 组不接收 Records。</a:t>
             </a:r>
             <a:endParaRPr lang="en-US" sz="2000" dirty="0"/>
           </a:p>
@@ -6390,7 +6449,7 @@
               <a:buNone/>
             </a:pPr>
             <a:r>
-              <a:rPr lang="en-US" sz="2700" b="1" dirty="0">
+              <a:rPr lang="en-US" sz="2500" b="1" dirty="0">
                 <a:solidFill>
                   <a:srgbClr val="FFFFFF"/>
                 </a:solidFill>
@@ -6398,9 +6457,9 @@
                 <a:ea typeface="Amazon Ember Display" pitchFamily="34" charset="-122"/>
                 <a:cs typeface="Amazon Ember Display" pitchFamily="34" charset="-120"/>
               </a:rPr>
-              <a:t>Harness Agent 留出实验：目标端只改变 Memory 开关</a:t>
-            </a:r>
-            <a:endParaRPr lang="en-US" sz="2700" dirty="0"/>
+              <a:t>Application 控制变量；Harness Agent 执行目标抽取</a:t>
+            </a:r>
+            <a:endParaRPr lang="en-US" sz="2500" dirty="0"/>
           </a:p>
         </p:txBody>
       </p:sp>
@@ -6437,7 +6496,7 @@
                 <a:ea typeface="Microsoft YaHei" pitchFamily="34" charset="-122"/>
                 <a:cs typeface="Microsoft YaHei" pitchFamily="34" charset="-120"/>
               </a:rPr>
-              <a:t>目标抽取由 Harness Agent 完成；Memory System 只在 enabled 组负责自动检索并注入 records。</a:t>
+              <a:t>Application 固定两组配置；enabled 组由 Memory System 检索 Records、AgentCore Harness 注入上下文。</a:t>
             </a:r>
             <a:endParaRPr lang="en-US" sz="1400" dirty="0"/>
           </a:p>
@@ -6503,7 +6562,7 @@
                 <a:ea typeface="Amazon Ember Display" pitchFamily="34" charset="-122"/>
                 <a:cs typeface="Amazon Ember Display" pitchFamily="34" charset="-120"/>
               </a:rPr>
-              <a:t>HARNESS AGENT · 目标抽取 Prompt</a:t>
+              <a:t>APPLICATION 提供 → HARNESS AGENT 执行</a:t>
             </a:r>
             <a:endParaRPr lang="en-US" sz="1150" dirty="0"/>
           </a:p>
@@ -6732,7 +6791,7 @@
                 <a:ea typeface="Amazon Ember Display" pitchFamily="34" charset="-122"/>
                 <a:cs typeface="Amazon Ember Display" pitchFamily="34" charset="-120"/>
               </a:rPr>
-              <a:t>控制变量</a:t>
+              <a:t>APPLICATION · 实验控制</a:t>
             </a:r>
             <a:endParaRPr lang="en-US" sz="1150" dirty="0"/>
           </a:p>
@@ -6771,7 +6830,7 @@
                 <a:ea typeface="Microsoft YaHei" pitchFamily="34" charset="-122"/>
                 <a:cs typeface="Microsoft YaHei" pitchFamily="34" charset="-120"/>
               </a:rPr>
-              <a:t>Harness Agent 配置相同</a:t>
+              <a:t>Application 固定 Harness Agent 配置</a:t>
             </a:r>
             <a:endParaRPr lang="en-US" sz="1700" dirty="0"/>
           </a:p>
@@ -6802,7 +6861,7 @@
               <a:buNone/>
             </a:pPr>
             <a:r>
-              <a:rPr lang="en-US" sz="1330" dirty="0">
+              <a:rPr lang="en-US" sz="1300" dirty="0">
                 <a:solidFill>
                   <a:srgbClr val="CFD9E4"/>
                 </a:solidFill>
@@ -6812,14 +6871,14 @@
               </a:rPr>
               <a:t>· 同一测试文档与 system prompt</a:t>
             </a:r>
-            <a:endParaRPr lang="en-US" sz="1330" dirty="0"/>
-          </a:p>
-          <a:p>
-            <a:pPr indent="0" marL="0">
-              <a:buNone/>
-            </a:pPr>
-            <a:r>
-              <a:rPr lang="en-US" sz="1330" dirty="0">
+            <a:endParaRPr lang="en-US" sz="1300" dirty="0"/>
+          </a:p>
+          <a:p>
+            <a:pPr indent="0" marL="0">
+              <a:buNone/>
+            </a:pPr>
+            <a:r>
+              <a:rPr lang="en-US" sz="1300" dirty="0">
                 <a:solidFill>
                   <a:srgbClr val="CFD9E4"/>
                 </a:solidFill>
@@ -6829,14 +6888,14 @@
               </a:rPr>
               <a:t>· claude-sonnet-4-6</a:t>
             </a:r>
-            <a:endParaRPr lang="en-US" sz="1330" dirty="0"/>
-          </a:p>
-          <a:p>
-            <a:pPr indent="0" marL="0">
-              <a:buNone/>
-            </a:pPr>
-            <a:r>
-              <a:rPr lang="en-US" sz="1330" dirty="0">
+            <a:endParaRPr lang="en-US" sz="1300" dirty="0"/>
+          </a:p>
+          <a:p>
+            <a:pPr indent="0" marL="0">
+              <a:buNone/>
+            </a:pPr>
+            <a:r>
+              <a:rPr lang="en-US" sz="1300" dirty="0">
                 <a:solidFill>
                   <a:srgbClr val="CFD9E4"/>
                 </a:solidFill>
@@ -6846,14 +6905,14 @@
               </a:rPr>
               <a:t>· temperature=0 · maxTokens=32768</a:t>
             </a:r>
-            <a:endParaRPr lang="en-US" sz="1330" dirty="0"/>
-          </a:p>
-          <a:p>
-            <a:pPr indent="0" marL="0">
-              <a:buNone/>
-            </a:pPr>
-            <a:r>
-              <a:rPr lang="en-US" sz="1330" dirty="0">
+            <a:endParaRPr lang="en-US" sz="1300" dirty="0"/>
+          </a:p>
+          <a:p>
+            <a:pPr indent="0" marL="0">
+              <a:buNone/>
+            </a:pPr>
+            <a:r>
+              <a:rPr lang="en-US" sz="1300" dirty="0">
                 <a:solidFill>
                   <a:srgbClr val="CFD9E4"/>
                 </a:solidFill>
@@ -6863,14 +6922,14 @@
               </a:rPr>
               <a:t>· skills=[] · tools=[]</a:t>
             </a:r>
-            <a:endParaRPr lang="en-US" sz="1330" dirty="0"/>
-          </a:p>
-          <a:p>
-            <a:pPr indent="0" marL="0">
-              <a:buNone/>
-            </a:pPr>
-            <a:r>
-              <a:rPr lang="en-US" sz="1330" dirty="0">
+            <a:endParaRPr lang="en-US" sz="1300" dirty="0"/>
+          </a:p>
+          <a:p>
+            <a:pPr indent="0" marL="0">
+              <a:buNone/>
+            </a:pPr>
+            <a:r>
+              <a:rPr lang="en-US" sz="1300" dirty="0">
                 <a:solidFill>
                   <a:srgbClr val="CFD9E4"/>
                 </a:solidFill>
@@ -6880,20 +6939,20 @@
               </a:rPr>
               <a:t>· 两组均使用全新 session</a:t>
             </a:r>
-            <a:endParaRPr lang="en-US" sz="1330" dirty="0"/>
-          </a:p>
-          <a:p>
-            <a:pPr indent="0" marL="0">
-              <a:buNone/>
-            </a:pPr>
-            <a:endParaRPr lang="en-US" sz="1330" dirty="0"/>
-          </a:p>
-          <a:p>
-            <a:pPr indent="0" marL="0">
-              <a:buNone/>
-            </a:pPr>
-            <a:r>
-              <a:rPr lang="en-US" sz="1330" dirty="0">
+            <a:endParaRPr lang="en-US" sz="1300" dirty="0"/>
+          </a:p>
+          <a:p>
+            <a:pPr indent="0" marL="0">
+              <a:buNone/>
+            </a:pPr>
+            <a:endParaRPr lang="en-US" sz="1300" dirty="0"/>
+          </a:p>
+          <a:p>
+            <a:pPr indent="0" marL="0">
+              <a:buNone/>
+            </a:pPr>
+            <a:r>
+              <a:rPr lang="en-US" sz="1300" dirty="0">
                 <a:solidFill>
                   <a:srgbClr val="CFD9E4"/>
                 </a:solidFill>
@@ -6901,16 +6960,16 @@
                 <a:ea typeface="Microsoft YaHei" pitchFamily="34" charset="-122"/>
                 <a:cs typeface="Microsoft YaHei" pitchFamily="34" charset="-120"/>
               </a:rPr>
-              <a:t>Memory 组：EPISODIC retrieval enabled</a:t>
-            </a:r>
-            <a:endParaRPr lang="en-US" sz="1330" dirty="0"/>
-          </a:p>
-          <a:p>
-            <a:pPr indent="0" marL="0">
-              <a:buNone/>
-            </a:pPr>
-            <a:r>
-              <a:rPr lang="en-US" sz="1330" dirty="0">
+              <a:t>Enabled：Memory Retrieval + Harness Injection</a:t>
+            </a:r>
+            <a:endParaRPr lang="en-US" sz="1300" dirty="0"/>
+          </a:p>
+          <a:p>
+            <a:pPr indent="0" marL="0">
+              <a:buNone/>
+            </a:pPr>
+            <a:r>
+              <a:rPr lang="en-US" sz="1300" dirty="0">
                 <a:solidFill>
                   <a:srgbClr val="CFD9E4"/>
                 </a:solidFill>
@@ -6918,9 +6977,9 @@
                 <a:ea typeface="Microsoft YaHei" pitchFamily="34" charset="-122"/>
                 <a:cs typeface="Microsoft YaHei" pitchFamily="34" charset="-120"/>
               </a:rPr>
-              <a:t>No Memory 组：Memory disabled</a:t>
-            </a:r>
-            <a:endParaRPr lang="en-US" sz="1330" dirty="0"/>
+              <a:t>Disabled：不检索、不注入历史 Records</a:t>
+            </a:r>
+            <a:endParaRPr lang="en-US" sz="1300" dirty="0"/>
           </a:p>
         </p:txBody>
       </p:sp>
@@ -6984,7 +7043,7 @@
                 <a:ea typeface="Amazon Ember Display" pitchFamily="34" charset="-122"/>
                 <a:cs typeface="Amazon Ember Display" pitchFamily="34" charset="-120"/>
               </a:rPr>
-              <a:t>执行主体：Harness Agent　|　实验变量：Memory System 是否检索并注入 source actor records</a:t>
+              <a:t>Application 控制变量　|　Memory System 检索　|　AgentCore Harness 注入　|　Harness Agent 抽取</a:t>
             </a:r>
             <a:endParaRPr lang="en-US" sz="1650" dirty="0"/>
           </a:p>
@@ -7196,7 +7255,7 @@
                 <a:ea typeface="Amazon Ember Display" pitchFamily="34" charset="-122"/>
                 <a:cs typeface="Amazon Ember Display" pitchFamily="34" charset="-120"/>
               </a:rPr>
-              <a:t>重点结果：31 vs 11</a:t>
+              <a:t>Harness Agent 结果：31 vs 11</a:t>
             </a:r>
             <a:endParaRPr lang="en-US" sz="2700" dirty="0"/>
           </a:p>
@@ -7235,7 +7294,7 @@
                 <a:ea typeface="Microsoft YaHei" pitchFamily="34" charset="-122"/>
                 <a:cs typeface="Microsoft YaHei" pitchFamily="34" charset="-120"/>
               </a:rPr>
-              <a:t>两组都由 Harness Agent 输出；Memory 组在推理前接收了 Memory System 检索并注入的 records。</a:t>
+              <a:t>Enabled 组由 Memory System 检索 EPISODIC Records、AgentCore Harness 注入；两组 Harness Agent 使用相同 Prompt。</a:t>
             </a:r>
             <a:endParaRPr lang="en-US" sz="1400" dirty="0"/>
           </a:p>
@@ -7550,7 +7609,7 @@
                 <a:ea typeface="Amazon Ember Display" pitchFamily="34" charset="-122"/>
                 <a:cs typeface="Amazon Ember Display" pitchFamily="34" charset="-120"/>
               </a:rPr>
-              <a:t>多出的 20 条主要来自两张 BOM：Memory 让 Agent 把零部件表和组件表系统展开。</a:t>
+              <a:t>AgentCore Harness 注入 Memory Records 后，Harness Agent 多输出约 20 条；新增内容主要来自两张 BOM。</a:t>
             </a:r>
             <a:endParaRPr lang="en-US" sz="1900" dirty="0"/>
           </a:p>
@@ -7616,7 +7675,7 @@
                 <a:ea typeface="Amazon Ember Display" pitchFamily="34" charset="-122"/>
                 <a:cs typeface="Amazon Ember Display" pitchFamily="34" charset="-120"/>
               </a:rPr>
-              <a:t>MEMORY 组新增示例</a:t>
+              <a:t>HARNESS AGENT · ENABLED 输出</a:t>
             </a:r>
             <a:endParaRPr lang="en-US" sz="1150" dirty="0"/>
           </a:p>
@@ -7760,7 +7819,7 @@
                 <a:ea typeface="Amazon Ember Display" pitchFamily="34" charset="-122"/>
                 <a:cs typeface="Amazon Ember Display" pitchFamily="34" charset="-120"/>
               </a:rPr>
-              <a:t>MEMORY 组新增示例</a:t>
+              <a:t>HARNESS AGENT · ENABLED 输出</a:t>
             </a:r>
             <a:endParaRPr lang="en-US" sz="1150" dirty="0"/>
           </a:p>
@@ -7904,7 +7963,7 @@
                 <a:ea typeface="Amazon Ember Display" pitchFamily="34" charset="-122"/>
                 <a:cs typeface="Amazon Ember Display" pitchFamily="34" charset="-120"/>
               </a:rPr>
-              <a:t>人眼检查：新增条目基本有原文依据；结论是覆盖关注点扩大，不是“质量提升 3 倍”。</a:t>
+              <a:t>Reviewer 人工核对：新增条目基本有原文依据；该实验说明覆盖关注点扩大，不等于质量提升 3 倍。</a:t>
             </a:r>
             <a:endParaRPr lang="en-US" sz="1650" dirty="0"/>
           </a:p>
@@ -8116,7 +8175,7 @@
                 <a:ea typeface="Amazon Ember Display" pitchFamily="34" charset="-122"/>
                 <a:cs typeface="Amazon Ember Display" pitchFamily="34" charset="-120"/>
               </a:rPr>
-              <a:t>三个实验合起来，结论才完整</a:t>
+              <a:t>三项实验：主体、输入、产物与结论边界</a:t>
             </a:r>
             <a:endParaRPr lang="en-US" sz="2700" dirty="0"/>
           </a:p>
@@ -8155,7 +8214,7 @@
                 <a:ea typeface="Microsoft YaHei" pitchFamily="34" charset="-122"/>
                 <a:cs typeface="Microsoft YaHei" pitchFamily="34" charset="-120"/>
               </a:rPr>
-              <a:t>抽象自省、Memory 生成和留出验证是三项独立实验，不是一个连续的“抽取方法二”。</a:t>
+              <a:t>Application 编排实验；Harness Agent 负责抽取；应用侧 LLM 或 Memory System 负责不同类型的经验形成；Reviewer 负责质量判断。</a:t>
             </a:r>
             <a:endParaRPr lang="en-US" sz="1400" dirty="0"/>
           </a:p>
@@ -8199,7 +8258,7 @@
                         <a:buNone/>
                       </a:pPr>
                       <a:r>
-                        <a:rPr lang="en-US" sz="1250" b="1" dirty="0">
+                        <a:rPr lang="en-US" sz="1150" b="1" dirty="0">
                           <a:solidFill>
                             <a:srgbClr val="FFFFFF"/>
                           </a:solidFill>
@@ -8209,7 +8268,7 @@
                         </a:rPr>
                         <a:t>实验</a:t>
                       </a:r>
-                      <a:endParaRPr lang="en-US" sz="1250" dirty="0">
+                      <a:endParaRPr lang="en-US" sz="1150" dirty="0">
                         <a:latin typeface="Microsoft YaHei" charset="0"/>
                         <a:ea typeface="Microsoft YaHei" charset="0"/>
                         <a:cs typeface="Microsoft YaHei" charset="0"/>
@@ -8267,7 +8326,7 @@
                         <a:buNone/>
                       </a:pPr>
                       <a:r>
-                        <a:rPr lang="en-US" sz="1250" b="1" dirty="0">
+                        <a:rPr lang="en-US" sz="1150" b="1" dirty="0">
                           <a:solidFill>
                             <a:srgbClr val="FFFFFF"/>
                           </a:solidFill>
@@ -8277,7 +8336,7 @@
                         </a:rPr>
                         <a:t>实验一 · 学习信号</a:t>
                       </a:r>
-                      <a:endParaRPr lang="en-US" sz="1250" dirty="0">
+                      <a:endParaRPr lang="en-US" sz="1150" dirty="0">
                         <a:latin typeface="Microsoft YaHei" charset="0"/>
                         <a:ea typeface="Microsoft YaHei" charset="0"/>
                         <a:cs typeface="Microsoft YaHei" charset="0"/>
@@ -8335,7 +8394,7 @@
                         <a:buNone/>
                       </a:pPr>
                       <a:r>
-                        <a:rPr lang="en-US" sz="1250" b="1" dirty="0">
+                        <a:rPr lang="en-US" sz="1150" b="1" dirty="0">
                           <a:solidFill>
                             <a:srgbClr val="FFFFFF"/>
                           </a:solidFill>
@@ -8345,7 +8404,7 @@
                         </a:rPr>
                         <a:t>实验二 · Memory 生成</a:t>
                       </a:r>
-                      <a:endParaRPr lang="en-US" sz="1250" dirty="0">
+                      <a:endParaRPr lang="en-US" sz="1150" dirty="0">
                         <a:latin typeface="Microsoft YaHei" charset="0"/>
                         <a:ea typeface="Microsoft YaHei" charset="0"/>
                         <a:cs typeface="Microsoft YaHei" charset="0"/>
@@ -8403,7 +8462,7 @@
                         <a:buNone/>
                       </a:pPr>
                       <a:r>
-                        <a:rPr lang="en-US" sz="1250" b="1" dirty="0">
+                        <a:rPr lang="en-US" sz="1150" b="1" dirty="0">
                           <a:solidFill>
                             <a:srgbClr val="FFFFFF"/>
                           </a:solidFill>
@@ -8413,7 +8472,7 @@
                         </a:rPr>
                         <a:t>实验三 · 留出验证</a:t>
                       </a:r>
-                      <a:endParaRPr lang="en-US" sz="1250" dirty="0">
+                      <a:endParaRPr lang="en-US" sz="1150" dirty="0">
                         <a:latin typeface="Microsoft YaHei" charset="0"/>
                         <a:ea typeface="Microsoft YaHei" charset="0"/>
                         <a:cs typeface="Microsoft YaHei" charset="0"/>
@@ -8473,7 +8532,7 @@
                         <a:buNone/>
                       </a:pPr>
                       <a:r>
-                        <a:rPr lang="en-US" sz="1220" b="1" dirty="0">
+                        <a:rPr lang="en-US" sz="1040" b="1" dirty="0">
                           <a:solidFill>
                             <a:srgbClr val="FFFFFF"/>
                           </a:solidFill>
@@ -8483,7 +8542,7 @@
                         </a:rPr>
                         <a:t>核心问题</a:t>
                       </a:r>
-                      <a:endParaRPr lang="en-US" sz="1220" dirty="0">
+                      <a:endParaRPr lang="en-US" sz="1040" dirty="0">
                         <a:latin typeface="Microsoft YaHei" charset="0"/>
                         <a:ea typeface="Microsoft YaHei" charset="0"/>
                         <a:cs typeface="Microsoft YaHei" charset="0"/>
@@ -8541,7 +8600,7 @@
                         <a:buNone/>
                       </a:pPr>
                       <a:r>
-                        <a:rPr lang="en-US" sz="1220" dirty="0">
+                        <a:rPr lang="en-US" sz="1040" dirty="0">
                           <a:solidFill>
                             <a:srgbClr val="CFD9E4"/>
                           </a:solidFill>
@@ -8549,9 +8608,9 @@
                           <a:ea typeface="Microsoft YaHei" pitchFamily="34" charset="-122"/>
                           <a:cs typeface="Microsoft YaHei" pitchFamily="34" charset="-120"/>
                         </a:rPr>
-                        <a:t>只看输出能学到什么？</a:t>
+                        <a:t>Reflection LLM 仅看 Harness Agent 输出</a:t>
                       </a:r>
-                      <a:endParaRPr lang="en-US" sz="1220" dirty="0">
+                      <a:endParaRPr lang="en-US" sz="1040" dirty="0">
                         <a:latin typeface="Microsoft YaHei" charset="0"/>
                         <a:ea typeface="Microsoft YaHei" charset="0"/>
                         <a:cs typeface="Microsoft YaHei" charset="0"/>
@@ -8609,7 +8668,7 @@
                         <a:buNone/>
                       </a:pPr>
                       <a:r>
-                        <a:rPr lang="en-US" sz="1220" dirty="0">
+                        <a:rPr lang="en-US" sz="1040" dirty="0">
                           <a:solidFill>
                             <a:srgbClr val="CFD9E4"/>
                           </a:solidFill>
@@ -8617,9 +8676,9 @@
                           <a:ea typeface="Microsoft YaHei" pitchFamily="34" charset="-122"/>
                           <a:cs typeface="Microsoft YaHei" pitchFamily="34" charset="-120"/>
                         </a:rPr>
-                        <a:t>怎样产生可提炼轨迹？</a:t>
+                        <a:t>Memory System 能否从轨迹生成 Records</a:t>
                       </a:r>
-                      <a:endParaRPr lang="en-US" sz="1220" dirty="0">
+                      <a:endParaRPr lang="en-US" sz="1040" dirty="0">
                         <a:latin typeface="Microsoft YaHei" charset="0"/>
                         <a:ea typeface="Microsoft YaHei" charset="0"/>
                         <a:cs typeface="Microsoft YaHei" charset="0"/>
@@ -8677,7 +8736,7 @@
                         <a:buNone/>
                       </a:pPr>
                       <a:r>
-                        <a:rPr lang="en-US" sz="1220" dirty="0">
+                        <a:rPr lang="en-US" sz="1040" dirty="0">
                           <a:solidFill>
                             <a:srgbClr val="CFD9E4"/>
                           </a:solidFill>
@@ -8685,9 +8744,9 @@
                           <a:ea typeface="Microsoft YaHei" pitchFamily="34" charset="-122"/>
                           <a:cs typeface="Microsoft YaHei" pitchFamily="34" charset="-120"/>
                         </a:rPr>
-                        <a:t>Memory 是否改变下一任务？</a:t>
+                        <a:t>注入后 Harness Agent 输出是否变化</a:t>
                       </a:r>
-                      <a:endParaRPr lang="en-US" sz="1220" dirty="0">
+                      <a:endParaRPr lang="en-US" sz="1040" dirty="0">
                         <a:latin typeface="Microsoft YaHei" charset="0"/>
                         <a:ea typeface="Microsoft YaHei" charset="0"/>
                         <a:cs typeface="Microsoft YaHei" charset="0"/>
@@ -8747,7 +8806,7 @@
                         <a:buNone/>
                       </a:pPr>
                       <a:r>
-                        <a:rPr lang="en-US" sz="1220" b="1" dirty="0">
+                        <a:rPr lang="en-US" sz="1040" b="1" dirty="0">
                           <a:solidFill>
                             <a:srgbClr val="FFFFFF"/>
                           </a:solidFill>
@@ -8757,7 +8816,7 @@
                         </a:rPr>
                         <a:t>执行主体</a:t>
                       </a:r>
-                      <a:endParaRPr lang="en-US" sz="1220" dirty="0">
+                      <a:endParaRPr lang="en-US" sz="1040" dirty="0">
                         <a:latin typeface="Microsoft YaHei" charset="0"/>
                         <a:ea typeface="Microsoft YaHei" charset="0"/>
                         <a:cs typeface="Microsoft YaHei" charset="0"/>
@@ -8815,7 +8874,7 @@
                         <a:buNone/>
                       </a:pPr>
                       <a:r>
-                        <a:rPr lang="en-US" sz="1220" dirty="0">
+                        <a:rPr lang="en-US" sz="1040" dirty="0">
                           <a:solidFill>
                             <a:srgbClr val="CFD9E4"/>
                           </a:solidFill>
@@ -8823,9 +8882,9 @@
                           <a:ea typeface="Microsoft YaHei" pitchFamily="34" charset="-122"/>
                           <a:cs typeface="Microsoft YaHei" pitchFamily="34" charset="-120"/>
                         </a:rPr>
-                        <a:t>应用侧 LLM 反思/合并</a:t>
+                        <a:t>Application + Reflection LLM + Consolidation LLM</a:t>
                       </a:r>
-                      <a:endParaRPr lang="en-US" sz="1220" dirty="0">
+                      <a:endParaRPr lang="en-US" sz="1040" dirty="0">
                         <a:latin typeface="Microsoft YaHei" charset="0"/>
                         <a:ea typeface="Microsoft YaHei" charset="0"/>
                         <a:cs typeface="Microsoft YaHei" charset="0"/>
@@ -8883,7 +8942,7 @@
                         <a:buNone/>
                       </a:pPr>
                       <a:r>
-                        <a:rPr lang="en-US" sz="1220" dirty="0">
+                        <a:rPr lang="en-US" sz="1040" dirty="0">
                           <a:solidFill>
                             <a:srgbClr val="CFD9E4"/>
                           </a:solidFill>
@@ -8891,9 +8950,9 @@
                           <a:ea typeface="Microsoft YaHei" pitchFamily="34" charset="-122"/>
                           <a:cs typeface="Microsoft YaHei" pitchFamily="34" charset="-120"/>
                         </a:rPr>
-                        <a:t>Harness Agent + Memory System</a:t>
+                        <a:t>Application + Harness Agent + Memory System</a:t>
                       </a:r>
-                      <a:endParaRPr lang="en-US" sz="1220" dirty="0">
+                      <a:endParaRPr lang="en-US" sz="1040" dirty="0">
                         <a:latin typeface="Microsoft YaHei" charset="0"/>
                         <a:ea typeface="Microsoft YaHei" charset="0"/>
                         <a:cs typeface="Microsoft YaHei" charset="0"/>
@@ -8951,7 +9010,7 @@
                         <a:buNone/>
                       </a:pPr>
                       <a:r>
-                        <a:rPr lang="en-US" sz="1220" dirty="0">
+                        <a:rPr lang="en-US" sz="1040" dirty="0">
                           <a:solidFill>
                             <a:srgbClr val="CFD9E4"/>
                           </a:solidFill>
@@ -8959,9 +9018,9 @@
                           <a:ea typeface="Microsoft YaHei" pitchFamily="34" charset="-122"/>
                           <a:cs typeface="Microsoft YaHei" pitchFamily="34" charset="-120"/>
                         </a:rPr>
-                        <a:t>Harness Agent；Memory 开关</a:t>
+                        <a:t>Application + Memory System + AgentCore Harness + Harness Agent + Reviewer</a:t>
                       </a:r>
-                      <a:endParaRPr lang="en-US" sz="1220" dirty="0">
+                      <a:endParaRPr lang="en-US" sz="1040" dirty="0">
                         <a:latin typeface="Microsoft YaHei" charset="0"/>
                         <a:ea typeface="Microsoft YaHei" charset="0"/>
                         <a:cs typeface="Microsoft YaHei" charset="0"/>
@@ -9021,7 +9080,7 @@
                         <a:buNone/>
                       </a:pPr>
                       <a:r>
-                        <a:rPr lang="en-US" sz="1220" b="1" dirty="0">
+                        <a:rPr lang="en-US" sz="1040" b="1" dirty="0">
                           <a:solidFill>
                             <a:srgbClr val="FFFFFF"/>
                           </a:solidFill>
@@ -9031,7 +9090,7 @@
                         </a:rPr>
                         <a:t>输入/变量</a:t>
                       </a:r>
-                      <a:endParaRPr lang="en-US" sz="1220" dirty="0">
+                      <a:endParaRPr lang="en-US" sz="1040" dirty="0">
                         <a:latin typeface="Microsoft YaHei" charset="0"/>
                         <a:ea typeface="Microsoft YaHei" charset="0"/>
                         <a:cs typeface="Microsoft YaHei" charset="0"/>
@@ -9089,7 +9148,7 @@
                         <a:buNone/>
                       </a:pPr>
                       <a:r>
-                        <a:rPr lang="en-US" sz="1220" dirty="0">
+                        <a:rPr lang="en-US" sz="1040" dirty="0">
                           <a:solidFill>
                             <a:srgbClr val="CFD9E4"/>
                           </a:solidFill>
@@ -9097,9 +9156,9 @@
                           <a:ea typeface="Microsoft YaHei" pitchFamily="34" charset="-122"/>
                           <a:cs typeface="Microsoft YaHei" pitchFamily="34" charset="-120"/>
                         </a:rPr>
-                        <a:t>只有已抽取结果</a:t>
+                        <a:t>Reflection LLM 仅收 Harness Agent JSON</a:t>
                       </a:r>
-                      <a:endParaRPr lang="en-US" sz="1220" dirty="0">
+                      <a:endParaRPr lang="en-US" sz="1040" dirty="0">
                         <a:latin typeface="Microsoft YaHei" charset="0"/>
                         <a:ea typeface="Microsoft YaHei" charset="0"/>
                         <a:cs typeface="Microsoft YaHei" charset="0"/>
@@ -9157,7 +9216,7 @@
                         <a:buNone/>
                       </a:pPr>
                       <a:r>
-                        <a:rPr lang="en-US" sz="1220" dirty="0">
+                        <a:rPr lang="en-US" sz="1040" dirty="0">
                           <a:solidFill>
                             <a:srgbClr val="CFD9E4"/>
                           </a:solidFill>
@@ -9165,9 +9224,9 @@
                           <a:ea typeface="Microsoft YaHei" pitchFamily="34" charset="-122"/>
                           <a:cs typeface="Microsoft YaHei" pitchFamily="34" charset="-120"/>
                         </a:rPr>
-                        <a:t>原文 + 草稿 + self_review</a:t>
+                        <a:t>Memory System 接收完整 session events</a:t>
                       </a:r>
-                      <a:endParaRPr lang="en-US" sz="1220" dirty="0">
+                      <a:endParaRPr lang="en-US" sz="1040" dirty="0">
                         <a:latin typeface="Microsoft YaHei" charset="0"/>
                         <a:ea typeface="Microsoft YaHei" charset="0"/>
                         <a:cs typeface="Microsoft YaHei" charset="0"/>
@@ -9225,7 +9284,7 @@
                         <a:buNone/>
                       </a:pPr>
                       <a:r>
-                        <a:rPr lang="en-US" sz="1220" dirty="0">
+                        <a:rPr lang="en-US" sz="1040" dirty="0">
                           <a:solidFill>
                             <a:srgbClr val="CFD9E4"/>
                           </a:solidFill>
@@ -9233,9 +9292,9 @@
                           <a:ea typeface="Microsoft YaHei" pitchFamily="34" charset="-122"/>
                           <a:cs typeface="Microsoft YaHei" pitchFamily="34" charset="-120"/>
                         </a:rPr>
-                        <a:t>同配置；只改变 Memory</a:t>
+                        <a:t>Application 只切换 Retrieval + Injection</a:t>
                       </a:r>
-                      <a:endParaRPr lang="en-US" sz="1220" dirty="0">
+                      <a:endParaRPr lang="en-US" sz="1040" dirty="0">
                         <a:latin typeface="Microsoft YaHei" charset="0"/>
                         <a:ea typeface="Microsoft YaHei" charset="0"/>
                         <a:cs typeface="Microsoft YaHei" charset="0"/>
@@ -9295,7 +9354,7 @@
                         <a:buNone/>
                       </a:pPr>
                       <a:r>
-                        <a:rPr lang="en-US" sz="1220" b="1" dirty="0">
+                        <a:rPr lang="en-US" sz="1040" b="1" dirty="0">
                           <a:solidFill>
                             <a:srgbClr val="FFFFFF"/>
                           </a:solidFill>
@@ -9305,7 +9364,7 @@
                         </a:rPr>
                         <a:t>实际产物</a:t>
                       </a:r>
-                      <a:endParaRPr lang="en-US" sz="1220" dirty="0">
+                      <a:endParaRPr lang="en-US" sz="1040" dirty="0">
                         <a:latin typeface="Microsoft YaHei" charset="0"/>
                         <a:ea typeface="Microsoft YaHei" charset="0"/>
                         <a:cs typeface="Microsoft YaHei" charset="0"/>
@@ -9363,7 +9422,7 @@
                         <a:buNone/>
                       </a:pPr>
                       <a:r>
-                        <a:rPr lang="en-US" sz="1220" dirty="0">
+                        <a:rPr lang="en-US" sz="1040" dirty="0">
                           <a:solidFill>
                             <a:srgbClr val="CFD9E4"/>
                           </a:solidFill>
@@ -9371,9 +9430,9 @@
                           <a:ea typeface="Microsoft YaHei" pitchFamily="34" charset="-122"/>
                           <a:cs typeface="Microsoft YaHei" pitchFamily="34" charset="-120"/>
                         </a:rPr>
-                        <a:t>15 条 canonical rules</a:t>
+                        <a:t>Consolidation LLM：15 条 rules</a:t>
                       </a:r>
-                      <a:endParaRPr lang="en-US" sz="1220" dirty="0">
+                      <a:endParaRPr lang="en-US" sz="1040" dirty="0">
                         <a:latin typeface="Microsoft YaHei" charset="0"/>
                         <a:ea typeface="Microsoft YaHei" charset="0"/>
                         <a:cs typeface="Microsoft YaHei" charset="0"/>
@@ -9431,7 +9490,7 @@
                         <a:buNone/>
                       </a:pPr>
                       <a:r>
-                        <a:rPr lang="en-US" sz="1220" dirty="0">
+                        <a:rPr lang="en-US" sz="1040" dirty="0">
                           <a:solidFill>
                             <a:srgbClr val="CFD9E4"/>
                           </a:solidFill>
@@ -9439,9 +9498,9 @@
                           <a:ea typeface="Microsoft YaHei" pitchFamily="34" charset="-122"/>
                           <a:cs typeface="Microsoft YaHei" pitchFamily="34" charset="-120"/>
                         </a:rPr>
-                        <a:t>1 episode + 2 reflections</a:t>
+                        <a:t>Memory System：1 episode + 2 reflections</a:t>
                       </a:r>
-                      <a:endParaRPr lang="en-US" sz="1220" dirty="0">
+                      <a:endParaRPr lang="en-US" sz="1040" dirty="0">
                         <a:latin typeface="Microsoft YaHei" charset="0"/>
                         <a:ea typeface="Microsoft YaHei" charset="0"/>
                         <a:cs typeface="Microsoft YaHei" charset="0"/>
@@ -9499,7 +9558,7 @@
                         <a:buNone/>
                       </a:pPr>
                       <a:r>
-                        <a:rPr lang="en-US" sz="1220" b="1" dirty="0">
+                        <a:rPr lang="en-US" sz="1040" b="1" dirty="0">
                           <a:solidFill>
                             <a:srgbClr val="00E500"/>
                           </a:solidFill>
@@ -9507,9 +9566,9 @@
                           <a:ea typeface="Microsoft YaHei" pitchFamily="34" charset="-122"/>
                           <a:cs typeface="Microsoft YaHei" pitchFamily="34" charset="-120"/>
                         </a:rPr>
-                        <a:t>31 条 vs 11 条</a:t>
+                        <a:t>Harness Agent：31 条 vs 11 条</a:t>
                       </a:r>
-                      <a:endParaRPr lang="en-US" sz="1220" dirty="0">
+                      <a:endParaRPr lang="en-US" sz="1040" dirty="0">
                         <a:latin typeface="Microsoft YaHei" charset="0"/>
                         <a:ea typeface="Microsoft YaHei" charset="0"/>
                         <a:cs typeface="Microsoft YaHei" charset="0"/>
@@ -9569,7 +9628,7 @@
                         <a:buNone/>
                       </a:pPr>
                       <a:r>
-                        <a:rPr lang="en-US" sz="1220" b="1" dirty="0">
+                        <a:rPr lang="en-US" sz="1040" b="1" dirty="0">
                           <a:solidFill>
                             <a:srgbClr val="FFFFFF"/>
                           </a:solidFill>
@@ -9579,7 +9638,7 @@
                         </a:rPr>
                         <a:t>观察</a:t>
                       </a:r>
-                      <a:endParaRPr lang="en-US" sz="1220" dirty="0">
+                      <a:endParaRPr lang="en-US" sz="1040" dirty="0">
                         <a:latin typeface="Microsoft YaHei" charset="0"/>
                         <a:ea typeface="Microsoft YaHei" charset="0"/>
                         <a:cs typeface="Microsoft YaHei" charset="0"/>
@@ -9637,7 +9696,7 @@
                         <a:buNone/>
                       </a:pPr>
                       <a:r>
-                        <a:rPr lang="en-US" sz="1220" b="1" dirty="0">
+                        <a:rPr lang="en-US" sz="1040" b="1" dirty="0">
                           <a:solidFill>
                             <a:srgbClr val="FF6A3D"/>
                           </a:solidFill>
@@ -9645,9 +9704,9 @@
                           <a:ea typeface="Microsoft YaHei" pitchFamily="34" charset="-122"/>
                           <a:cs typeface="Microsoft YaHei" pitchFamily="34" charset="-120"/>
                         </a:rPr>
-                        <a:t>90→102，主要拆分变细</a:t>
+                        <a:t>Harness Agent 输出 90→102，主要拆分变细</a:t>
                       </a:r>
-                      <a:endParaRPr lang="en-US" sz="1220" dirty="0">
+                      <a:endParaRPr lang="en-US" sz="1040" dirty="0">
                         <a:latin typeface="Microsoft YaHei" charset="0"/>
                         <a:ea typeface="Microsoft YaHei" charset="0"/>
                         <a:cs typeface="Microsoft YaHei" charset="0"/>
@@ -9705,7 +9764,7 @@
                         <a:buNone/>
                       </a:pPr>
                       <a:r>
-                        <a:rPr lang="en-US" sz="1220" dirty="0">
+                        <a:rPr lang="en-US" sz="1040" dirty="0">
                           <a:solidFill>
                             <a:srgbClr val="CFD9E4"/>
                           </a:solidFill>
@@ -9713,9 +9772,9 @@
                           <a:ea typeface="Microsoft YaHei" pitchFamily="34" charset="-122"/>
                           <a:cs typeface="Microsoft YaHei" pitchFamily="34" charset="-120"/>
                         </a:rPr>
-                        <a:t>形成覆盖/遗漏处理方法</a:t>
+                        <a:t>Memory Records 包含覆盖/遗漏处理方法</a:t>
                       </a:r>
-                      <a:endParaRPr lang="en-US" sz="1220" dirty="0">
+                      <a:endParaRPr lang="en-US" sz="1040" dirty="0">
                         <a:latin typeface="Microsoft YaHei" charset="0"/>
                         <a:ea typeface="Microsoft YaHei" charset="0"/>
                         <a:cs typeface="Microsoft YaHei" charset="0"/>
@@ -9773,7 +9832,7 @@
                         <a:buNone/>
                       </a:pPr>
                       <a:r>
-                        <a:rPr lang="en-US" sz="1220" b="1" dirty="0">
+                        <a:rPr lang="en-US" sz="1040" b="1" dirty="0">
                           <a:solidFill>
                             <a:srgbClr val="00E500"/>
                           </a:solidFill>
@@ -9781,9 +9840,9 @@
                           <a:ea typeface="Microsoft YaHei" pitchFamily="34" charset="-122"/>
                           <a:cs typeface="Microsoft YaHei" pitchFamily="34" charset="-120"/>
                         </a:rPr>
-                        <a:t>两张 BOM 被系统展开</a:t>
+                        <a:t>Enabled Harness Agent 展开两张 BOM</a:t>
                       </a:r>
-                      <a:endParaRPr lang="en-US" sz="1220" dirty="0">
+                      <a:endParaRPr lang="en-US" sz="1040" dirty="0">
                         <a:latin typeface="Microsoft YaHei" charset="0"/>
                         <a:ea typeface="Microsoft YaHei" charset="0"/>
                         <a:cs typeface="Microsoft YaHei" charset="0"/>
@@ -9843,7 +9902,7 @@
                         <a:buNone/>
                       </a:pPr>
                       <a:r>
-                        <a:rPr lang="en-US" sz="1220" b="1" dirty="0">
+                        <a:rPr lang="en-US" sz="1040" b="1" dirty="0">
                           <a:solidFill>
                             <a:srgbClr val="FFFFFF"/>
                           </a:solidFill>
@@ -9853,7 +9912,7 @@
                         </a:rPr>
                         <a:t>结论边界</a:t>
                       </a:r>
-                      <a:endParaRPr lang="en-US" sz="1220" dirty="0">
+                      <a:endParaRPr lang="en-US" sz="1040" dirty="0">
                         <a:latin typeface="Microsoft YaHei" charset="0"/>
                         <a:ea typeface="Microsoft YaHei" charset="0"/>
                         <a:cs typeface="Microsoft YaHei" charset="0"/>
@@ -9911,7 +9970,7 @@
                         <a:buNone/>
                       </a:pPr>
                       <a:r>
-                        <a:rPr lang="en-US" sz="1220" dirty="0">
+                        <a:rPr lang="en-US" sz="1040" dirty="0">
                           <a:solidFill>
                             <a:srgbClr val="CFD9E4"/>
                           </a:solidFill>
@@ -9919,9 +9978,9 @@
                           <a:ea typeface="Microsoft YaHei" pitchFamily="34" charset="-122"/>
                           <a:cs typeface="Microsoft YaHei" pitchFamily="34" charset="-120"/>
                         </a:rPr>
-                        <a:t>看不见整块遗漏</a:t>
+                        <a:t>Reflection LLM 看不见整块遗漏</a:t>
                       </a:r>
-                      <a:endParaRPr lang="en-US" sz="1220" dirty="0">
+                      <a:endParaRPr lang="en-US" sz="1040" dirty="0">
                         <a:latin typeface="Microsoft YaHei" charset="0"/>
                         <a:ea typeface="Microsoft YaHei" charset="0"/>
                         <a:cs typeface="Microsoft YaHei" charset="0"/>
@@ -9979,7 +10038,7 @@
                         <a:buNone/>
                       </a:pPr>
                       <a:r>
-                        <a:rPr lang="en-US" sz="1220" dirty="0">
+                        <a:rPr lang="en-US" sz="1040" dirty="0">
                           <a:solidFill>
                             <a:srgbClr val="CFD9E4"/>
                           </a:solidFill>
@@ -9987,9 +10046,9 @@
                           <a:ea typeface="Microsoft YaHei" pitchFamily="34" charset="-122"/>
                           <a:cs typeface="Microsoft YaHei" pitchFamily="34" charset="-120"/>
                         </a:rPr>
-                        <a:t>证明托管 Memory 可生成</a:t>
+                        <a:t>EPISODIC Records 可生成</a:t>
                       </a:r>
-                      <a:endParaRPr lang="en-US" sz="1220" dirty="0">
+                      <a:endParaRPr lang="en-US" sz="1040" dirty="0">
                         <a:latin typeface="Microsoft YaHei" charset="0"/>
                         <a:ea typeface="Microsoft YaHei" charset="0"/>
                         <a:cs typeface="Microsoft YaHei" charset="0"/>
@@ -10047,7 +10106,7 @@
                         <a:buNone/>
                       </a:pPr>
                       <a:r>
-                        <a:rPr lang="en-US" sz="1220" dirty="0">
+                        <a:rPr lang="en-US" sz="1040" dirty="0">
                           <a:solidFill>
                             <a:srgbClr val="CFD9E4"/>
                           </a:solidFill>
@@ -10055,9 +10114,9 @@
                           <a:ea typeface="Microsoft YaHei" pitchFamily="34" charset="-122"/>
                           <a:cs typeface="Microsoft YaHei" pitchFamily="34" charset="-120"/>
                         </a:rPr>
-                        <a:t>证明关注点发生变化</a:t>
+                        <a:t>关注点变化；质量由 Reviewer 判断</a:t>
                       </a:r>
-                      <a:endParaRPr lang="en-US" sz="1220" dirty="0">
+                      <a:endParaRPr lang="en-US" sz="1040" dirty="0">
                         <a:latin typeface="Microsoft YaHei" charset="0"/>
                         <a:ea typeface="Microsoft YaHei" charset="0"/>
                         <a:cs typeface="Microsoft YaHei" charset="0"/>
@@ -10111,72 +10170,6 @@
           </a:graphicData>
         </a:graphic>
       </p:graphicFrame>
-      <p:sp>
-        <p:nvSpPr>
-          <p:cNvPr id="9" name="Shape 5"/>
-          <p:cNvSpPr/>
-          <p:nvPr/>
-        </p:nvSpPr>
-        <p:spPr>
-          <a:xfrm>
-            <a:off x="566928" y="5440680"/>
-            <a:ext cx="11064240" cy="777240"/>
-          </a:xfrm>
-          <a:prstGeom prst="roundRect">
-            <a:avLst>
-              <a:gd name="adj" fmla="val 9412"/>
-            </a:avLst>
-          </a:prstGeom>
-          <a:solidFill>
-            <a:srgbClr val="0B1220"/>
-          </a:solidFill>
-          <a:ln w="10160">
-            <a:solidFill>
-              <a:srgbClr val="42B4FF"/>
-            </a:solidFill>
-            <a:prstDash val="solid"/>
-          </a:ln>
-        </p:spPr>
-      </p:sp>
-      <p:sp>
-        <p:nvSpPr>
-          <p:cNvPr id="10" name="Text 6"/>
-          <p:cNvSpPr/>
-          <p:nvPr/>
-        </p:nvSpPr>
-        <p:spPr>
-          <a:xfrm>
-            <a:off x="822960" y="5440680"/>
-            <a:ext cx="10552176" cy="777240"/>
-          </a:xfrm>
-          <a:prstGeom prst="rect">
-            <a:avLst/>
-          </a:prstGeom>
-          <a:noFill/>
-          <a:ln/>
-        </p:spPr>
-        <p:txBody>
-          <a:bodyPr wrap="square" lIns="0" tIns="0" rIns="0" bIns="0" rtlCol="0" anchor="ctr"/>
-          <a:lstStyle/>
-          <a:p>
-            <a:pPr algn="ctr" indent="0" marL="0">
-              <a:buNone/>
-            </a:pPr>
-            <a:r>
-              <a:rPr lang="en-US" sz="1650" b="1" dirty="0">
-                <a:solidFill>
-                  <a:srgbClr val="42B4FF"/>
-                </a:solidFill>
-                <a:latin typeface="Amazon Ember Display" pitchFamily="34" charset="0"/>
-                <a:ea typeface="Amazon Ember Display" pitchFamily="34" charset="-122"/>
-                <a:cs typeface="Amazon Ember Display" pitchFamily="34" charset="-120"/>
-              </a:rPr>
-              <a:t>统一结论：原文驱动的 Review 产生了可复用 Memory，并在留出文档上把 BOM 覆盖从零散变为系统展开。</a:t>
-            </a:r>
-            <a:endParaRPr lang="en-US" sz="1650" dirty="0"/>
-          </a:p>
-        </p:txBody>
-      </p:sp>
     </p:spTree>
   </p:cSld>
   <p:clrMapOvr>
@@ -10383,7 +10376,7 @@
                 <a:ea typeface="Amazon Ember Display" pitchFamily="34" charset="-122"/>
                 <a:cs typeface="Amazon Ember Display" pitchFamily="34" charset="-120"/>
               </a:rPr>
-              <a:t>结构化数据抽取的 Memory 最佳实践</a:t>
+              <a:t>各组件在 Memory 学习回路中的最佳实践</a:t>
             </a:r>
             <a:endParaRPr lang="en-US" sz="2700" dirty="0"/>
           </a:p>
@@ -10422,7 +10415,7 @@
                 <a:ea typeface="Microsoft YaHei" pitchFamily="34" charset="-122"/>
                 <a:cs typeface="Microsoft YaHei" pitchFamily="34" charset="-120"/>
               </a:rPr>
-              <a:t>把 Memory 设计成可验证的学习回路，而不是无限累积的历史上下文。</a:t>
+              <a:t>每条实践都明确责任主体，避免把 Application 编排、Harness Agent 推理和 Memory System 托管能力混为一谈。</a:t>
             </a:r>
             <a:endParaRPr lang="en-US" sz="1400" dirty="0"/>
           </a:p>
@@ -10821,7 +10814,7 @@
                 <a:ea typeface="Microsoft YaHei" pitchFamily="34" charset="-122"/>
                 <a:cs typeface="Microsoft YaHei" pitchFamily="34" charset="-120"/>
               </a:rPr>
-              <a:t>Harness Agent · 产出动作</a:t>
+              <a:t>Application · 编排两阶段</a:t>
             </a:r>
             <a:endParaRPr lang="en-US" sz="1450" dirty="0"/>
           </a:p>
@@ -10860,7 +10853,7 @@
                 <a:ea typeface="Microsoft YaHei" pitchFamily="34" charset="-122"/>
                 <a:cs typeface="Microsoft YaHei" pitchFamily="34" charset="-120"/>
               </a:rPr>
-              <a:t>生成明确、可执行的 next_actions。</a:t>
+              <a:t>顺序调用 Review 与 Revision，并保持同一 session。</a:t>
             </a:r>
             <a:endParaRPr lang="en-US" sz="1170" dirty="0"/>
           </a:p>
@@ -10967,7 +10960,7 @@
                 <a:ea typeface="Microsoft YaHei" pitchFamily="34" charset="-122"/>
                 <a:cs typeface="Microsoft YaHei" pitchFamily="34" charset="-120"/>
               </a:rPr>
-              <a:t>任务设计 · 区分问题</a:t>
+              <a:t>Reviewer / Human · 定义边界</a:t>
             </a:r>
             <a:endParaRPr lang="en-US" sz="1450" dirty="0"/>
           </a:p>
@@ -11006,7 +10999,7 @@
                 <a:ea typeface="Microsoft YaHei" pitchFamily="34" charset="-122"/>
                 <a:cs typeface="Microsoft YaHei" pitchFamily="34" charset="-120"/>
               </a:rPr>
-              <a:t>源覆盖可自审；任务边界需要规范或 Reviewer。</a:t>
+              <a:t>Harness Agent 自审源覆盖；Reviewer 定义业务边界。</a:t>
             </a:r>
             <a:endParaRPr lang="en-US" sz="1170" dirty="0"/>
           </a:p>
@@ -11113,7 +11106,7 @@
                 <a:ea typeface="Microsoft YaHei" pitchFamily="34" charset="-122"/>
                 <a:cs typeface="Microsoft YaHei" pitchFamily="34" charset="-120"/>
               </a:rPr>
-              <a:t>Memory 内容 · 保存方法</a:t>
+              <a:t>Memory 设计者 · 保存方法</a:t>
             </a:r>
             <a:endParaRPr lang="en-US" sz="1450" dirty="0"/>
           </a:p>
@@ -11152,7 +11145,7 @@
                 <a:ea typeface="Microsoft YaHei" pitchFamily="34" charset="-122"/>
                 <a:cs typeface="Microsoft YaHei" pitchFamily="34" charset="-120"/>
               </a:rPr>
-              <a:t>描述何时适用、检查什么、避免什么，不保存答案。</a:t>
+              <a:t>要求 Records 描述何时适用、检查什么、避免什么。</a:t>
             </a:r>
             <a:endParaRPr lang="en-US" sz="1170" dirty="0"/>
           </a:p>
@@ -11298,7 +11291,7 @@
                 <a:ea typeface="Microsoft YaHei" pitchFamily="34" charset="-122"/>
                 <a:cs typeface="Microsoft YaHei" pitchFamily="34" charset="-120"/>
               </a:rPr>
-              <a:t>Episode 记录一次任务；Reflection 沉淀跨任务方法。</a:t>
+              <a:t>EPISODIC：Episode 记一次任务；Reflection 沉淀跨任务方法。</a:t>
             </a:r>
             <a:endParaRPr lang="en-US" sz="1170" dirty="0"/>
           </a:p>
@@ -11405,7 +11398,7 @@
                 <a:ea typeface="Microsoft YaHei" pitchFamily="34" charset="-122"/>
                 <a:cs typeface="Microsoft YaHei" pitchFamily="34" charset="-120"/>
               </a:rPr>
-              <a:t>Harness 配置 · 控制召回</a:t>
+              <a:t>AgentCore Harness · 控制注入</a:t>
             </a:r>
             <a:endParaRPr lang="en-US" sz="1450" dirty="0"/>
           </a:p>
@@ -11444,7 +11437,7 @@
                 <a:ea typeface="Microsoft YaHei" pitchFamily="34" charset="-122"/>
                 <a:cs typeface="Microsoft YaHei" pitchFamily="34" charset="-120"/>
               </a:rPr>
-              <a:t>限制 topK、清理噪声、避免长 episode 撑爆上下文。</a:t>
+              <a:t>调用 Retrieval、设置 topK，并记录向 Harness Agent 注入的 Records。</a:t>
             </a:r>
             <a:endParaRPr lang="en-US" sz="1170" dirty="0"/>
           </a:p>
@@ -11551,7 +11544,7 @@
                 <a:ea typeface="Microsoft YaHei" pitchFamily="34" charset="-122"/>
                 <a:cs typeface="Microsoft YaHei" pitchFamily="34" charset="-120"/>
               </a:rPr>
-              <a:t>Evaluation · 人工校准</a:t>
+              <a:t>Reviewer / Human · 校准结果</a:t>
             </a:r>
             <a:endParaRPr lang="en-US" sz="1450" dirty="0"/>
           </a:p>
@@ -11590,7 +11583,7 @@
                 <a:ea typeface="Microsoft YaHei" pitchFamily="34" charset="-122"/>
                 <a:cs typeface="Microsoft YaHei" pitchFamily="34" charset="-120"/>
               </a:rPr>
-              <a:t>分别检查忠实性、完整性、粒度与过度抽取。</a:t>
+              <a:t>分别检查忠实性、完整性、粒度、过度抽取和业务边界。</a:t>
             </a:r>
             <a:endParaRPr lang="en-US" sz="1170" dirty="0"/>
           </a:p>
@@ -11656,7 +11649,7 @@
                 <a:ea typeface="Amazon Ember Display" pitchFamily="34" charset="-122"/>
                 <a:cs typeface="Amazon Ember Display" pitchFamily="34" charset="-120"/>
               </a:rPr>
-              <a:t>Memory 的价值不是记住历史答案，而是复用经过 Review 得到的抽取策略。</a:t>
+              <a:t>Harness Agent 产 Review；Memory System 生成/检索；AgentCore Harness 注入；Reviewer / Human 判断质量。</a:t>
             </a:r>
             <a:endParaRPr lang="en-US" sz="1550" dirty="0"/>
           </a:p>
@@ -11868,7 +11861,7 @@
                 <a:ea typeface="Amazon Ember Display" pitchFamily="34" charset="-122"/>
                 <a:cs typeface="Amazon Ember Display" pitchFamily="34" charset="-120"/>
               </a:rPr>
-              <a:t>结构化抽取真正难在哪里</a:t>
+              <a:t>Harness Agent 的结构化抽取难点</a:t>
             </a:r>
             <a:endParaRPr lang="en-US" sz="2700" dirty="0"/>
           </a:p>
@@ -11907,7 +11900,7 @@
                 <a:ea typeface="Microsoft YaHei" pitchFamily="34" charset="-122"/>
                 <a:cs typeface="Microsoft YaHei" pitchFamily="34" charset="-120"/>
               </a:rPr>
-              <a:t>难点不是生成合法 JSON，而是完整识别散落在不同载体中的“应该抽取的信息”。</a:t>
+              <a:t>Harness Agent 生成合法 JSON 并不难；难点是完整识别散落在不同载体中的目标信息。</a:t>
             </a:r>
             <a:endParaRPr lang="en-US" sz="1400" dirty="0"/>
           </a:p>
@@ -11973,7 +11966,7 @@
                 <a:ea typeface="Amazon Ember Display" pitchFamily="34" charset="-122"/>
                 <a:cs typeface="Amazon Ember Display" pitchFamily="34" charset="-120"/>
               </a:rPr>
-              <a:t>真实输入：正文 + 表格</a:t>
+              <a:t>APPLICATION 提供的真实输入</a:t>
             </a:r>
             <a:endParaRPr lang="en-US" sz="1150" dirty="0"/>
           </a:p>
@@ -12213,7 +12206,7 @@
                 <a:ea typeface="Amazon Ember Display" pitchFamily="34" charset="-122"/>
                 <a:cs typeface="Amazon Ember Display" pitchFamily="34" charset="-120"/>
               </a:rPr>
-              <a:t>常见漏项</a:t>
+              <a:t>HARNESS AGENT · 常见漏项</a:t>
             </a:r>
             <a:endParaRPr lang="en-US" sz="1150" dirty="0"/>
           </a:p>
@@ -12252,7 +12245,7 @@
                 <a:ea typeface="Microsoft YaHei" pitchFamily="34" charset="-122"/>
                 <a:cs typeface="Microsoft YaHei" pitchFamily="34" charset="-120"/>
               </a:rPr>
-              <a:t>模型通常先抓住数值参数</a:t>
+              <a:t>Harness Agent 通常先抓住数值参数</a:t>
             </a:r>
             <a:endParaRPr lang="en-US" sz="1700" dirty="0"/>
           </a:p>
@@ -12425,7 +12418,7 @@
                 <a:ea typeface="Amazon Ember Display" pitchFamily="34" charset="-122"/>
                 <a:cs typeface="Amazon Ember Display" pitchFamily="34" charset="-120"/>
               </a:rPr>
-              <a:t>真正的问题：Agent 如何知道自己漏了什么？</a:t>
+              <a:t>真正的问题：Harness Agent 如何发现自己的源覆盖遗漏？</a:t>
             </a:r>
             <a:endParaRPr lang="en-US" sz="1650" dirty="0"/>
           </a:p>
@@ -12637,7 +12630,7 @@
                 <a:ea typeface="Amazon Ember Display" pitchFamily="34" charset="-122"/>
                 <a:cs typeface="Amazon Ember Display" pitchFamily="34" charset="-120"/>
               </a:rPr>
-              <a:t>Memory 应该在抽取回路中做什么</a:t>
+              <a:t>端到端抽取回路：每一步由谁执行</a:t>
             </a:r>
             <a:endParaRPr lang="en-US" sz="2700" dirty="0"/>
           </a:p>
@@ -12676,7 +12669,7 @@
                 <a:ea typeface="Microsoft YaHei" pitchFamily="34" charset="-122"/>
                 <a:cs typeface="Microsoft YaHei" pitchFamily="34" charset="-120"/>
               </a:rPr>
-              <a:t>不是保存上一次答案，而是保存下一次任务可复用的抽取策略。</a:t>
+              <a:t>Application 负责调用与实验控制；Harness Agent 负责抽取与自审；Memory System 负责 EPISODIC 处理与跨 session 召回。</a:t>
             </a:r>
             <a:endParaRPr lang="en-US" sz="1400" dirty="0"/>
           </a:p>
@@ -12690,12 +12683,12 @@
         </p:nvSpPr>
         <p:spPr>
           <a:xfrm>
-            <a:off x="566928" y="2057400"/>
-            <a:ext cx="1874520" cy="1143000"/>
+            <a:off x="566928" y="1755648"/>
+            <a:ext cx="1874520" cy="1600200"/>
           </a:xfrm>
           <a:prstGeom prst="roundRect">
             <a:avLst>
-              <a:gd name="adj" fmla="val 6400"/>
+              <a:gd name="adj" fmla="val 4571"/>
             </a:avLst>
           </a:prstGeom>
           <a:solidFill>
@@ -12717,7 +12710,7 @@
         </p:nvSpPr>
         <p:spPr>
           <a:xfrm>
-            <a:off x="768096" y="2194560"/>
+            <a:off x="768096" y="1892808"/>
             <a:ext cx="1472184" cy="256032"/>
           </a:xfrm>
           <a:prstGeom prst="rect">
@@ -12742,7 +12735,7 @@
                 <a:ea typeface="Amazon Ember Display" pitchFamily="34" charset="-122"/>
                 <a:cs typeface="Amazon Ember Display" pitchFamily="34" charset="-120"/>
               </a:rPr>
-              <a:t>①</a:t>
+              <a:t>① APPLICATION</a:t>
             </a:r>
             <a:endParaRPr lang="en-US" sz="1150" dirty="0"/>
           </a:p>
@@ -12756,7 +12749,7 @@
         </p:nvSpPr>
         <p:spPr>
           <a:xfrm>
-            <a:off x="768096" y="2542032"/>
+            <a:off x="768096" y="2240280"/>
             <a:ext cx="1472184" cy="384048"/>
           </a:xfrm>
           <a:prstGeom prst="rect">
@@ -12773,7 +12766,7 @@
               <a:buNone/>
             </a:pPr>
             <a:r>
-              <a:rPr lang="en-US" sz="1700" b="1" dirty="0">
+              <a:rPr lang="en-US" sz="1500" b="1" dirty="0">
                 <a:solidFill>
                   <a:srgbClr val="FFFFFF"/>
                 </a:solidFill>
@@ -12781,9 +12774,9 @@
                 <a:ea typeface="Microsoft YaHei" pitchFamily="34" charset="-122"/>
                 <a:cs typeface="Microsoft YaHei" pitchFamily="34" charset="-120"/>
               </a:rPr>
-              <a:t>抽取草稿</a:t>
-            </a:r>
-            <a:endParaRPr lang="en-US" sz="1700" dirty="0"/>
+              <a:t>启动源任务</a:t>
+            </a:r>
+            <a:endParaRPr lang="en-US" sz="1500" dirty="0"/>
           </a:p>
         </p:txBody>
       </p:sp>
@@ -12795,8 +12788,8 @@
         </p:nvSpPr>
         <p:spPr>
           <a:xfrm>
-            <a:off x="768096" y="2999232"/>
-            <a:ext cx="1472184" cy="73152"/>
+            <a:off x="768096" y="2697480"/>
+            <a:ext cx="1472184" cy="530352"/>
           </a:xfrm>
           <a:prstGeom prst="rect">
             <a:avLst/>
@@ -12812,7 +12805,7 @@
               <a:buNone/>
             </a:pPr>
             <a:r>
-              <a:rPr lang="en-US" sz="1300" dirty="0">
+              <a:rPr lang="en-US" sz="1120" dirty="0">
                 <a:solidFill>
                   <a:srgbClr val="CFD9E4"/>
                 </a:solidFill>
@@ -12820,9 +12813,9 @@
                 <a:ea typeface="Microsoft YaHei" pitchFamily="34" charset="-122"/>
                 <a:cs typeface="Microsoft YaHei" pitchFamily="34" charset="-120"/>
               </a:rPr>
-              <a:t>当前文档</a:t>
-            </a:r>
-            <a:endParaRPr lang="en-US" sz="1300" dirty="0"/>
+              <a:t>向 Harness Agent 提交源文档与抽取 Prompt</a:t>
+            </a:r>
+            <a:endParaRPr lang="en-US" sz="1120" dirty="0"/>
           </a:p>
         </p:txBody>
       </p:sp>
@@ -12834,7 +12827,7 @@
         </p:nvSpPr>
         <p:spPr>
           <a:xfrm>
-            <a:off x="2468880" y="2350008"/>
+            <a:off x="2441448" y="2267712"/>
             <a:ext cx="384048" cy="548640"/>
           </a:xfrm>
           <a:prstGeom prst="rect">
@@ -12873,12 +12866,12 @@
         </p:nvSpPr>
         <p:spPr>
           <a:xfrm>
-            <a:off x="2852928" y="2057400"/>
-            <a:ext cx="1874520" cy="1143000"/>
+            <a:off x="2770632" y="1755648"/>
+            <a:ext cx="1874520" cy="1600200"/>
           </a:xfrm>
           <a:prstGeom prst="roundRect">
             <a:avLst>
-              <a:gd name="adj" fmla="val 6400"/>
+              <a:gd name="adj" fmla="val 4571"/>
             </a:avLst>
           </a:prstGeom>
           <a:solidFill>
@@ -12900,7 +12893,7 @@
         </p:nvSpPr>
         <p:spPr>
           <a:xfrm>
-            <a:off x="3054096" y="2194560"/>
+            <a:off x="2971800" y="1892808"/>
             <a:ext cx="1472184" cy="256032"/>
           </a:xfrm>
           <a:prstGeom prst="rect">
@@ -12925,7 +12918,7 @@
                 <a:ea typeface="Amazon Ember Display" pitchFamily="34" charset="-122"/>
                 <a:cs typeface="Amazon Ember Display" pitchFamily="34" charset="-120"/>
               </a:rPr>
-              <a:t>②</a:t>
+              <a:t>② HARNESS AGENT</a:t>
             </a:r>
             <a:endParaRPr lang="en-US" sz="1150" dirty="0"/>
           </a:p>
@@ -12939,7 +12932,7 @@
         </p:nvSpPr>
         <p:spPr>
           <a:xfrm>
-            <a:off x="3054096" y="2542032"/>
+            <a:off x="2971800" y="2240280"/>
             <a:ext cx="1472184" cy="384048"/>
           </a:xfrm>
           <a:prstGeom prst="rect">
@@ -12956,7 +12949,7 @@
               <a:buNone/>
             </a:pPr>
             <a:r>
-              <a:rPr lang="en-US" sz="1700" b="1" dirty="0">
+              <a:rPr lang="en-US" sz="1500" b="1" dirty="0">
                 <a:solidFill>
                   <a:srgbClr val="FFFFFF"/>
                 </a:solidFill>
@@ -12964,9 +12957,9 @@
                 <a:ea typeface="Microsoft YaHei" pitchFamily="34" charset="-122"/>
                 <a:cs typeface="Microsoft YaHei" pitchFamily="34" charset="-120"/>
               </a:rPr>
-              <a:t>Review</a:t>
-            </a:r>
-            <a:endParaRPr lang="en-US" sz="1700" dirty="0"/>
+              <a:t>抽取 + Self-review</a:t>
+            </a:r>
+            <a:endParaRPr lang="en-US" sz="1500" dirty="0"/>
           </a:p>
         </p:txBody>
       </p:sp>
@@ -12978,8 +12971,8 @@
         </p:nvSpPr>
         <p:spPr>
           <a:xfrm>
-            <a:off x="3054096" y="2999232"/>
-            <a:ext cx="1472184" cy="73152"/>
+            <a:off x="2971800" y="2697480"/>
+            <a:ext cx="1472184" cy="530352"/>
           </a:xfrm>
           <a:prstGeom prst="rect">
             <a:avLst/>
@@ -12995,7 +12988,7 @@
               <a:buNone/>
             </a:pPr>
             <a:r>
-              <a:rPr lang="en-US" sz="1300" dirty="0">
+              <a:rPr lang="en-US" sz="1120" dirty="0">
                 <a:solidFill>
                   <a:srgbClr val="CFD9E4"/>
                 </a:solidFill>
@@ -13003,9 +12996,9 @@
                 <a:ea typeface="Microsoft YaHei" pitchFamily="34" charset="-122"/>
                 <a:cs typeface="Microsoft YaHei" pitchFamily="34" charset="-120"/>
               </a:rPr>
-              <a:t>漏了什么？</a:t>
-            </a:r>
-            <a:endParaRPr lang="en-US" sz="1300" dirty="0"/>
+              <a:t>产出 self_review、next_actions 与最终 JSON</a:t>
+            </a:r>
+            <a:endParaRPr lang="en-US" sz="1120" dirty="0"/>
           </a:p>
         </p:txBody>
       </p:sp>
@@ -13017,7 +13010,7 @@
         </p:nvSpPr>
         <p:spPr>
           <a:xfrm>
-            <a:off x="4754880" y="2350008"/>
+            <a:off x="4645152" y="2267712"/>
             <a:ext cx="384048" cy="548640"/>
           </a:xfrm>
           <a:prstGeom prst="rect">
@@ -13056,12 +13049,12 @@
         </p:nvSpPr>
         <p:spPr>
           <a:xfrm>
-            <a:off x="5138928" y="2057400"/>
-            <a:ext cx="1874520" cy="1143000"/>
+            <a:off x="4974336" y="1755648"/>
+            <a:ext cx="1874520" cy="1600200"/>
           </a:xfrm>
           <a:prstGeom prst="roundRect">
             <a:avLst>
-              <a:gd name="adj" fmla="val 6400"/>
+              <a:gd name="adj" fmla="val 4571"/>
             </a:avLst>
           </a:prstGeom>
           <a:solidFill>
@@ -13083,7 +13076,7 @@
         </p:nvSpPr>
         <p:spPr>
           <a:xfrm>
-            <a:off x="5340096" y="2194560"/>
+            <a:off x="5175504" y="1892808"/>
             <a:ext cx="1472184" cy="256032"/>
           </a:xfrm>
           <a:prstGeom prst="rect">
@@ -13108,7 +13101,7 @@
                 <a:ea typeface="Amazon Ember Display" pitchFamily="34" charset="-122"/>
                 <a:cs typeface="Amazon Ember Display" pitchFamily="34" charset="-120"/>
               </a:rPr>
-              <a:t>③</a:t>
+              <a:t>③ MEMORY SYSTEM</a:t>
             </a:r>
             <a:endParaRPr lang="en-US" sz="1150" dirty="0"/>
           </a:p>
@@ -13122,7 +13115,7 @@
         </p:nvSpPr>
         <p:spPr>
           <a:xfrm>
-            <a:off x="5340096" y="2542032"/>
+            <a:off x="5175504" y="2240280"/>
             <a:ext cx="1472184" cy="384048"/>
           </a:xfrm>
           <a:prstGeom prst="rect">
@@ -13139,7 +13132,7 @@
               <a:buNone/>
             </a:pPr>
             <a:r>
-              <a:rPr lang="en-US" sz="1700" b="1" dirty="0">
+              <a:rPr lang="en-US" sz="1500" b="1" dirty="0">
                 <a:solidFill>
                   <a:srgbClr val="FFFFFF"/>
                 </a:solidFill>
@@ -13147,9 +13140,9 @@
                 <a:ea typeface="Microsoft YaHei" pitchFamily="34" charset="-122"/>
                 <a:cs typeface="Microsoft YaHei" pitchFamily="34" charset="-120"/>
               </a:rPr>
-              <a:t>可复用经验</a:t>
-            </a:r>
-            <a:endParaRPr lang="en-US" sz="1700" dirty="0"/>
+              <a:t>EPISODIC 处理</a:t>
+            </a:r>
+            <a:endParaRPr lang="en-US" sz="1500" dirty="0"/>
           </a:p>
         </p:txBody>
       </p:sp>
@@ -13161,8 +13154,8 @@
         </p:nvSpPr>
         <p:spPr>
           <a:xfrm>
-            <a:off x="5340096" y="2999232"/>
-            <a:ext cx="1472184" cy="73152"/>
+            <a:off x="5175504" y="2697480"/>
+            <a:ext cx="1472184" cy="530352"/>
           </a:xfrm>
           <a:prstGeom prst="rect">
             <a:avLst/>
@@ -13178,7 +13171,7 @@
               <a:buNone/>
             </a:pPr>
             <a:r>
-              <a:rPr lang="en-US" sz="1300" dirty="0">
+              <a:rPr lang="en-US" sz="1080" dirty="0">
                 <a:solidFill>
                   <a:srgbClr val="CFD9E4"/>
                 </a:solidFill>
@@ -13186,9 +13179,9 @@
                 <a:ea typeface="Microsoft YaHei" pitchFamily="34" charset="-122"/>
                 <a:cs typeface="Microsoft YaHei" pitchFamily="34" charset="-120"/>
               </a:rPr>
-              <a:t>形成策略</a:t>
-            </a:r>
-            <a:endParaRPr lang="en-US" sz="1300" dirty="0"/>
+              <a:t>Event Storage → Extraction → Consolidation → Reflection</a:t>
+            </a:r>
+            <a:endParaRPr lang="en-US" sz="1080" dirty="0"/>
           </a:p>
         </p:txBody>
       </p:sp>
@@ -13200,7 +13193,7 @@
         </p:nvSpPr>
         <p:spPr>
           <a:xfrm>
-            <a:off x="7040880" y="2350008"/>
+            <a:off x="6848856" y="2267712"/>
             <a:ext cx="384048" cy="548640"/>
           </a:xfrm>
           <a:prstGeom prst="rect">
@@ -13239,12 +13232,12 @@
         </p:nvSpPr>
         <p:spPr>
           <a:xfrm>
-            <a:off x="7424928" y="2057400"/>
-            <a:ext cx="1874520" cy="1143000"/>
+            <a:off x="7178040" y="1755648"/>
+            <a:ext cx="1874520" cy="1600200"/>
           </a:xfrm>
           <a:prstGeom prst="roundRect">
             <a:avLst>
-              <a:gd name="adj" fmla="val 6400"/>
+              <a:gd name="adj" fmla="val 4571"/>
             </a:avLst>
           </a:prstGeom>
           <a:solidFill>
@@ -13266,7 +13259,7 @@
         </p:nvSpPr>
         <p:spPr>
           <a:xfrm>
-            <a:off x="7626096" y="2194560"/>
+            <a:off x="7379208" y="1892808"/>
             <a:ext cx="1472184" cy="256032"/>
           </a:xfrm>
           <a:prstGeom prst="rect">
@@ -13291,7 +13284,7 @@
                 <a:ea typeface="Amazon Ember Display" pitchFamily="34" charset="-122"/>
                 <a:cs typeface="Amazon Ember Display" pitchFamily="34" charset="-120"/>
               </a:rPr>
-              <a:t>④</a:t>
+              <a:t>④ AGENTCORE HARNESS</a:t>
             </a:r>
             <a:endParaRPr lang="en-US" sz="1150" dirty="0"/>
           </a:p>
@@ -13305,7 +13298,7 @@
         </p:nvSpPr>
         <p:spPr>
           <a:xfrm>
-            <a:off x="7626096" y="2542032"/>
+            <a:off x="7379208" y="2240280"/>
             <a:ext cx="1472184" cy="384048"/>
           </a:xfrm>
           <a:prstGeom prst="rect">
@@ -13322,7 +13315,7 @@
               <a:buNone/>
             </a:pPr>
             <a:r>
-              <a:rPr lang="en-US" sz="1700" b="1" dirty="0">
+              <a:rPr lang="en-US" sz="1450" b="1" dirty="0">
                 <a:solidFill>
                   <a:srgbClr val="FFFFFF"/>
                 </a:solidFill>
@@ -13330,9 +13323,9 @@
                 <a:ea typeface="Microsoft YaHei" pitchFamily="34" charset="-122"/>
                 <a:cs typeface="Microsoft YaHei" pitchFamily="34" charset="-120"/>
               </a:rPr>
-              <a:t>Memory</a:t>
-            </a:r>
-            <a:endParaRPr lang="en-US" sz="1700" dirty="0"/>
+              <a:t>调用 Retrieval + 注入</a:t>
+            </a:r>
+            <a:endParaRPr lang="en-US" sz="1450" dirty="0"/>
           </a:p>
         </p:txBody>
       </p:sp>
@@ -13344,8 +13337,8 @@
         </p:nvSpPr>
         <p:spPr>
           <a:xfrm>
-            <a:off x="7626096" y="2999232"/>
-            <a:ext cx="1472184" cy="73152"/>
+            <a:off x="7379208" y="2697480"/>
+            <a:ext cx="1472184" cy="530352"/>
           </a:xfrm>
           <a:prstGeom prst="rect">
             <a:avLst/>
@@ -13361,7 +13354,7 @@
               <a:buNone/>
             </a:pPr>
             <a:r>
-              <a:rPr lang="en-US" sz="1300" dirty="0">
+              <a:rPr lang="en-US" sz="1080" dirty="0">
                 <a:solidFill>
                   <a:srgbClr val="CFD9E4"/>
                 </a:solidFill>
@@ -13369,9 +13362,9 @@
                 <a:ea typeface="Microsoft YaHei" pitchFamily="34" charset="-122"/>
                 <a:cs typeface="Microsoft YaHei" pitchFamily="34" charset="-120"/>
               </a:rPr>
-              <a:t>跨 session</a:t>
-            </a:r>
-            <a:endParaRPr lang="en-US" sz="1300" dirty="0"/>
+              <a:t>调用 Memory System 检索 actor records，并注入新 session</a:t>
+            </a:r>
+            <a:endParaRPr lang="en-US" sz="1080" dirty="0"/>
           </a:p>
         </p:txBody>
       </p:sp>
@@ -13383,7 +13376,7 @@
         </p:nvSpPr>
         <p:spPr>
           <a:xfrm>
-            <a:off x="9326880" y="2350008"/>
+            <a:off x="9052560" y="2267712"/>
             <a:ext cx="384048" cy="548640"/>
           </a:xfrm>
           <a:prstGeom prst="rect">
@@ -13422,12 +13415,12 @@
         </p:nvSpPr>
         <p:spPr>
           <a:xfrm>
-            <a:off x="9710928" y="2057400"/>
-            <a:ext cx="1920240" cy="1143000"/>
+            <a:off x="9381744" y="1755648"/>
+            <a:ext cx="1874520" cy="1600200"/>
           </a:xfrm>
           <a:prstGeom prst="roundRect">
             <a:avLst>
-              <a:gd name="adj" fmla="val 6400"/>
+              <a:gd name="adj" fmla="val 4571"/>
             </a:avLst>
           </a:prstGeom>
           <a:solidFill>
@@ -13449,8 +13442,8 @@
         </p:nvSpPr>
         <p:spPr>
           <a:xfrm>
-            <a:off x="9912096" y="2194560"/>
-            <a:ext cx="1517904" cy="256032"/>
+            <a:off x="9582912" y="1892808"/>
+            <a:ext cx="1472184" cy="256032"/>
           </a:xfrm>
           <a:prstGeom prst="rect">
             <a:avLst/>
@@ -13474,7 +13467,7 @@
                 <a:ea typeface="Amazon Ember Display" pitchFamily="34" charset="-122"/>
                 <a:cs typeface="Amazon Ember Display" pitchFamily="34" charset="-120"/>
               </a:rPr>
-              <a:t>⑤</a:t>
+              <a:t>⑤ HARNESS AGENT</a:t>
             </a:r>
             <a:endParaRPr lang="en-US" sz="1150" dirty="0"/>
           </a:p>
@@ -13488,24 +13481,24 @@
         </p:nvSpPr>
         <p:spPr>
           <a:xfrm>
-            <a:off x="9912096" y="2542032"/>
-            <a:ext cx="1517904" cy="384048"/>
-          </a:xfrm>
-          <a:prstGeom prst="rect">
-            <a:avLst/>
-          </a:prstGeom>
-          <a:noFill/>
-          <a:ln/>
-        </p:spPr>
-        <p:txBody>
-          <a:bodyPr wrap="square" lIns="0" tIns="0" rIns="0" bIns="0" rtlCol="0" anchor="ctr"/>
-          <a:lstStyle/>
-          <a:p>
-            <a:pPr indent="0" marL="0">
-              <a:buNone/>
-            </a:pPr>
-            <a:r>
-              <a:rPr lang="en-US" sz="1700" b="1" dirty="0">
+            <a:off x="9582912" y="2240280"/>
+            <a:ext cx="1472184" cy="384048"/>
+          </a:xfrm>
+          <a:prstGeom prst="rect">
+            <a:avLst/>
+          </a:prstGeom>
+          <a:noFill/>
+          <a:ln/>
+        </p:spPr>
+        <p:txBody>
+          <a:bodyPr wrap="square" lIns="0" tIns="0" rIns="0" bIns="0" rtlCol="0" anchor="ctr"/>
+          <a:lstStyle/>
+          <a:p>
+            <a:pPr indent="0" marL="0">
+              <a:buNone/>
+            </a:pPr>
+            <a:r>
+              <a:rPr lang="en-US" sz="1500" b="1" dirty="0">
                 <a:solidFill>
                   <a:srgbClr val="FFFFFF"/>
                 </a:solidFill>
@@ -13513,9 +13506,9 @@
                 <a:ea typeface="Microsoft YaHei" pitchFamily="34" charset="-122"/>
                 <a:cs typeface="Microsoft YaHei" pitchFamily="34" charset="-120"/>
               </a:rPr>
-              <a:t>下一份文档</a:t>
-            </a:r>
-            <a:endParaRPr lang="en-US" sz="1700" dirty="0"/>
+              <a:t>执行目标抽取</a:t>
+            </a:r>
+            <a:endParaRPr lang="en-US" sz="1500" dirty="0"/>
           </a:p>
         </p:txBody>
       </p:sp>
@@ -13527,8 +13520,8 @@
         </p:nvSpPr>
         <p:spPr>
           <a:xfrm>
-            <a:off x="9912096" y="2999232"/>
-            <a:ext cx="1517904" cy="73152"/>
+            <a:off x="9582912" y="2697480"/>
+            <a:ext cx="1472184" cy="530352"/>
           </a:xfrm>
           <a:prstGeom prst="rect">
             <a:avLst/>
@@ -13544,7 +13537,7 @@
               <a:buNone/>
             </a:pPr>
             <a:r>
-              <a:rPr lang="en-US" sz="1300" dirty="0">
+              <a:rPr lang="en-US" sz="1120" dirty="0">
                 <a:solidFill>
                   <a:srgbClr val="CFD9E4"/>
                 </a:solidFill>
@@ -13552,9 +13545,9 @@
                 <a:ea typeface="Microsoft YaHei" pitchFamily="34" charset="-122"/>
                 <a:cs typeface="Microsoft YaHei" pitchFamily="34" charset="-120"/>
               </a:rPr>
-              <a:t>复用经验</a:t>
-            </a:r>
-            <a:endParaRPr lang="en-US" sz="1300" dirty="0"/>
+              <a:t>读取新文档与注入的 Records，输出最终 JSON</a:t>
+            </a:r>
+            <a:endParaRPr lang="en-US" sz="1120" dirty="0"/>
           </a:p>
         </p:txBody>
       </p:sp>
@@ -13566,12 +13559,12 @@
         </p:nvSpPr>
         <p:spPr>
           <a:xfrm>
-            <a:off x="566928" y="3749040"/>
-            <a:ext cx="3429000" cy="1417320"/>
+            <a:off x="566928" y="3794760"/>
+            <a:ext cx="3429000" cy="1298448"/>
           </a:xfrm>
           <a:prstGeom prst="roundRect">
             <a:avLst>
-              <a:gd name="adj" fmla="val 5161"/>
+              <a:gd name="adj" fmla="val 5634"/>
             </a:avLst>
           </a:prstGeom>
           <a:solidFill>
@@ -13593,7 +13586,7 @@
         </p:nvSpPr>
         <p:spPr>
           <a:xfrm>
-            <a:off x="768096" y="3886200"/>
+            <a:off x="768096" y="3931920"/>
             <a:ext cx="3026664" cy="256032"/>
           </a:xfrm>
           <a:prstGeom prst="rect">
@@ -13612,13 +13605,13 @@
             <a:r>
               <a:rPr lang="en-US" sz="1150" b="1" dirty="0">
                 <a:solidFill>
-                  <a:srgbClr val="FF6A3D"/>
+                  <a:srgbClr val="42B4FF"/>
                 </a:solidFill>
                 <a:latin typeface="Amazon Ember Display" pitchFamily="34" charset="0"/>
                 <a:ea typeface="Amazon Ember Display" pitchFamily="34" charset="-122"/>
                 <a:cs typeface="Amazon Ember Display" pitchFamily="34" charset="-120"/>
               </a:rPr>
-              <a:t>容易漏什么</a:t>
+              <a:t>源任务产物 · HARNESS AGENT</a:t>
             </a:r>
             <a:endParaRPr lang="en-US" sz="1150" dirty="0"/>
           </a:p>
@@ -13632,8 +13625,8 @@
         </p:nvSpPr>
         <p:spPr>
           <a:xfrm>
-            <a:off x="768096" y="4233672"/>
-            <a:ext cx="3026664" cy="804672"/>
+            <a:off x="768096" y="4279392"/>
+            <a:ext cx="3026664" cy="685800"/>
           </a:xfrm>
           <a:prstGeom prst="rect">
             <a:avLst/>
@@ -13657,7 +13650,7 @@
                 <a:ea typeface="Microsoft YaHei" pitchFamily="34" charset="-122"/>
                 <a:cs typeface="Microsoft YaHei" pitchFamily="34" charset="-120"/>
               </a:rPr>
-              <a:t>表格、附注、流程要求、图片限制</a:t>
+              <a:t>self_review + next_actions + 最终 JSON</a:t>
             </a:r>
             <a:endParaRPr lang="en-US" sz="1300" dirty="0"/>
           </a:p>
@@ -13671,12 +13664,12 @@
         </p:nvSpPr>
         <p:spPr>
           <a:xfrm>
-            <a:off x="4379976" y="3749040"/>
-            <a:ext cx="3429000" cy="1417320"/>
+            <a:off x="4379976" y="3794760"/>
+            <a:ext cx="3429000" cy="1298448"/>
           </a:xfrm>
           <a:prstGeom prst="roundRect">
             <a:avLst>
-              <a:gd name="adj" fmla="val 5161"/>
+              <a:gd name="adj" fmla="val 5634"/>
             </a:avLst>
           </a:prstGeom>
           <a:solidFill>
@@ -13698,7 +13691,7 @@
         </p:nvSpPr>
         <p:spPr>
           <a:xfrm>
-            <a:off x="4581144" y="3886200"/>
+            <a:off x="4581144" y="3931920"/>
             <a:ext cx="3026664" cy="256032"/>
           </a:xfrm>
           <a:prstGeom prst="rect">
@@ -13717,13 +13710,13 @@
             <a:r>
               <a:rPr lang="en-US" sz="1150" b="1" dirty="0">
                 <a:solidFill>
-                  <a:srgbClr val="42B4FF"/>
+                  <a:srgbClr val="FF6A3D"/>
                 </a:solidFill>
                 <a:latin typeface="Amazon Ember Display" pitchFamily="34" charset="0"/>
                 <a:ea typeface="Amazon Ember Display" pitchFamily="34" charset="-122"/>
                 <a:cs typeface="Amazon Ember Display" pitchFamily="34" charset="-120"/>
               </a:rPr>
-              <a:t>应该检查什么</a:t>
+              <a:t>托管记录 · MEMORY SYSTEM</a:t>
             </a:r>
             <a:endParaRPr lang="en-US" sz="1150" dirty="0"/>
           </a:p>
@@ -13737,8 +13730,8 @@
         </p:nvSpPr>
         <p:spPr>
           <a:xfrm>
-            <a:off x="4581144" y="4233672"/>
-            <a:ext cx="3026664" cy="804672"/>
+            <a:off x="4581144" y="4279392"/>
+            <a:ext cx="3026664" cy="685800"/>
           </a:xfrm>
           <a:prstGeom prst="rect">
             <a:avLst/>
@@ -13762,7 +13755,7 @@
                 <a:ea typeface="Microsoft YaHei" pitchFamily="34" charset="-122"/>
                 <a:cs typeface="Microsoft YaHei" pitchFamily="34" charset="-120"/>
               </a:rPr>
-              <a:t>覆盖、遗漏、格式、粒度、冲突</a:t>
+              <a:t>1 session-level episode + actor-level reflections</a:t>
             </a:r>
             <a:endParaRPr lang="en-US" sz="1300" dirty="0"/>
           </a:p>
@@ -13776,12 +13769,12 @@
         </p:nvSpPr>
         <p:spPr>
           <a:xfrm>
-            <a:off x="8193024" y="3749040"/>
-            <a:ext cx="3438144" cy="1417320"/>
+            <a:off x="8193024" y="3794760"/>
+            <a:ext cx="3438144" cy="1298448"/>
           </a:xfrm>
           <a:prstGeom prst="roundRect">
             <a:avLst>
-              <a:gd name="adj" fmla="val 5161"/>
+              <a:gd name="adj" fmla="val 5634"/>
             </a:avLst>
           </a:prstGeom>
           <a:solidFill>
@@ -13803,7 +13796,7 @@
         </p:nvSpPr>
         <p:spPr>
           <a:xfrm>
-            <a:off x="8394192" y="3886200"/>
+            <a:off x="8394192" y="3931920"/>
             <a:ext cx="3035808" cy="256032"/>
           </a:xfrm>
           <a:prstGeom prst="rect">
@@ -13828,7 +13821,7 @@
                 <a:ea typeface="Amazon Ember Display" pitchFamily="34" charset="-122"/>
                 <a:cs typeface="Amazon Ember Display" pitchFamily="34" charset="-120"/>
               </a:rPr>
-              <a:t>下次怎么做</a:t>
+              <a:t>目标任务产物 · HARNESS AGENT</a:t>
             </a:r>
             <a:endParaRPr lang="en-US" sz="1150" dirty="0"/>
           </a:p>
@@ -13842,8 +13835,8 @@
         </p:nvSpPr>
         <p:spPr>
           <a:xfrm>
-            <a:off x="8394192" y="4233672"/>
-            <a:ext cx="3035808" cy="804672"/>
+            <a:off x="8394192" y="4279392"/>
+            <a:ext cx="3035808" cy="685800"/>
           </a:xfrm>
           <a:prstGeom prst="rect">
             <a:avLst/>
@@ -13867,7 +13860,7 @@
                 <a:ea typeface="Microsoft YaHei" pitchFamily="34" charset="-122"/>
                 <a:cs typeface="Microsoft YaHei" pitchFamily="34" charset="-120"/>
               </a:rPr>
-              <a:t>先扫章节与表格，再按 next_actions 修订</a:t>
+              <a:t>Memory enabled / disabled 两组最终 JSON</a:t>
             </a:r>
             <a:endParaRPr lang="en-US" sz="1300" dirty="0"/>
           </a:p>
@@ -13881,7 +13874,7 @@
         </p:nvSpPr>
         <p:spPr>
           <a:xfrm>
-            <a:off x="566928" y="5468112"/>
+            <a:off x="566928" y="5376672"/>
             <a:ext cx="11064240" cy="777240"/>
           </a:xfrm>
           <a:prstGeom prst="roundRect">
@@ -13908,7 +13901,7 @@
         </p:nvSpPr>
         <p:spPr>
           <a:xfrm>
-            <a:off x="822960" y="5468112"/>
+            <a:off x="822960" y="5376672"/>
             <a:ext cx="10552176" cy="777240"/>
           </a:xfrm>
           <a:prstGeom prst="rect">
@@ -13933,7 +13926,7 @@
                 <a:ea typeface="Amazon Ember Display" pitchFamily="34" charset="-122"/>
                 <a:cs typeface="Amazon Ember Display" pitchFamily="34" charset="-120"/>
               </a:rPr>
-              <a:t>Memory 的价值：复用 Review 得到的方法，而不是复读历史结果。</a:t>
+              <a:t>端到端链路：Application 调用 → Harness Agent 产轨迹 → Memory System 提炼/检索 → AgentCore Harness 注入</a:t>
             </a:r>
             <a:endParaRPr lang="en-US" sz="1650" dirty="0"/>
           </a:p>
@@ -14145,7 +14138,7 @@
                 <a:ea typeface="Amazon Ember Display" pitchFamily="34" charset="-122"/>
                 <a:cs typeface="Amazon Ember Display" pitchFamily="34" charset="-120"/>
               </a:rPr>
-              <a:t>三个实验，回答三个不同问题</a:t>
+              <a:t>三个实验：调用链和系统边界</a:t>
             </a:r>
             <a:endParaRPr lang="en-US" sz="2700" dirty="0"/>
           </a:p>
@@ -14184,7 +14177,7 @@
                 <a:ea typeface="Microsoft YaHei" pitchFamily="34" charset="-122"/>
                 <a:cs typeface="Microsoft YaHei" pitchFamily="34" charset="-120"/>
               </a:rPr>
-              <a:t>先判断学习信号是否有效，再生成托管 Memory，最后用留出文档验证跨 session 影响。</a:t>
+              <a:t>三项实验使用不同的反思主体与 Memory 机制；每项实验必须分别解释执行者、输入、产物和验证方式。</a:t>
             </a:r>
             <a:endParaRPr lang="en-US" sz="1400" dirty="0"/>
           </a:p>
@@ -14198,8 +14191,8 @@
         </p:nvSpPr>
         <p:spPr>
           <a:xfrm>
-            <a:off x="566928" y="1737360"/>
-            <a:ext cx="3429000" cy="3566160"/>
+            <a:off x="566928" y="1664208"/>
+            <a:ext cx="3429000" cy="3703320"/>
           </a:xfrm>
           <a:prstGeom prst="roundRect">
             <a:avLst>
@@ -14225,7 +14218,7 @@
         </p:nvSpPr>
         <p:spPr>
           <a:xfrm>
-            <a:off x="768096" y="1874520"/>
+            <a:off x="768096" y="1801368"/>
             <a:ext cx="3026664" cy="256032"/>
           </a:xfrm>
           <a:prstGeom prst="rect">
@@ -14250,7 +14243,7 @@
                 <a:ea typeface="Amazon Ember Display" pitchFamily="34" charset="-122"/>
                 <a:cs typeface="Amazon Ember Display" pitchFamily="34" charset="-120"/>
               </a:rPr>
-              <a:t>实验一 · 学习信号</a:t>
+              <a:t>实验一 · APPLICATION 自管规则</a:t>
             </a:r>
             <a:endParaRPr lang="en-US" sz="1150" dirty="0"/>
           </a:p>
@@ -14264,7 +14257,7 @@
         </p:nvSpPr>
         <p:spPr>
           <a:xfrm>
-            <a:off x="768096" y="2221992"/>
+            <a:off x="768096" y="2148840"/>
             <a:ext cx="3026664" cy="384048"/>
           </a:xfrm>
           <a:prstGeom prst="rect">
@@ -14281,7 +14274,7 @@
               <a:buNone/>
             </a:pPr>
             <a:r>
-              <a:rPr lang="en-US" sz="1700" b="1" dirty="0">
+              <a:rPr lang="en-US" sz="1550" b="1" dirty="0">
                 <a:solidFill>
                   <a:srgbClr val="FFFFFF"/>
                 </a:solidFill>
@@ -14289,9 +14282,9 @@
                 <a:ea typeface="Microsoft YaHei" pitchFamily="34" charset="-122"/>
                 <a:cs typeface="Microsoft YaHei" pitchFamily="34" charset="-120"/>
               </a:rPr>
-              <a:t>只看输出的抽象自省</a:t>
-            </a:r>
-            <a:endParaRPr lang="en-US" sz="1700" dirty="0"/>
+              <a:t>Reflection LLM 只看 Harness Agent 输出</a:t>
+            </a:r>
+            <a:endParaRPr lang="en-US" sz="1550" dirty="0"/>
           </a:p>
         </p:txBody>
       </p:sp>
@@ -14303,8 +14296,8 @@
         </p:nvSpPr>
         <p:spPr>
           <a:xfrm>
-            <a:off x="768096" y="2679192"/>
-            <a:ext cx="3026664" cy="2496312"/>
+            <a:off x="768096" y="2606040"/>
+            <a:ext cx="3026664" cy="2633472"/>
           </a:xfrm>
           <a:prstGeom prst="rect">
             <a:avLst/>
@@ -14320,7 +14313,7 @@
               <a:buNone/>
             </a:pPr>
             <a:r>
-              <a:rPr lang="en-US" sz="1320" dirty="0">
+              <a:rPr lang="en-US" sz="1140" dirty="0">
                 <a:solidFill>
                   <a:srgbClr val="CFD9E4"/>
                 </a:solidFill>
@@ -14328,22 +14321,16 @@
                 <a:ea typeface="Microsoft YaHei" pitchFamily="34" charset="-122"/>
                 <a:cs typeface="Microsoft YaHei" pitchFamily="34" charset="-120"/>
               </a:rPr>
-              <a:t>问题：Agent 能否仅从自己的结果中发现真正遗漏？</a:t>
-            </a:r>
-            <a:endParaRPr lang="en-US" sz="1320" dirty="0"/>
-          </a:p>
-          <a:p>
-            <a:pPr indent="0" marL="0">
-              <a:buNone/>
-            </a:pPr>
-            <a:endParaRPr lang="en-US" sz="1320" dirty="0"/>
-          </a:p>
-          <a:p>
-            <a:pPr indent="0" marL="0">
-              <a:buNone/>
-            </a:pPr>
-            <a:r>
-              <a:rPr lang="en-US" sz="1320" dirty="0">
+              <a:t>Application → Harness Agent：生成抽取 JSON</a:t>
+            </a:r>
+            <a:endParaRPr lang="en-US" sz="1140" dirty="0"/>
+          </a:p>
+          <a:p>
+            <a:pPr indent="0" marL="0">
+              <a:buNone/>
+            </a:pPr>
+            <a:r>
+              <a:rPr lang="en-US" sz="1140" dirty="0">
                 <a:solidFill>
                   <a:srgbClr val="CFD9E4"/>
                 </a:solidFill>
@@ -14351,16 +14338,16 @@
                 <a:ea typeface="Microsoft YaHei" pitchFamily="34" charset="-122"/>
                 <a:cs typeface="Microsoft YaHei" pitchFamily="34" charset="-120"/>
               </a:rPr>
-              <a:t>输入：已抽取结果</a:t>
-            </a:r>
-            <a:endParaRPr lang="en-US" sz="1320" dirty="0"/>
-          </a:p>
-          <a:p>
-            <a:pPr indent="0" marL="0">
-              <a:buNone/>
-            </a:pPr>
-            <a:r>
-              <a:rPr lang="en-US" sz="1320" dirty="0">
+              <a:t>Application → Reflection LLM：生成本轮规则</a:t>
+            </a:r>
+            <a:endParaRPr lang="en-US" sz="1140" dirty="0"/>
+          </a:p>
+          <a:p>
+            <a:pPr indent="0" marL="0">
+              <a:buNone/>
+            </a:pPr>
+            <a:r>
+              <a:rPr lang="en-US" sz="1140" dirty="0">
                 <a:solidFill>
                   <a:srgbClr val="CFD9E4"/>
                 </a:solidFill>
@@ -14368,16 +14355,16 @@
                 <a:ea typeface="Microsoft YaHei" pitchFamily="34" charset="-122"/>
                 <a:cs typeface="Microsoft YaHei" pitchFamily="34" charset="-120"/>
               </a:rPr>
-              <a:t>产物：15 条 canonical rules</a:t>
-            </a:r>
-            <a:endParaRPr lang="en-US" sz="1320" dirty="0"/>
-          </a:p>
-          <a:p>
-            <a:pPr indent="0" marL="0">
-              <a:buNone/>
-            </a:pPr>
-            <a:r>
-              <a:rPr lang="en-US" sz="1320" dirty="0">
+              <a:t>Application → Consolidation LLM：合并 canonical rules</a:t>
+            </a:r>
+            <a:endParaRPr lang="en-US" sz="1140" dirty="0"/>
+          </a:p>
+          <a:p>
+            <a:pPr indent="0" marL="0">
+              <a:buNone/>
+            </a:pPr>
+            <a:r>
+              <a:rPr lang="en-US" sz="1140" dirty="0">
                 <a:solidFill>
                   <a:srgbClr val="CFD9E4"/>
                 </a:solidFill>
@@ -14385,9 +14372,32 @@
                 <a:ea typeface="Microsoft YaHei" pitchFamily="34" charset="-122"/>
                 <a:cs typeface="Microsoft YaHei" pitchFamily="34" charset="-120"/>
               </a:rPr>
-              <a:t>观察：90 → 102，主要是拆分变细</a:t>
-            </a:r>
-            <a:endParaRPr lang="en-US" sz="1320" dirty="0"/>
+              <a:t>Application → 下一轮 Harness Agent：注入规则</a:t>
+            </a:r>
+            <a:endParaRPr lang="en-US" sz="1140" dirty="0"/>
+          </a:p>
+          <a:p>
+            <a:pPr indent="0" marL="0">
+              <a:buNone/>
+            </a:pPr>
+            <a:endParaRPr lang="en-US" sz="1140" dirty="0"/>
+          </a:p>
+          <a:p>
+            <a:pPr indent="0" marL="0">
+              <a:buNone/>
+            </a:pPr>
+            <a:r>
+              <a:rPr lang="en-US" sz="1140" dirty="0">
+                <a:solidFill>
+                  <a:srgbClr val="CFD9E4"/>
+                </a:solidFill>
+                <a:latin typeface="Microsoft YaHei" pitchFamily="34" charset="0"/>
+                <a:ea typeface="Microsoft YaHei" pitchFamily="34" charset="-122"/>
+                <a:cs typeface="Microsoft YaHei" pitchFamily="34" charset="-120"/>
+              </a:rPr>
+              <a:t>观察：90 → 102，主要拆分变细</a:t>
+            </a:r>
+            <a:endParaRPr lang="en-US" sz="1140" dirty="0"/>
           </a:p>
         </p:txBody>
       </p:sp>
@@ -14399,8 +14409,8 @@
         </p:nvSpPr>
         <p:spPr>
           <a:xfrm>
-            <a:off x="4379976" y="1737360"/>
-            <a:ext cx="3429000" cy="3566160"/>
+            <a:off x="4379976" y="1664208"/>
+            <a:ext cx="3429000" cy="3703320"/>
           </a:xfrm>
           <a:prstGeom prst="roundRect">
             <a:avLst>
@@ -14426,7 +14436,7 @@
         </p:nvSpPr>
         <p:spPr>
           <a:xfrm>
-            <a:off x="4581144" y="1874520"/>
+            <a:off x="4581144" y="1801368"/>
             <a:ext cx="3026664" cy="256032"/>
           </a:xfrm>
           <a:prstGeom prst="rect">
@@ -14451,7 +14461,7 @@
                 <a:ea typeface="Amazon Ember Display" pitchFamily="34" charset="-122"/>
                 <a:cs typeface="Amazon Ember Display" pitchFamily="34" charset="-120"/>
               </a:rPr>
-              <a:t>实验二 · Memory 生成</a:t>
+              <a:t>实验二 · AGENTCORE EPISODIC</a:t>
             </a:r>
             <a:endParaRPr lang="en-US" sz="1150" dirty="0"/>
           </a:p>
@@ -14465,7 +14475,7 @@
         </p:nvSpPr>
         <p:spPr>
           <a:xfrm>
-            <a:off x="4581144" y="2221992"/>
+            <a:off x="4581144" y="2148840"/>
             <a:ext cx="3026664" cy="384048"/>
           </a:xfrm>
           <a:prstGeom prst="rect">
@@ -14482,7 +14492,7 @@
               <a:buNone/>
             </a:pPr>
             <a:r>
-              <a:rPr lang="en-US" sz="1700" b="1" dirty="0">
+              <a:rPr lang="en-US" sz="1550" b="1" dirty="0">
                 <a:solidFill>
                   <a:srgbClr val="FFFFFF"/>
                 </a:solidFill>
@@ -14490,9 +14500,9 @@
                 <a:ea typeface="Microsoft YaHei" pitchFamily="34" charset="-122"/>
                 <a:cs typeface="Microsoft YaHei" pitchFamily="34" charset="-120"/>
               </a:rPr>
-              <a:t>结构化 Self-review</a:t>
-            </a:r>
-            <a:endParaRPr lang="en-US" sz="1700" dirty="0"/>
+              <a:t>Harness Agent 产轨迹；Memory System 提炼</a:t>
+            </a:r>
+            <a:endParaRPr lang="en-US" sz="1550" dirty="0"/>
           </a:p>
         </p:txBody>
       </p:sp>
@@ -14504,8 +14514,8 @@
         </p:nvSpPr>
         <p:spPr>
           <a:xfrm>
-            <a:off x="4581144" y="2679192"/>
-            <a:ext cx="3026664" cy="2496312"/>
+            <a:off x="4581144" y="2606040"/>
+            <a:ext cx="3026664" cy="2633472"/>
           </a:xfrm>
           <a:prstGeom prst="rect">
             <a:avLst/>
@@ -14521,7 +14531,7 @@
               <a:buNone/>
             </a:pPr>
             <a:r>
-              <a:rPr lang="en-US" sz="1320" dirty="0">
+              <a:rPr lang="en-US" sz="1140" dirty="0">
                 <a:solidFill>
                   <a:srgbClr val="CFD9E4"/>
                 </a:solidFill>
@@ -14529,22 +14539,16 @@
                 <a:ea typeface="Microsoft YaHei" pitchFamily="34" charset="-122"/>
                 <a:cs typeface="Microsoft YaHei" pitchFamily="34" charset="-120"/>
               </a:rPr>
-              <a:t>问题：怎样产生可被 Memory System 提炼的高质量轨迹？</a:t>
-            </a:r>
-            <a:endParaRPr lang="en-US" sz="1320" dirty="0"/>
-          </a:p>
-          <a:p>
-            <a:pPr indent="0" marL="0">
-              <a:buNone/>
-            </a:pPr>
-            <a:endParaRPr lang="en-US" sz="1320" dirty="0"/>
-          </a:p>
-          <a:p>
-            <a:pPr indent="0" marL="0">
-              <a:buNone/>
-            </a:pPr>
-            <a:r>
-              <a:rPr lang="en-US" sz="1320" dirty="0">
+              <a:t>Application：顺序调用两个阶段</a:t>
+            </a:r>
+            <a:endParaRPr lang="en-US" sz="1140" dirty="0"/>
+          </a:p>
+          <a:p>
+            <a:pPr indent="0" marL="0">
+              <a:buNone/>
+            </a:pPr>
+            <a:r>
+              <a:rPr lang="en-US" sz="1140" dirty="0">
                 <a:solidFill>
                   <a:srgbClr val="CFD9E4"/>
                 </a:solidFill>
@@ -14552,16 +14556,16 @@
                 <a:ea typeface="Microsoft YaHei" pitchFamily="34" charset="-122"/>
                 <a:cs typeface="Microsoft YaHei" pitchFamily="34" charset="-120"/>
               </a:rPr>
-              <a:t>Harness Agent：原文 + 草稿自审</a:t>
-            </a:r>
-            <a:endParaRPr lang="en-US" sz="1320" dirty="0"/>
-          </a:p>
-          <a:p>
-            <a:pPr indent="0" marL="0">
-              <a:buNone/>
-            </a:pPr>
-            <a:r>
-              <a:rPr lang="en-US" sz="1320" dirty="0">
+              <a:t>Harness Agent：原文 → self_review → 最终 JSON</a:t>
+            </a:r>
+            <a:endParaRPr lang="en-US" sz="1140" dirty="0"/>
+          </a:p>
+          <a:p>
+            <a:pPr indent="0" marL="0">
+              <a:buNone/>
+            </a:pPr>
+            <a:r>
+              <a:rPr lang="en-US" sz="1140" dirty="0">
                 <a:solidFill>
                   <a:srgbClr val="CFD9E4"/>
                 </a:solidFill>
@@ -14569,16 +14573,22 @@
                 <a:ea typeface="Microsoft YaHei" pitchFamily="34" charset="-122"/>
                 <a:cs typeface="Microsoft YaHei" pitchFamily="34" charset="-120"/>
               </a:rPr>
-              <a:t>Memory System：EPISODIC</a:t>
-            </a:r>
-            <a:endParaRPr lang="en-US" sz="1320" dirty="0"/>
-          </a:p>
-          <a:p>
-            <a:pPr indent="0" marL="0">
-              <a:buNone/>
-            </a:pPr>
-            <a:r>
-              <a:rPr lang="en-US" sz="1320" dirty="0">
+              <a:t>Memory System · EPISODIC：Event Storage → Extraction → Consolidation → Reflection</a:t>
+            </a:r>
+            <a:endParaRPr lang="en-US" sz="1140" dirty="0"/>
+          </a:p>
+          <a:p>
+            <a:pPr indent="0" marL="0">
+              <a:buNone/>
+            </a:pPr>
+            <a:endParaRPr lang="en-US" sz="1140" dirty="0"/>
+          </a:p>
+          <a:p>
+            <a:pPr indent="0" marL="0">
+              <a:buNone/>
+            </a:pPr>
+            <a:r>
+              <a:rPr lang="en-US" sz="1140" dirty="0">
                 <a:solidFill>
                   <a:srgbClr val="CFD9E4"/>
                 </a:solidFill>
@@ -14586,9 +14596,9 @@
                 <a:ea typeface="Microsoft YaHei" pitchFamily="34" charset="-122"/>
                 <a:cs typeface="Microsoft YaHei" pitchFamily="34" charset="-120"/>
               </a:rPr>
-              <a:t>产物：1 episode + 2 reflections</a:t>
-            </a:r>
-            <a:endParaRPr lang="en-US" sz="1320" dirty="0"/>
+              <a:t>产物：1 episode + 2 actor reflections</a:t>
+            </a:r>
+            <a:endParaRPr lang="en-US" sz="1140" dirty="0"/>
           </a:p>
         </p:txBody>
       </p:sp>
@@ -14600,8 +14610,8 @@
         </p:nvSpPr>
         <p:spPr>
           <a:xfrm>
-            <a:off x="8193024" y="1737360"/>
-            <a:ext cx="3438144" cy="3566160"/>
+            <a:off x="8193024" y="1664208"/>
+            <a:ext cx="3438144" cy="3703320"/>
           </a:xfrm>
           <a:prstGeom prst="roundRect">
             <a:avLst>
@@ -14627,7 +14637,7 @@
         </p:nvSpPr>
         <p:spPr>
           <a:xfrm>
-            <a:off x="8394192" y="1874520"/>
+            <a:off x="8394192" y="1801368"/>
             <a:ext cx="3035808" cy="256032"/>
           </a:xfrm>
           <a:prstGeom prst="rect">
@@ -14652,7 +14662,7 @@
                 <a:ea typeface="Amazon Ember Display" pitchFamily="34" charset="-122"/>
                 <a:cs typeface="Amazon Ember Display" pitchFamily="34" charset="-120"/>
               </a:rPr>
-              <a:t>实验三 · 跨任务验证</a:t>
+              <a:t>实验三 · APPLICATION 控制对照</a:t>
             </a:r>
             <a:endParaRPr lang="en-US" sz="1150" dirty="0"/>
           </a:p>
@@ -14666,7 +14676,7 @@
         </p:nvSpPr>
         <p:spPr>
           <a:xfrm>
-            <a:off x="8394192" y="2221992"/>
+            <a:off x="8394192" y="2148840"/>
             <a:ext cx="3035808" cy="384048"/>
           </a:xfrm>
           <a:prstGeom prst="rect">
@@ -14683,7 +14693,7 @@
               <a:buNone/>
             </a:pPr>
             <a:r>
-              <a:rPr lang="en-US" sz="1700" b="1" dirty="0">
+              <a:rPr lang="en-US" sz="1550" b="1" dirty="0">
                 <a:solidFill>
                   <a:srgbClr val="FFFFFF"/>
                 </a:solidFill>
@@ -14691,9 +14701,9 @@
                 <a:ea typeface="Microsoft YaHei" pitchFamily="34" charset="-122"/>
                 <a:cs typeface="Microsoft YaHei" pitchFamily="34" charset="-120"/>
               </a:rPr>
-              <a:t>留出文档开关对照</a:t>
-            </a:r>
-            <a:endParaRPr lang="en-US" sz="1700" dirty="0"/>
+              <a:t>Memory Retrieval 开关实验</a:t>
+            </a:r>
+            <a:endParaRPr lang="en-US" sz="1550" dirty="0"/>
           </a:p>
         </p:txBody>
       </p:sp>
@@ -14705,8 +14715,8 @@
         </p:nvSpPr>
         <p:spPr>
           <a:xfrm>
-            <a:off x="8394192" y="2679192"/>
-            <a:ext cx="3035808" cy="2496312"/>
+            <a:off x="8394192" y="2606040"/>
+            <a:ext cx="3035808" cy="2633472"/>
           </a:xfrm>
           <a:prstGeom prst="rect">
             <a:avLst/>
@@ -14722,7 +14732,7 @@
               <a:buNone/>
             </a:pPr>
             <a:r>
-              <a:rPr lang="en-US" sz="1320" dirty="0">
+              <a:rPr lang="en-US" sz="1110" dirty="0">
                 <a:solidFill>
                   <a:srgbClr val="CFD9E4"/>
                 </a:solidFill>
@@ -14730,22 +14740,16 @@
                 <a:ea typeface="Microsoft YaHei" pitchFamily="34" charset="-122"/>
                 <a:cs typeface="Microsoft YaHei" pitchFamily="34" charset="-120"/>
               </a:rPr>
-              <a:t>问题：托管 Memory 是否改变下一份文档的抽取关注点？</a:t>
-            </a:r>
-            <a:endParaRPr lang="en-US" sz="1320" dirty="0"/>
-          </a:p>
-          <a:p>
-            <a:pPr indent="0" marL="0">
-              <a:buNone/>
-            </a:pPr>
-            <a:endParaRPr lang="en-US" sz="1320" dirty="0"/>
-          </a:p>
-          <a:p>
-            <a:pPr indent="0" marL="0">
-              <a:buNone/>
-            </a:pPr>
-            <a:r>
-              <a:rPr lang="en-US" sz="1320" dirty="0">
+              <a:t>Application：创建两组 fresh sessions</a:t>
+            </a:r>
+            <a:endParaRPr lang="en-US" sz="1110" dirty="0"/>
+          </a:p>
+          <a:p>
+            <a:pPr indent="0" marL="0">
+              <a:buNone/>
+            </a:pPr>
+            <a:r>
+              <a:rPr lang="en-US" sz="1110" dirty="0">
                 <a:solidFill>
                   <a:srgbClr val="CFD9E4"/>
                 </a:solidFill>
@@ -14753,16 +14757,16 @@
                 <a:ea typeface="Microsoft YaHei" pitchFamily="34" charset="-122"/>
                 <a:cs typeface="Microsoft YaHei" pitchFamily="34" charset="-120"/>
               </a:rPr>
-              <a:t>唯一变量：Memory 开关</a:t>
-            </a:r>
-            <a:endParaRPr lang="en-US" sz="1320" dirty="0"/>
-          </a:p>
-          <a:p>
-            <a:pPr indent="0" marL="0">
-              <a:buNone/>
-            </a:pPr>
-            <a:r>
-              <a:rPr lang="en-US" sz="1320" dirty="0">
+              <a:t>Memory System：仅 enabled 组 Retrieval</a:t>
+            </a:r>
+            <a:endParaRPr lang="en-US" sz="1110" dirty="0"/>
+          </a:p>
+          <a:p>
+            <a:pPr indent="0" marL="0">
+              <a:buNone/>
+            </a:pPr>
+            <a:r>
+              <a:rPr lang="en-US" sz="1110" dirty="0">
                 <a:solidFill>
                   <a:srgbClr val="CFD9E4"/>
                 </a:solidFill>
@@ -14770,16 +14774,16 @@
                 <a:ea typeface="Microsoft YaHei" pitchFamily="34" charset="-122"/>
                 <a:cs typeface="Microsoft YaHei" pitchFamily="34" charset="-120"/>
               </a:rPr>
-              <a:t>结果：31 vs 11</a:t>
-            </a:r>
-            <a:endParaRPr lang="en-US" sz="1320" dirty="0"/>
-          </a:p>
-          <a:p>
-            <a:pPr indent="0" marL="0">
-              <a:buNone/>
-            </a:pPr>
-            <a:r>
-              <a:rPr lang="en-US" sz="1320" dirty="0">
+              <a:t>AgentCore Harness：仅 enabled 组注入 Records</a:t>
+            </a:r>
+            <a:endParaRPr lang="en-US" sz="1110" dirty="0"/>
+          </a:p>
+          <a:p>
+            <a:pPr indent="0" marL="0">
+              <a:buNone/>
+            </a:pPr>
+            <a:r>
+              <a:rPr lang="en-US" sz="1110" dirty="0">
                 <a:solidFill>
                   <a:srgbClr val="CFD9E4"/>
                 </a:solidFill>
@@ -14787,9 +14791,49 @@
                 <a:ea typeface="Microsoft YaHei" pitchFamily="34" charset="-122"/>
                 <a:cs typeface="Microsoft YaHei" pitchFamily="34" charset="-120"/>
               </a:rPr>
-              <a:t>主要差异：两张 BOM 的系统展开</a:t>
-            </a:r>
-            <a:endParaRPr lang="en-US" sz="1320" dirty="0"/>
+              <a:t>Harness Agent：两组使用相同 Prompt 抽取</a:t>
+            </a:r>
+            <a:endParaRPr lang="en-US" sz="1110" dirty="0"/>
+          </a:p>
+          <a:p>
+            <a:pPr indent="0" marL="0">
+              <a:buNone/>
+            </a:pPr>
+            <a:r>
+              <a:rPr lang="en-US" sz="1110" dirty="0">
+                <a:solidFill>
+                  <a:srgbClr val="CFD9E4"/>
+                </a:solidFill>
+                <a:latin typeface="Microsoft YaHei" pitchFamily="34" charset="0"/>
+                <a:ea typeface="Microsoft YaHei" pitchFamily="34" charset="-122"/>
+                <a:cs typeface="Microsoft YaHei" pitchFamily="34" charset="-120"/>
+              </a:rPr>
+              <a:t>Reviewer：人工核对</a:t>
+            </a:r>
+            <a:endParaRPr lang="en-US" sz="1110" dirty="0"/>
+          </a:p>
+          <a:p>
+            <a:pPr indent="0" marL="0">
+              <a:buNone/>
+            </a:pPr>
+            <a:endParaRPr lang="en-US" sz="1110" dirty="0"/>
+          </a:p>
+          <a:p>
+            <a:pPr indent="0" marL="0">
+              <a:buNone/>
+            </a:pPr>
+            <a:r>
+              <a:rPr lang="en-US" sz="1110" dirty="0">
+                <a:solidFill>
+                  <a:srgbClr val="CFD9E4"/>
+                </a:solidFill>
+                <a:latin typeface="Microsoft YaHei" pitchFamily="34" charset="0"/>
+                <a:ea typeface="Microsoft YaHei" pitchFamily="34" charset="-122"/>
+                <a:cs typeface="Microsoft YaHei" pitchFamily="34" charset="-120"/>
+              </a:rPr>
+              <a:t>结果：31 vs 11；差异主要来自两张 BOM</a:t>
+            </a:r>
+            <a:endParaRPr lang="en-US" sz="1110" dirty="0"/>
           </a:p>
         </p:txBody>
       </p:sp>
@@ -14801,7 +14845,7 @@
         </p:nvSpPr>
         <p:spPr>
           <a:xfrm>
-            <a:off x="566928" y="5504688"/>
+            <a:off x="566928" y="5532120"/>
             <a:ext cx="11064240" cy="777240"/>
           </a:xfrm>
           <a:prstGeom prst="roundRect">
@@ -14828,7 +14872,7 @@
         </p:nvSpPr>
         <p:spPr>
           <a:xfrm>
-            <a:off x="822960" y="5504688"/>
+            <a:off x="822960" y="5532120"/>
             <a:ext cx="10552176" cy="777240"/>
           </a:xfrm>
           <a:prstGeom prst="rect">
@@ -14853,7 +14897,7 @@
                 <a:ea typeface="Amazon Ember Display" pitchFamily="34" charset="-122"/>
                 <a:cs typeface="Amazon Ember Display" pitchFamily="34" charset="-120"/>
               </a:rPr>
-              <a:t>主线：学习信号 → Memory 生成 → 留出文档验证</a:t>
+              <a:t>实验主线：应用侧规则学习 → 托管 EPISODIC 记录生成 → 托管 Records 跨 session 验证</a:t>
             </a:r>
             <a:endParaRPr lang="en-US" sz="1650" dirty="0"/>
           </a:p>
@@ -15096,7 +15140,7 @@
               <a:buNone/>
             </a:pPr>
             <a:r>
-              <a:rPr lang="en-US" sz="3400" b="1" dirty="0">
+              <a:rPr lang="en-US" sz="2700" b="1" dirty="0">
                 <a:solidFill>
                   <a:srgbClr val="FFFFFF"/>
                 </a:solidFill>
@@ -15104,9 +15148,9 @@
                 <a:ea typeface="Amazon Ember Display" pitchFamily="34" charset="-122"/>
                 <a:cs typeface="Amazon Ember Display" pitchFamily="34" charset="-120"/>
               </a:rPr>
-              <a:t>抽象自省：只看输出能学到什么？</a:t>
-            </a:r>
-            <a:endParaRPr lang="en-US" sz="3400" dirty="0"/>
+              <a:t>应用侧 Reflection LLM：只看 Harness Agent 输出能学到什么？</a:t>
+            </a:r>
+            <a:endParaRPr lang="en-US" sz="2700" dirty="0"/>
           </a:p>
         </p:txBody>
       </p:sp>
@@ -15143,7 +15187,7 @@
                 <a:ea typeface="Microsoft YaHei" pitchFamily="34" charset="-122"/>
                 <a:cs typeface="Microsoft YaHei" pitchFamily="34" charset="-120"/>
               </a:rPr>
-              <a:t>先验证没有原文对照时，Agent 自己总结出的规则是否能稳定提升完整性。</a:t>
+              <a:t>Application 只向 Reflection LLM 提供 Harness Agent 已抽取的 JSON，不提供源文档。</a:t>
             </a:r>
             <a:endParaRPr lang="en-US" sz="1800" dirty="0"/>
           </a:p>
@@ -15209,7 +15253,7 @@
                 <a:ea typeface="Microsoft YaHei" pitchFamily="34" charset="-122"/>
                 <a:cs typeface="Microsoft YaHei" pitchFamily="34" charset="-120"/>
               </a:rPr>
-              <a:t>实验边界：这一段使用应用侧反思与规则合并，不是 AgentCore 内置 EPISODIC strategy。</a:t>
+              <a:t>实验边界：Application 调用 Reflection LLM 生成规则，再调用 Consolidation LLM 合并；本段不使用 AgentCore EPISODIC。</a:t>
             </a:r>
             <a:endParaRPr lang="en-US" sz="2000" dirty="0"/>
           </a:p>
@@ -15421,7 +15465,7 @@
                 <a:ea typeface="Amazon Ember Display" pitchFamily="34" charset="-122"/>
                 <a:cs typeface="Amazon Ember Display" pitchFamily="34" charset="-120"/>
               </a:rPr>
-              <a:t>尝试一：只看输出的抽象自省</a:t>
+              <a:t>应用侧两个 LLM 调用的真实 Prompt</a:t>
             </a:r>
             <a:endParaRPr lang="en-US" sz="2700" dirty="0"/>
           </a:p>
@@ -15460,7 +15504,7 @@
                 <a:ea typeface="Microsoft YaHei" pitchFamily="34" charset="-122"/>
                 <a:cs typeface="Microsoft YaHei" pitchFamily="34" charset="-120"/>
               </a:rPr>
-              <a:t>最初的做法，是让模型从已经生成的抽取结果中总结通用规则。</a:t>
+              <a:t>Application 先把 Harness Agent 输出发送给 Reflection LLM，再把新规则与旧规则发送给 Consolidation LLM。</a:t>
             </a:r>
             <a:endParaRPr lang="en-US" sz="1400" dirty="0"/>
           </a:p>
@@ -15526,7 +15570,7 @@
                 <a:ea typeface="Amazon Ember Display" pitchFamily="34" charset="-122"/>
                 <a:cs typeface="Amazon Ember Display" pitchFamily="34" charset="-120"/>
               </a:rPr>
-              <a:t>真实反思 Prompt</a:t>
+              <a:t>APPLICATION → REFLECTION LLM</a:t>
             </a:r>
             <a:endParaRPr lang="en-US" sz="1150" dirty="0"/>
           </a:p>
@@ -15749,7 +15793,7 @@
                 <a:ea typeface="Amazon Ember Display" pitchFamily="34" charset="-122"/>
                 <a:cs typeface="Amazon Ember Display" pitchFamily="34" charset="-120"/>
               </a:rPr>
-              <a:t>真实 Consolidation Prompt</a:t>
+              <a:t>APPLICATION → CONSOLIDATION LLM</a:t>
             </a:r>
             <a:endParaRPr lang="en-US" sz="1150" dirty="0"/>
           </a:p>
@@ -15972,7 +16016,7 @@
                 <a:ea typeface="Amazon Ember Display" pitchFamily="34" charset="-122"/>
                 <a:cs typeface="Amazon Ember Display" pitchFamily="34" charset="-120"/>
               </a:rPr>
-              <a:t>问题埋在输入里：模型只能总结“已经抽出来的内容”。</a:t>
+              <a:t>输入盲区：Reflection LLM 只看到 Harness Agent 输出，因此无法观察被整块漏掉的原文区域。</a:t>
             </a:r>
             <a:endParaRPr lang="en-US" sz="1650" dirty="0"/>
           </a:p>
@@ -16184,7 +16228,7 @@
                 <a:ea typeface="Amazon Ember Display" pitchFamily="34" charset="-122"/>
                 <a:cs typeface="Amazon Ember Display" pitchFamily="34" charset="-120"/>
               </a:rPr>
-              <a:t>抽象自省实际记住了什么</a:t>
+              <a:t>Consolidation LLM 最终合并出 15 条规则</a:t>
             </a:r>
             <a:endParaRPr lang="en-US" sz="2700" dirty="0"/>
           </a:p>
@@ -16223,7 +16267,7 @@
                 <a:ea typeface="Microsoft YaHei" pitchFamily="34" charset="-122"/>
                 <a:cs typeface="Microsoft YaHei" pitchFamily="34" charset="-120"/>
               </a:rPr>
-              <a:t>4 轮运行后，consolidation 形成一份包含 15 条规则的 canonical Memory。</a:t>
+              <a:t>Application 每轮把 canonical rules 注入下一次 Harness Agent 调用；4 轮后规则集收敛为 15 条。</a:t>
             </a:r>
             <a:endParaRPr lang="en-US" sz="1400" dirty="0"/>
           </a:p>
@@ -16880,7 +16924,7 @@
                 <a:ea typeface="Amazon Ember Display" pitchFamily="34" charset="-122"/>
                 <a:cs typeface="Amazon Ember Display" pitchFamily="34" charset="-120"/>
               </a:rPr>
-              <a:t>4 轮抽取：90 → 93 → 95 → 102 条　|　15 条规则　|　53 个唯一原文　|　1.92 条/原文</a:t>
+              <a:t>Harness Agent 4 轮输出：90 → 93 → 95 → 102 条　|　Consolidation LLM：15 条规则　|　53 个唯一原文</a:t>
             </a:r>
             <a:endParaRPr lang="en-US" sz="1550" dirty="0"/>
           </a:p>
@@ -17092,7 +17136,7 @@
                 <a:ea typeface="Amazon Ember Display" pitchFamily="34" charset="-122"/>
                 <a:cs typeface="Amazon Ember Display" pitchFamily="34" charset="-120"/>
               </a:rPr>
-              <a:t>实验一结论：只看输出，发现不了整块遗漏</a:t>
+              <a:t>实验一结论：Reflection LLM 看不到 Harness Agent 的整块遗漏</a:t>
             </a:r>
             <a:endParaRPr lang="en-US" sz="2700" dirty="0"/>
           </a:p>
@@ -17131,7 +17175,7 @@
                 <a:ea typeface="Microsoft YaHei" pitchFamily="34" charset="-122"/>
                 <a:cs typeface="Microsoft YaHei" pitchFamily="34" charset="-120"/>
               </a:rPr>
-              <a:t>规则数量和输出条数都增加了，但学习信号无法看见没有进入结果的章节或表格。</a:t>
+              <a:t>Application 没有把源文档提供给 Reflection LLM；规则和条数增加并不能证明 Harness Agent 覆盖了更多原文区域。</a:t>
             </a:r>
             <a:endParaRPr lang="en-US" sz="1400" dirty="0"/>
           </a:p>
@@ -17197,7 +17241,7 @@
                 <a:ea typeface="Amazon Ember Display" pitchFamily="34" charset="-122"/>
                 <a:cs typeface="Amazon Ember Display" pitchFamily="34" charset="-120"/>
               </a:rPr>
-              <a:t>类型 A</a:t>
+              <a:t>类型 A · HARNESS AGENT 可自审</a:t>
             </a:r>
             <a:endParaRPr lang="en-US" sz="1150" dirty="0"/>
           </a:p>
@@ -17267,7 +17311,7 @@
               <a:buNone/>
             </a:pPr>
             <a:r>
-              <a:rPr lang="en-US" sz="1400" dirty="0">
+              <a:rPr lang="en-US" sz="1350" dirty="0">
                 <a:solidFill>
                   <a:srgbClr val="CFD9E4"/>
                 </a:solidFill>
@@ -17275,22 +17319,22 @@
                 <a:ea typeface="Microsoft YaHei" pitchFamily="34" charset="-122"/>
                 <a:cs typeface="Microsoft YaHei" pitchFamily="34" charset="-120"/>
               </a:rPr>
-              <a:t>定义：原文中出现了 X，但输出中没有 X。</a:t>
-            </a:r>
-            <a:endParaRPr lang="en-US" sz="1400" dirty="0"/>
-          </a:p>
-          <a:p>
-            <a:pPr indent="0" marL="0">
-              <a:buNone/>
-            </a:pPr>
-            <a:endParaRPr lang="en-US" sz="1400" dirty="0"/>
-          </a:p>
-          <a:p>
-            <a:pPr indent="0" marL="0">
-              <a:buNone/>
-            </a:pPr>
-            <a:r>
-              <a:rPr lang="en-US" sz="1400" dirty="0">
+              <a:t>定义：原文中出现了 X，但 Harness Agent 输出中没有 X。</a:t>
+            </a:r>
+            <a:endParaRPr lang="en-US" sz="1350" dirty="0"/>
+          </a:p>
+          <a:p>
+            <a:pPr indent="0" marL="0">
+              <a:buNone/>
+            </a:pPr>
+            <a:endParaRPr lang="en-US" sz="1350" dirty="0"/>
+          </a:p>
+          <a:p>
+            <a:pPr indent="0" marL="0">
+              <a:buNone/>
+            </a:pPr>
+            <a:r>
+              <a:rPr lang="en-US" sz="1350" dirty="0">
                 <a:solidFill>
                   <a:srgbClr val="CFD9E4"/>
                 </a:solidFill>
@@ -17300,14 +17344,14 @@
               </a:rPr>
               <a:t>例子：</a:t>
             </a:r>
-            <a:endParaRPr lang="en-US" sz="1400" dirty="0"/>
-          </a:p>
-          <a:p>
-            <a:pPr indent="0" marL="0">
-              <a:buNone/>
-            </a:pPr>
-            <a:r>
-              <a:rPr lang="en-US" sz="1400" dirty="0">
+            <a:endParaRPr lang="en-US" sz="1350" dirty="0"/>
+          </a:p>
+          <a:p>
+            <a:pPr indent="0" marL="0">
+              <a:buNone/>
+            </a:pPr>
+            <a:r>
+              <a:rPr lang="en-US" sz="1350" dirty="0">
                 <a:solidFill>
                   <a:srgbClr val="CFD9E4"/>
                 </a:solidFill>
@@ -17317,14 +17361,14 @@
               </a:rPr>
               <a:t>· 整张 BOM 没抽</a:t>
             </a:r>
-            <a:endParaRPr lang="en-US" sz="1400" dirty="0"/>
-          </a:p>
-          <a:p>
-            <a:pPr indent="0" marL="0">
-              <a:buNone/>
-            </a:pPr>
-            <a:r>
-              <a:rPr lang="en-US" sz="1400" dirty="0">
+            <a:endParaRPr lang="en-US" sz="1350" dirty="0"/>
+          </a:p>
+          <a:p>
+            <a:pPr indent="0" marL="0">
+              <a:buNone/>
+            </a:pPr>
+            <a:r>
+              <a:rPr lang="en-US" sz="1350" dirty="0">
                 <a:solidFill>
                   <a:srgbClr val="CFD9E4"/>
                 </a:solidFill>
@@ -17332,16 +17376,16 @@
                 <a:ea typeface="Microsoft YaHei" pitchFamily="34" charset="-122"/>
                 <a:cs typeface="Microsoft YaHei" pitchFamily="34" charset="-120"/>
               </a:rPr>
-              <a:t>· 漏掉某个章节或附注</a:t>
-            </a:r>
-            <a:endParaRPr lang="en-US" sz="1400" dirty="0"/>
-          </a:p>
-          <a:p>
-            <a:pPr indent="0" marL="0">
-              <a:buNone/>
-            </a:pPr>
-            <a:r>
-              <a:rPr lang="en-US" sz="1400" dirty="0">
+              <a:t>· 漏掉章节或附注</a:t>
+            </a:r>
+            <a:endParaRPr lang="en-US" sz="1350" dirty="0"/>
+          </a:p>
+          <a:p>
+            <a:pPr indent="0" marL="0">
+              <a:buNone/>
+            </a:pPr>
+            <a:r>
+              <a:rPr lang="en-US" sz="1350" dirty="0">
                 <a:solidFill>
                   <a:srgbClr val="CFD9E4"/>
                 </a:solidFill>
@@ -17351,14 +17395,14 @@
               </a:rPr>
               <a:t>· 重复记录</a:t>
             </a:r>
-            <a:endParaRPr lang="en-US" sz="1400" dirty="0"/>
-          </a:p>
-          <a:p>
-            <a:pPr indent="0" marL="0">
-              <a:buNone/>
-            </a:pPr>
-            <a:r>
-              <a:rPr lang="en-US" sz="1400" dirty="0">
+            <a:endParaRPr lang="en-US" sz="1350" dirty="0"/>
+          </a:p>
+          <a:p>
+            <a:pPr indent="0" marL="0">
+              <a:buNone/>
+            </a:pPr>
+            <a:r>
+              <a:rPr lang="en-US" sz="1350" dirty="0">
                 <a:solidFill>
                   <a:srgbClr val="CFD9E4"/>
                 </a:solidFill>
@@ -17368,20 +17412,20 @@
               </a:rPr>
               <a:t>· 字段为空或格式错误</a:t>
             </a:r>
-            <a:endParaRPr lang="en-US" sz="1400" dirty="0"/>
-          </a:p>
-          <a:p>
-            <a:pPr indent="0" marL="0">
-              <a:buNone/>
-            </a:pPr>
-            <a:endParaRPr lang="en-US" sz="1400" dirty="0"/>
-          </a:p>
-          <a:p>
-            <a:pPr indent="0" marL="0">
-              <a:buNone/>
-            </a:pPr>
-            <a:r>
-              <a:rPr lang="en-US" sz="1400" dirty="0">
+            <a:endParaRPr lang="en-US" sz="1350" dirty="0"/>
+          </a:p>
+          <a:p>
+            <a:pPr indent="0" marL="0">
+              <a:buNone/>
+            </a:pPr>
+            <a:endParaRPr lang="en-US" sz="1350" dirty="0"/>
+          </a:p>
+          <a:p>
+            <a:pPr indent="0" marL="0">
+              <a:buNone/>
+            </a:pPr>
+            <a:r>
+              <a:rPr lang="en-US" sz="1350" dirty="0">
                 <a:solidFill>
                   <a:srgbClr val="CFD9E4"/>
                 </a:solidFill>
@@ -17389,9 +17433,9 @@
                 <a:ea typeface="Microsoft YaHei" pitchFamily="34" charset="-122"/>
                 <a:cs typeface="Microsoft YaHei" pitchFamily="34" charset="-120"/>
               </a:rPr>
-              <a:t>可通过：原文 + 草稿的结构化自审发现</a:t>
-            </a:r>
-            <a:endParaRPr lang="en-US" sz="1400" dirty="0"/>
+              <a:t>发现主体：Harness Agent 同时读取原文 + 草稿</a:t>
+            </a:r>
+            <a:endParaRPr lang="en-US" sz="1350" dirty="0"/>
           </a:p>
         </p:txBody>
       </p:sp>
@@ -17455,7 +17499,7 @@
                 <a:ea typeface="Amazon Ember Display" pitchFamily="34" charset="-122"/>
                 <a:cs typeface="Amazon Ember Display" pitchFamily="34" charset="-120"/>
               </a:rPr>
-              <a:t>类型 B</a:t>
+              <a:t>类型 B · REVIEWER 决定</a:t>
             </a:r>
             <a:endParaRPr lang="en-US" sz="1150" dirty="0"/>
           </a:p>
@@ -17525,7 +17569,7 @@
               <a:buNone/>
             </a:pPr>
             <a:r>
-              <a:rPr lang="en-US" sz="1400" dirty="0">
+              <a:rPr lang="en-US" sz="1350" dirty="0">
                 <a:solidFill>
                   <a:srgbClr val="CFD9E4"/>
                 </a:solidFill>
@@ -17533,22 +17577,22 @@
                 <a:ea typeface="Microsoft YaHei" pitchFamily="34" charset="-122"/>
                 <a:cs typeface="Microsoft YaHei" pitchFamily="34" charset="-120"/>
               </a:rPr>
-              <a:t>定义：模型不知道 X 也属于抽取目标。</a:t>
-            </a:r>
-            <a:endParaRPr lang="en-US" sz="1400" dirty="0"/>
-          </a:p>
-          <a:p>
-            <a:pPr indent="0" marL="0">
-              <a:buNone/>
-            </a:pPr>
-            <a:endParaRPr lang="en-US" sz="1400" dirty="0"/>
-          </a:p>
-          <a:p>
-            <a:pPr indent="0" marL="0">
-              <a:buNone/>
-            </a:pPr>
-            <a:r>
-              <a:rPr lang="en-US" sz="1400" dirty="0">
+              <a:t>定义：Harness Agent 不知道 X 是否属于抽取目标。</a:t>
+            </a:r>
+            <a:endParaRPr lang="en-US" sz="1350" dirty="0"/>
+          </a:p>
+          <a:p>
+            <a:pPr indent="0" marL="0">
+              <a:buNone/>
+            </a:pPr>
+            <a:endParaRPr lang="en-US" sz="1350" dirty="0"/>
+          </a:p>
+          <a:p>
+            <a:pPr indent="0" marL="0">
+              <a:buNone/>
+            </a:pPr>
+            <a:r>
+              <a:rPr lang="en-US" sz="1350" dirty="0">
                 <a:solidFill>
                   <a:srgbClr val="CFD9E4"/>
                 </a:solidFill>
@@ -17558,14 +17602,14 @@
               </a:rPr>
               <a:t>例子：</a:t>
             </a:r>
-            <a:endParaRPr lang="en-US" sz="1400" dirty="0"/>
-          </a:p>
-          <a:p>
-            <a:pPr indent="0" marL="0">
-              <a:buNone/>
-            </a:pPr>
-            <a:r>
-              <a:rPr lang="en-US" sz="1400" dirty="0">
+            <a:endParaRPr lang="en-US" sz="1350" dirty="0"/>
+          </a:p>
+          <a:p>
+            <a:pPr indent="0" marL="0">
+              <a:buNone/>
+            </a:pPr>
+            <a:r>
+              <a:rPr lang="en-US" sz="1350" dirty="0">
                 <a:solidFill>
                   <a:srgbClr val="CFD9E4"/>
                 </a:solidFill>
@@ -17575,14 +17619,14 @@
               </a:rPr>
               <a:t>· 流程与见证要求</a:t>
             </a:r>
-            <a:endParaRPr lang="en-US" sz="1400" dirty="0"/>
-          </a:p>
-          <a:p>
-            <a:pPr indent="0" marL="0">
-              <a:buNone/>
-            </a:pPr>
-            <a:r>
-              <a:rPr lang="en-US" sz="1400" dirty="0">
+            <a:endParaRPr lang="en-US" sz="1350" dirty="0"/>
+          </a:p>
+          <a:p>
+            <a:pPr indent="0" marL="0">
+              <a:buNone/>
+            </a:pPr>
+            <a:r>
+              <a:rPr lang="en-US" sz="1350" dirty="0">
                 <a:solidFill>
                   <a:srgbClr val="CFD9E4"/>
                 </a:solidFill>
@@ -17592,14 +17636,14 @@
               </a:rPr>
               <a:t>· 报告与交付文件</a:t>
             </a:r>
-            <a:endParaRPr lang="en-US" sz="1400" dirty="0"/>
-          </a:p>
-          <a:p>
-            <a:pPr indent="0" marL="0">
-              <a:buNone/>
-            </a:pPr>
-            <a:r>
-              <a:rPr lang="en-US" sz="1400" dirty="0">
+            <a:endParaRPr lang="en-US" sz="1350" dirty="0"/>
+          </a:p>
+          <a:p>
+            <a:pPr indent="0" marL="0">
+              <a:buNone/>
+            </a:pPr>
+            <a:r>
+              <a:rPr lang="en-US" sz="1350" dirty="0">
                 <a:solidFill>
                   <a:srgbClr val="CFD9E4"/>
                 </a:solidFill>
@@ -17609,14 +17653,14 @@
               </a:rPr>
               <a:t>· 待确认事项</a:t>
             </a:r>
-            <a:endParaRPr lang="en-US" sz="1400" dirty="0"/>
-          </a:p>
-          <a:p>
-            <a:pPr indent="0" marL="0">
-              <a:buNone/>
-            </a:pPr>
-            <a:r>
-              <a:rPr lang="en-US" sz="1400" dirty="0">
+            <a:endParaRPr lang="en-US" sz="1350" dirty="0"/>
+          </a:p>
+          <a:p>
+            <a:pPr indent="0" marL="0">
+              <a:buNone/>
+            </a:pPr>
+            <a:r>
+              <a:rPr lang="en-US" sz="1350" dirty="0">
                 <a:solidFill>
                   <a:srgbClr val="CFD9E4"/>
                 </a:solidFill>
@@ -17626,20 +17670,20 @@
               </a:rPr>
               <a:t>· 什么粒度算一条</a:t>
             </a:r>
-            <a:endParaRPr lang="en-US" sz="1400" dirty="0"/>
-          </a:p>
-          <a:p>
-            <a:pPr indent="0" marL="0">
-              <a:buNone/>
-            </a:pPr>
-            <a:endParaRPr lang="en-US" sz="1400" dirty="0"/>
-          </a:p>
-          <a:p>
-            <a:pPr indent="0" marL="0">
-              <a:buNone/>
-            </a:pPr>
-            <a:r>
-              <a:rPr lang="en-US" sz="1400" dirty="0">
+            <a:endParaRPr lang="en-US" sz="1350" dirty="0"/>
+          </a:p>
+          <a:p>
+            <a:pPr indent="0" marL="0">
+              <a:buNone/>
+            </a:pPr>
+            <a:endParaRPr lang="en-US" sz="1350" dirty="0"/>
+          </a:p>
+          <a:p>
+            <a:pPr indent="0" marL="0">
+              <a:buNone/>
+            </a:pPr>
+            <a:r>
+              <a:rPr lang="en-US" sz="1350" dirty="0">
                 <a:solidFill>
                   <a:srgbClr val="CFD9E4"/>
                 </a:solidFill>
@@ -17647,9 +17691,9 @@
                 <a:ea typeface="Microsoft YaHei" pitchFamily="34" charset="-122"/>
                 <a:cs typeface="Microsoft YaHei" pitchFamily="34" charset="-120"/>
               </a:rPr>
-              <a:t>需要：任务规范、Reviewer 或人工反馈</a:t>
-            </a:r>
-            <a:endParaRPr lang="en-US" sz="1400" dirty="0"/>
+              <a:t>判断主体：任务规范制定者 / Reviewer / Human</a:t>
+            </a:r>
+            <a:endParaRPr lang="en-US" sz="1350" dirty="0"/>
           </a:p>
         </p:txBody>
       </p:sp>
@@ -17713,7 +17757,7 @@
                 <a:ea typeface="Amazon Ember Display" pitchFamily="34" charset="-122"/>
                 <a:cs typeface="Amazon Ember Display" pitchFamily="34" charset="-120"/>
               </a:rPr>
-              <a:t>Self-review 能发现“漏了什么”；规范/Reviewer 决定“什么应该抽”。</a:t>
+              <a:t>Harness Agent 可用原文自审源覆盖；Reviewer / Human 负责定义任务边界。</a:t>
             </a:r>
             <a:endParaRPr lang="en-US" sz="1650" dirty="0"/>
           </a:p>
@@ -17956,7 +18000,7 @@
               <a:buNone/>
             </a:pPr>
             <a:r>
-              <a:rPr lang="en-US" sz="3400" b="1" dirty="0">
+              <a:rPr lang="en-US" sz="2700" b="1" dirty="0">
                 <a:solidFill>
                   <a:srgbClr val="FFFFFF"/>
                 </a:solidFill>
@@ -17964,9 +18008,9 @@
                 <a:ea typeface="Amazon Ember Display" pitchFamily="34" charset="-122"/>
                 <a:cs typeface="Amazon Ember Display" pitchFamily="34" charset="-120"/>
               </a:rPr>
-              <a:t>生成托管 Memory：让 Review 对照原文</a:t>
-            </a:r>
-            <a:endParaRPr lang="en-US" sz="3400" dirty="0"/>
+              <a:t>Harness Agent 产出轨迹；Memory System 生成 Records</a:t>
+            </a:r>
+            <a:endParaRPr lang="en-US" sz="2700" dirty="0"/>
           </a:p>
         </p:txBody>
       </p:sp>
@@ -18003,7 +18047,7 @@
                 <a:ea typeface="Microsoft YaHei" pitchFamily="34" charset="-122"/>
                 <a:cs typeface="Microsoft YaHei" pitchFamily="34" charset="-120"/>
               </a:rPr>
-              <a:t>这一段只回答 Memory 如何生成：Harness Agent 产生结构化轨迹，Memory System 负责提炼。</a:t>
+              <a:t>Application 顺序调用 Harness Agent 两个阶段；Harness Agent 对照原文自审并修订。</a:t>
             </a:r>
             <a:endParaRPr lang="en-US" sz="1800" dirty="0"/>
           </a:p>
@@ -18069,7 +18113,7 @@
                 <a:ea typeface="Microsoft YaHei" pitchFamily="34" charset="-122"/>
                 <a:cs typeface="Microsoft YaHei" pitchFamily="34" charset="-120"/>
               </a:rPr>
-              <a:t>实验边界：源任务是 13 页液氮罐文档；结果是 1 条 episode 和 2 条 actor-level reflection。</a:t>
+              <a:t>实验边界：AgentCore Memory System 使用内置 EPISODIC 处理源 session，生成 1 条 episode 和 2 条 actor reflections。</a:t>
             </a:r>
             <a:endParaRPr lang="en-US" sz="2000" dirty="0"/>
           </a:p>

</xml_diff>